<commit_message>
docs: finalize deployment evidence and editable reports
</commit_message>
<xml_diff>
--- a/report/dist/property_shot_ai_technical_report.pptx
+++ b/report/dist/property_shot_ai_technical_report.pptx
@@ -2,31 +2,31 @@
 <file path=ppt/presentation.xml><?xml version="1.0" encoding="utf-8"?>
 <p:presentation xmlns:p="http://schemas.openxmlformats.org/presentationml/2006/main">
   <p:sldMasterIdLst>
-    <p:sldMasterId xmlns:r="http://schemas.openxmlformats.org/officeDocument/2006/relationships" id="2147483648" r:id="R8e3a78da9dd847ab"/>
+    <p:sldMasterId xmlns:r="http://schemas.openxmlformats.org/officeDocument/2006/relationships" id="2147483648" r:id="R1eff0c8ab04140da"/>
   </p:sldMasterIdLst>
   <p:notesMasterIdLst>
-    <p:notesMasterId xmlns:r="http://schemas.openxmlformats.org/officeDocument/2006/relationships" r:id="R8643070254004183"/>
+    <p:notesMasterId xmlns:r="http://schemas.openxmlformats.org/officeDocument/2006/relationships" r:id="R9575554401c14264"/>
   </p:notesMasterIdLst>
   <p:sldIdLst>
-    <p:sldId xmlns:r="http://schemas.openxmlformats.org/officeDocument/2006/relationships" id="256" r:id="Rbb12f7bf25214035"/>
-    <p:sldId xmlns:r="http://schemas.openxmlformats.org/officeDocument/2006/relationships" id="257" r:id="R7033d0070e4d4084"/>
-    <p:sldId xmlns:r="http://schemas.openxmlformats.org/officeDocument/2006/relationships" id="258" r:id="R595ed2e0fb5a473c"/>
-    <p:sldId xmlns:r="http://schemas.openxmlformats.org/officeDocument/2006/relationships" id="259" r:id="R24e4ffaed78d40b5"/>
-    <p:sldId xmlns:r="http://schemas.openxmlformats.org/officeDocument/2006/relationships" id="260" r:id="R09c5007941f74be0"/>
-    <p:sldId xmlns:r="http://schemas.openxmlformats.org/officeDocument/2006/relationships" id="261" r:id="Rfb34df4317314b34"/>
-    <p:sldId xmlns:r="http://schemas.openxmlformats.org/officeDocument/2006/relationships" id="262" r:id="Rc48d09fee8a84fea"/>
-    <p:sldId xmlns:r="http://schemas.openxmlformats.org/officeDocument/2006/relationships" id="263" r:id="Rcccc0526450c4b5d"/>
-    <p:sldId xmlns:r="http://schemas.openxmlformats.org/officeDocument/2006/relationships" id="264" r:id="Re7d34861cd0548f1"/>
-    <p:sldId xmlns:r="http://schemas.openxmlformats.org/officeDocument/2006/relationships" id="265" r:id="R19dc3251b64a4b1c"/>
-    <p:sldId xmlns:r="http://schemas.openxmlformats.org/officeDocument/2006/relationships" id="266" r:id="R2515687388ee4484"/>
-    <p:sldId xmlns:r="http://schemas.openxmlformats.org/officeDocument/2006/relationships" id="267" r:id="Re316a8e5b6cf4034"/>
-    <p:sldId xmlns:r="http://schemas.openxmlformats.org/officeDocument/2006/relationships" id="268" r:id="Rd2878f6c99164995"/>
-    <p:sldId xmlns:r="http://schemas.openxmlformats.org/officeDocument/2006/relationships" id="269" r:id="R119b0b4aa0ce487c"/>
-    <p:sldId xmlns:r="http://schemas.openxmlformats.org/officeDocument/2006/relationships" id="270" r:id="R37788a9d308b4bf5"/>
-    <p:sldId xmlns:r="http://schemas.openxmlformats.org/officeDocument/2006/relationships" id="271" r:id="Re7dc4ee6f4dd4fbe"/>
-    <p:sldId xmlns:r="http://schemas.openxmlformats.org/officeDocument/2006/relationships" id="272" r:id="R2f69d8e685434113"/>
-    <p:sldId xmlns:r="http://schemas.openxmlformats.org/officeDocument/2006/relationships" id="273" r:id="R471727c2b00a41b6"/>
-    <p:sldId xmlns:r="http://schemas.openxmlformats.org/officeDocument/2006/relationships" id="274" r:id="R7175e5e1cbc843bc"/>
+    <p:sldId xmlns:r="http://schemas.openxmlformats.org/officeDocument/2006/relationships" id="256" r:id="R35ad849bd39f4e33"/>
+    <p:sldId xmlns:r="http://schemas.openxmlformats.org/officeDocument/2006/relationships" id="257" r:id="R4e834c23efd94e80"/>
+    <p:sldId xmlns:r="http://schemas.openxmlformats.org/officeDocument/2006/relationships" id="258" r:id="R9e2b3a0cfd994fde"/>
+    <p:sldId xmlns:r="http://schemas.openxmlformats.org/officeDocument/2006/relationships" id="259" r:id="R3c33e2b672754ae4"/>
+    <p:sldId xmlns:r="http://schemas.openxmlformats.org/officeDocument/2006/relationships" id="260" r:id="R1f0b7c2286bb4112"/>
+    <p:sldId xmlns:r="http://schemas.openxmlformats.org/officeDocument/2006/relationships" id="261" r:id="R1f8fe5b31a544971"/>
+    <p:sldId xmlns:r="http://schemas.openxmlformats.org/officeDocument/2006/relationships" id="262" r:id="R335d52078f4a475d"/>
+    <p:sldId xmlns:r="http://schemas.openxmlformats.org/officeDocument/2006/relationships" id="263" r:id="Rdcfa546cbf934501"/>
+    <p:sldId xmlns:r="http://schemas.openxmlformats.org/officeDocument/2006/relationships" id="264" r:id="R6e6fc942f636469e"/>
+    <p:sldId xmlns:r="http://schemas.openxmlformats.org/officeDocument/2006/relationships" id="265" r:id="Rd47c1505db8343fb"/>
+    <p:sldId xmlns:r="http://schemas.openxmlformats.org/officeDocument/2006/relationships" id="266" r:id="Rfa5d712f86bd4fc9"/>
+    <p:sldId xmlns:r="http://schemas.openxmlformats.org/officeDocument/2006/relationships" id="267" r:id="Rde5caf04dc684a6b"/>
+    <p:sldId xmlns:r="http://schemas.openxmlformats.org/officeDocument/2006/relationships" id="268" r:id="R373ddafc5a824019"/>
+    <p:sldId xmlns:r="http://schemas.openxmlformats.org/officeDocument/2006/relationships" id="269" r:id="R32095e833ce44a78"/>
+    <p:sldId xmlns:r="http://schemas.openxmlformats.org/officeDocument/2006/relationships" id="270" r:id="R470666de1aa04c8f"/>
+    <p:sldId xmlns:r="http://schemas.openxmlformats.org/officeDocument/2006/relationships" id="271" r:id="R80fc4cc6d5494200"/>
+    <p:sldId xmlns:r="http://schemas.openxmlformats.org/officeDocument/2006/relationships" id="272" r:id="R97dbae29dcd64065"/>
+    <p:sldId xmlns:r="http://schemas.openxmlformats.org/officeDocument/2006/relationships" id="273" r:id="R4475a5cd034541d5"/>
+    <p:sldId xmlns:r="http://schemas.openxmlformats.org/officeDocument/2006/relationships" id="274" r:id="Rf7e16f50340e4664"/>
   </p:sldIdLst>
   <p:sldSz cx="7562850" cy="10696575"/>
   <p:notesSz cx="6858000" cy="9144000"/>
@@ -1300,7 +1300,7 @@
           </a:p>
           <a:p xmlns:a="http://schemas.openxmlformats.org/drawingml/2006/main">
             <a:r>
-              <a:t>- https://github.com/good5229/Property_shot/actions/runs/31315470165</a:t>
+              <a:t>- https://github.com/good5229/Property_shot/actions/runs/31373105599</a:t>
             </a:r>
           </a:p>
         </p:txBody>
@@ -1978,7 +1978,7 @@
   </p:cSld>
   <p:clrMap bg1="lt1" tx1="dk1" bg2="lt2" tx2="dk2" accent1="accent1" accent2="accent2" accent3="accent3" accent4="accent4" accent5="accent5" accent6="accent6" hlink="hlink" folHlink="folHlink"/>
   <p:sldLayoutIdLst>
-    <p:sldLayoutId xmlns:r="http://schemas.openxmlformats.org/officeDocument/2006/relationships" id="2147483649" r:id="R1c32db9a839442e4"/>
+    <p:sldLayoutId xmlns:r="http://schemas.openxmlformats.org/officeDocument/2006/relationships" id="2147483649" r:id="R76a3bd2f8f694f7e"/>
   </p:sldLayoutIdLst>
   <p:txStyles>
     <p:titleStyle>
@@ -2529,7 +2529,7 @@
           <p:cNvPr id="9" name="cover-accent">
             <a:extLst xmlns:a="http://schemas.openxmlformats.org/drawingml/2006/main">
               <a:ext uri="{FF2B5EF4-FFF2-40B4-BE49-F238E27FC236}">
-                <a16:creationId xmlns:a16="http://schemas.microsoft.com/office/drawing/2014/main" id="{C02F6F97-0D8D-4BC6-9A76-66E62975DA0C}"/>
+                <a16:creationId xmlns:a16="http://schemas.microsoft.com/office/drawing/2014/main" id="{2E0D472D-60FD-4D2F-86B9-112F2382A06F}"/>
               </a:ext>
             </a:extLst>
           </p:cNvPr>
@@ -2560,7 +2560,7 @@
           <p:cNvPr id="2" name="cover-kicker">
             <a:extLst xmlns:a="http://schemas.openxmlformats.org/drawingml/2006/main">
               <a:ext uri="{FF2B5EF4-FFF2-40B4-BE49-F238E27FC236}">
-                <a16:creationId xmlns:a16="http://schemas.microsoft.com/office/drawing/2014/main" id="{F995FE92-7B9B-4789-A168-CA8BA092CC34}"/>
+                <a16:creationId xmlns:a16="http://schemas.microsoft.com/office/drawing/2014/main" id="{03FC6C9F-CCFA-42E4-9F25-75F2BCE43A84}"/>
               </a:ext>
             </a:extLst>
           </p:cNvPr>
@@ -2622,7 +2622,7 @@
           <p:cNvPr id="3" name="cover-title">
             <a:extLst xmlns:a="http://schemas.openxmlformats.org/drawingml/2006/main">
               <a:ext uri="{FF2B5EF4-FFF2-40B4-BE49-F238E27FC236}">
-                <a16:creationId xmlns:a16="http://schemas.microsoft.com/office/drawing/2014/main" id="{C2E9A8CF-90DB-462C-A5FC-320445632700}"/>
+                <a16:creationId xmlns:a16="http://schemas.microsoft.com/office/drawing/2014/main" id="{AF7CB933-7834-407E-9B61-89E7F201B3B8}"/>
               </a:ext>
             </a:extLst>
           </p:cNvPr>
@@ -2684,7 +2684,7 @@
           <p:cNvPr id="4" name="cover-subtitle">
             <a:extLst xmlns:a="http://schemas.openxmlformats.org/drawingml/2006/main">
               <a:ext uri="{FF2B5EF4-FFF2-40B4-BE49-F238E27FC236}">
-                <a16:creationId xmlns:a16="http://schemas.microsoft.com/office/drawing/2014/main" id="{07798C27-8054-40E6-9BEC-B01BB772B067}"/>
+                <a16:creationId xmlns:a16="http://schemas.microsoft.com/office/drawing/2014/main" id="{947D58C1-01BA-4F84-BDE2-F51B61F65FEE}"/>
               </a:ext>
             </a:extLst>
           </p:cNvPr>
@@ -2746,7 +2746,7 @@
           <p:cNvPr id="5" name="cover-rule">
             <a:extLst xmlns:a="http://schemas.openxmlformats.org/drawingml/2006/main">
               <a:ext uri="{FF2B5EF4-FFF2-40B4-BE49-F238E27FC236}">
-                <a16:creationId xmlns:a16="http://schemas.microsoft.com/office/drawing/2014/main" id="{3B8222E9-DD57-48EC-99FD-F771CCE74BF7}"/>
+                <a16:creationId xmlns:a16="http://schemas.microsoft.com/office/drawing/2014/main" id="{778190C1-7E67-4F43-9190-E77DD1B313D2}"/>
               </a:ext>
             </a:extLst>
           </p:cNvPr>
@@ -2777,7 +2777,7 @@
           <p:cNvPr id="6" name="cover-description">
             <a:extLst xmlns:a="http://schemas.openxmlformats.org/drawingml/2006/main">
               <a:ext uri="{FF2B5EF4-FFF2-40B4-BE49-F238E27FC236}">
-                <a16:creationId xmlns:a16="http://schemas.microsoft.com/office/drawing/2014/main" id="{D0388013-7E41-417F-9740-ECD0637A4894}"/>
+                <a16:creationId xmlns:a16="http://schemas.microsoft.com/office/drawing/2014/main" id="{2EDC5B5F-A629-4015-92A2-16124AEC4E06}"/>
               </a:ext>
             </a:extLst>
           </p:cNvPr>
@@ -2839,7 +2839,7 @@
           <p:cNvPr id="7" name="cover-meta">
             <a:extLst xmlns:a="http://schemas.openxmlformats.org/drawingml/2006/main">
               <a:ext uri="{FF2B5EF4-FFF2-40B4-BE49-F238E27FC236}">
-                <a16:creationId xmlns:a16="http://schemas.microsoft.com/office/drawing/2014/main" id="{288E4E9C-F173-46FD-98DB-D6D406E0D90F}"/>
+                <a16:creationId xmlns:a16="http://schemas.microsoft.com/office/drawing/2014/main" id="{5AE9B627-0EAF-4E71-97E5-2286E3958C2D}"/>
               </a:ext>
             </a:extLst>
           </p:cNvPr>
@@ -2928,7 +2928,7 @@
           <p:cNvPr id="8" name="cover-page">
             <a:extLst xmlns:a="http://schemas.openxmlformats.org/drawingml/2006/main">
               <a:ext uri="{FF2B5EF4-FFF2-40B4-BE49-F238E27FC236}">
-                <a16:creationId xmlns:a16="http://schemas.microsoft.com/office/drawing/2014/main" id="{0FE6F10B-42AB-475A-B7EA-4D12E365D50B}"/>
+                <a16:creationId xmlns:a16="http://schemas.microsoft.com/office/drawing/2014/main" id="{67FA1914-D95F-4E37-8143-DFA9C8F6B16C}"/>
               </a:ext>
             </a:extLst>
           </p:cNvPr>
@@ -2988,7 +2988,7 @@
     </p:spTree>
     <p:extLst>
       <p:ext uri="{BB962C8B-B14F-4D97-AF65-F5344CB8AC3E}">
-        <p14:creationId xmlns:p14="http://schemas.microsoft.com/office/powerpoint/2010/main" val="1944617848"/>
+        <p14:creationId xmlns:p14="http://schemas.microsoft.com/office/powerpoint/2010/main" val="1609960971"/>
       </p:ext>
     </p:extLst>
   </p:cSld>
@@ -3019,7 +3019,7 @@
           <p:cNvPr id="55" name="running-label">
             <a:extLst xmlns:a="http://schemas.openxmlformats.org/drawingml/2006/main">
               <a:ext uri="{FF2B5EF4-FFF2-40B4-BE49-F238E27FC236}">
-                <a16:creationId xmlns:a16="http://schemas.microsoft.com/office/drawing/2014/main" id="{B150F821-439B-40BC-A35D-873563FE51ED}"/>
+                <a16:creationId xmlns:a16="http://schemas.microsoft.com/office/drawing/2014/main" id="{1A9AD28D-D5B2-4CD4-9E36-4AD3865E8CC5}"/>
               </a:ext>
             </a:extLst>
           </p:cNvPr>
@@ -3081,7 +3081,7 @@
           <p:cNvPr id="2" name="page-number">
             <a:extLst xmlns:a="http://schemas.openxmlformats.org/drawingml/2006/main">
               <a:ext uri="{FF2B5EF4-FFF2-40B4-BE49-F238E27FC236}">
-                <a16:creationId xmlns:a16="http://schemas.microsoft.com/office/drawing/2014/main" id="{AC3C04FD-7137-41EC-B9E8-4763E90A71CE}"/>
+                <a16:creationId xmlns:a16="http://schemas.microsoft.com/office/drawing/2014/main" id="{05D0053A-4BF7-418D-868C-BC8C776F2C26}"/>
               </a:ext>
             </a:extLst>
           </p:cNvPr>
@@ -3143,7 +3143,7 @@
           <p:cNvPr id="3" name="header-rule">
             <a:extLst xmlns:a="http://schemas.openxmlformats.org/drawingml/2006/main">
               <a:ext uri="{FF2B5EF4-FFF2-40B4-BE49-F238E27FC236}">
-                <a16:creationId xmlns:a16="http://schemas.microsoft.com/office/drawing/2014/main" id="{76D8F72D-1168-4DD2-92AA-5574388E3F39}"/>
+                <a16:creationId xmlns:a16="http://schemas.microsoft.com/office/drawing/2014/main" id="{9D4A957D-68BC-4CA0-AD84-A7040C6C6980}"/>
               </a:ext>
             </a:extLst>
           </p:cNvPr>
@@ -3174,7 +3174,7 @@
           <p:cNvPr id="4" name="slide-title">
             <a:extLst xmlns:a="http://schemas.openxmlformats.org/drawingml/2006/main">
               <a:ext uri="{FF2B5EF4-FFF2-40B4-BE49-F238E27FC236}">
-                <a16:creationId xmlns:a16="http://schemas.microsoft.com/office/drawing/2014/main" id="{00FCC38E-58E3-4D8F-8AB2-995F26EFD0C3}"/>
+                <a16:creationId xmlns:a16="http://schemas.microsoft.com/office/drawing/2014/main" id="{3A07A962-9B19-4793-9B1C-5BA7C2759572}"/>
               </a:ext>
             </a:extLst>
           </p:cNvPr>
@@ -3236,7 +3236,7 @@
           <p:cNvPr id="5" name="table-cell-140-0-0">
             <a:extLst xmlns:a="http://schemas.openxmlformats.org/drawingml/2006/main">
               <a:ext uri="{FF2B5EF4-FFF2-40B4-BE49-F238E27FC236}">
-                <a16:creationId xmlns:a16="http://schemas.microsoft.com/office/drawing/2014/main" id="{BE866893-7B4A-449A-AC7F-A8E19C30C090}"/>
+                <a16:creationId xmlns:a16="http://schemas.microsoft.com/office/drawing/2014/main" id="{C530E048-8DD7-4A14-824F-E81F994DB98C}"/>
               </a:ext>
             </a:extLst>
           </p:cNvPr>
@@ -3269,7 +3269,7 @@
           <p:cNvPr id="6" name="table-text-140-0-0">
             <a:extLst xmlns:a="http://schemas.openxmlformats.org/drawingml/2006/main">
               <a:ext uri="{FF2B5EF4-FFF2-40B4-BE49-F238E27FC236}">
-                <a16:creationId xmlns:a16="http://schemas.microsoft.com/office/drawing/2014/main" id="{D73B7BA0-5916-4985-A930-77B9FF1D8065}"/>
+                <a16:creationId xmlns:a16="http://schemas.microsoft.com/office/drawing/2014/main" id="{1B682B23-3049-413E-8BA3-DB80912CC943}"/>
               </a:ext>
             </a:extLst>
           </p:cNvPr>
@@ -3331,7 +3331,7 @@
           <p:cNvPr id="7" name="table-cell-140-0-1">
             <a:extLst xmlns:a="http://schemas.openxmlformats.org/drawingml/2006/main">
               <a:ext uri="{FF2B5EF4-FFF2-40B4-BE49-F238E27FC236}">
-                <a16:creationId xmlns:a16="http://schemas.microsoft.com/office/drawing/2014/main" id="{7610158A-30EB-4BD3-A3A1-9B3CC266ACC1}"/>
+                <a16:creationId xmlns:a16="http://schemas.microsoft.com/office/drawing/2014/main" id="{546E67AC-2E75-442A-9B96-6F005A3686B9}"/>
               </a:ext>
             </a:extLst>
           </p:cNvPr>
@@ -3364,7 +3364,7 @@
           <p:cNvPr id="8" name="table-text-140-0-1">
             <a:extLst xmlns:a="http://schemas.openxmlformats.org/drawingml/2006/main">
               <a:ext uri="{FF2B5EF4-FFF2-40B4-BE49-F238E27FC236}">
-                <a16:creationId xmlns:a16="http://schemas.microsoft.com/office/drawing/2014/main" id="{5F9DA99F-5105-4777-9592-23A1A6147BE2}"/>
+                <a16:creationId xmlns:a16="http://schemas.microsoft.com/office/drawing/2014/main" id="{C2F25A88-08A0-44FD-8D97-F741FEABFAD9}"/>
               </a:ext>
             </a:extLst>
           </p:cNvPr>
@@ -3426,7 +3426,7 @@
           <p:cNvPr id="9" name="table-cell-140-1-0">
             <a:extLst xmlns:a="http://schemas.openxmlformats.org/drawingml/2006/main">
               <a:ext uri="{FF2B5EF4-FFF2-40B4-BE49-F238E27FC236}">
-                <a16:creationId xmlns:a16="http://schemas.microsoft.com/office/drawing/2014/main" id="{04631DD4-D2F2-463D-9655-8FA0B52685B1}"/>
+                <a16:creationId xmlns:a16="http://schemas.microsoft.com/office/drawing/2014/main" id="{81C3180C-8A0B-4E91-BE01-201BA84E1ADB}"/>
               </a:ext>
             </a:extLst>
           </p:cNvPr>
@@ -3459,7 +3459,7 @@
           <p:cNvPr id="10" name="table-text-140-1-0">
             <a:extLst xmlns:a="http://schemas.openxmlformats.org/drawingml/2006/main">
               <a:ext uri="{FF2B5EF4-FFF2-40B4-BE49-F238E27FC236}">
-                <a16:creationId xmlns:a16="http://schemas.microsoft.com/office/drawing/2014/main" id="{52834E67-CCDA-4690-8C99-2DEEB9B6DCA8}"/>
+                <a16:creationId xmlns:a16="http://schemas.microsoft.com/office/drawing/2014/main" id="{7E5B7805-F27E-4973-B2C2-64FB3AB05A81}"/>
               </a:ext>
             </a:extLst>
           </p:cNvPr>
@@ -3521,7 +3521,7 @@
           <p:cNvPr id="11" name="table-cell-140-1-1">
             <a:extLst xmlns:a="http://schemas.openxmlformats.org/drawingml/2006/main">
               <a:ext uri="{FF2B5EF4-FFF2-40B4-BE49-F238E27FC236}">
-                <a16:creationId xmlns:a16="http://schemas.microsoft.com/office/drawing/2014/main" id="{6F1FCFC6-BFE3-4D8C-92FC-C1F3038DE165}"/>
+                <a16:creationId xmlns:a16="http://schemas.microsoft.com/office/drawing/2014/main" id="{9ADE5F82-C556-423C-815B-7897B6C05F18}"/>
               </a:ext>
             </a:extLst>
           </p:cNvPr>
@@ -3554,7 +3554,7 @@
           <p:cNvPr id="12" name="table-text-140-1-1">
             <a:extLst xmlns:a="http://schemas.openxmlformats.org/drawingml/2006/main">
               <a:ext uri="{FF2B5EF4-FFF2-40B4-BE49-F238E27FC236}">
-                <a16:creationId xmlns:a16="http://schemas.microsoft.com/office/drawing/2014/main" id="{6E7D88AE-20A2-485D-B6E8-1BE9547BE575}"/>
+                <a16:creationId xmlns:a16="http://schemas.microsoft.com/office/drawing/2014/main" id="{470CF015-3742-4BB7-A41C-F1959CFE6A85}"/>
               </a:ext>
             </a:extLst>
           </p:cNvPr>
@@ -3616,7 +3616,7 @@
           <p:cNvPr id="13" name="table-cell-140-2-0">
             <a:extLst xmlns:a="http://schemas.openxmlformats.org/drawingml/2006/main">
               <a:ext uri="{FF2B5EF4-FFF2-40B4-BE49-F238E27FC236}">
-                <a16:creationId xmlns:a16="http://schemas.microsoft.com/office/drawing/2014/main" id="{DFB3D07C-606B-4FB3-A4D2-76C440CB8FC2}"/>
+                <a16:creationId xmlns:a16="http://schemas.microsoft.com/office/drawing/2014/main" id="{E54EEC50-F323-431B-B0CF-F6373C651AEA}"/>
               </a:ext>
             </a:extLst>
           </p:cNvPr>
@@ -3649,7 +3649,7 @@
           <p:cNvPr id="14" name="table-text-140-2-0">
             <a:extLst xmlns:a="http://schemas.openxmlformats.org/drawingml/2006/main">
               <a:ext uri="{FF2B5EF4-FFF2-40B4-BE49-F238E27FC236}">
-                <a16:creationId xmlns:a16="http://schemas.microsoft.com/office/drawing/2014/main" id="{613396C9-7B56-4D23-8162-EAE362DCD76A}"/>
+                <a16:creationId xmlns:a16="http://schemas.microsoft.com/office/drawing/2014/main" id="{912E465D-655F-4021-96EA-F0D7D96411D2}"/>
               </a:ext>
             </a:extLst>
           </p:cNvPr>
@@ -3711,7 +3711,7 @@
           <p:cNvPr id="15" name="table-cell-140-2-1">
             <a:extLst xmlns:a="http://schemas.openxmlformats.org/drawingml/2006/main">
               <a:ext uri="{FF2B5EF4-FFF2-40B4-BE49-F238E27FC236}">
-                <a16:creationId xmlns:a16="http://schemas.microsoft.com/office/drawing/2014/main" id="{ACB36727-CF35-4084-8F82-2A9676676DB2}"/>
+                <a16:creationId xmlns:a16="http://schemas.microsoft.com/office/drawing/2014/main" id="{C99FBB09-6E5E-47CC-888F-70A63417007B}"/>
               </a:ext>
             </a:extLst>
           </p:cNvPr>
@@ -3744,7 +3744,7 @@
           <p:cNvPr id="16" name="table-text-140-2-1">
             <a:extLst xmlns:a="http://schemas.openxmlformats.org/drawingml/2006/main">
               <a:ext uri="{FF2B5EF4-FFF2-40B4-BE49-F238E27FC236}">
-                <a16:creationId xmlns:a16="http://schemas.microsoft.com/office/drawing/2014/main" id="{C7366D67-6E52-496C-A4FA-638B1239D89F}"/>
+                <a16:creationId xmlns:a16="http://schemas.microsoft.com/office/drawing/2014/main" id="{2E4909DF-CBCD-490A-A192-0A1DFF2DE81C}"/>
               </a:ext>
             </a:extLst>
           </p:cNvPr>
@@ -3806,7 +3806,7 @@
           <p:cNvPr id="17" name="table-cell-140-3-0">
             <a:extLst xmlns:a="http://schemas.openxmlformats.org/drawingml/2006/main">
               <a:ext uri="{FF2B5EF4-FFF2-40B4-BE49-F238E27FC236}">
-                <a16:creationId xmlns:a16="http://schemas.microsoft.com/office/drawing/2014/main" id="{75D47656-80BA-43F9-9E63-7F3333E56B76}"/>
+                <a16:creationId xmlns:a16="http://schemas.microsoft.com/office/drawing/2014/main" id="{9B303598-C526-4E33-82DC-3AC5FB1BBDEE}"/>
               </a:ext>
             </a:extLst>
           </p:cNvPr>
@@ -3839,7 +3839,7 @@
           <p:cNvPr id="18" name="table-text-140-3-0">
             <a:extLst xmlns:a="http://schemas.openxmlformats.org/drawingml/2006/main">
               <a:ext uri="{FF2B5EF4-FFF2-40B4-BE49-F238E27FC236}">
-                <a16:creationId xmlns:a16="http://schemas.microsoft.com/office/drawing/2014/main" id="{B9DEED2D-85AB-439F-8914-525E1D21B27B}"/>
+                <a16:creationId xmlns:a16="http://schemas.microsoft.com/office/drawing/2014/main" id="{CC163E26-F5F5-42E8-8560-F5C4C1AC940B}"/>
               </a:ext>
             </a:extLst>
           </p:cNvPr>
@@ -3901,7 +3901,7 @@
           <p:cNvPr id="19" name="table-cell-140-3-1">
             <a:extLst xmlns:a="http://schemas.openxmlformats.org/drawingml/2006/main">
               <a:ext uri="{FF2B5EF4-FFF2-40B4-BE49-F238E27FC236}">
-                <a16:creationId xmlns:a16="http://schemas.microsoft.com/office/drawing/2014/main" id="{D41970DA-2935-451F-868A-990CD3156A08}"/>
+                <a16:creationId xmlns:a16="http://schemas.microsoft.com/office/drawing/2014/main" id="{0FAA89E9-EE49-4872-B83F-2C2E7A66C606}"/>
               </a:ext>
             </a:extLst>
           </p:cNvPr>
@@ -3934,7 +3934,7 @@
           <p:cNvPr id="20" name="table-text-140-3-1">
             <a:extLst xmlns:a="http://schemas.openxmlformats.org/drawingml/2006/main">
               <a:ext uri="{FF2B5EF4-FFF2-40B4-BE49-F238E27FC236}">
-                <a16:creationId xmlns:a16="http://schemas.microsoft.com/office/drawing/2014/main" id="{410335A6-C545-40E0-8729-52EA3E2EB07A}"/>
+                <a16:creationId xmlns:a16="http://schemas.microsoft.com/office/drawing/2014/main" id="{FC0A04A0-A473-4668-898E-441806FDD317}"/>
               </a:ext>
             </a:extLst>
           </p:cNvPr>
@@ -3996,7 +3996,7 @@
           <p:cNvPr id="21" name="table-cell-140-4-0">
             <a:extLst xmlns:a="http://schemas.openxmlformats.org/drawingml/2006/main">
               <a:ext uri="{FF2B5EF4-FFF2-40B4-BE49-F238E27FC236}">
-                <a16:creationId xmlns:a16="http://schemas.microsoft.com/office/drawing/2014/main" id="{78BC8328-8A3D-4230-BF83-A1DFC4B30B04}"/>
+                <a16:creationId xmlns:a16="http://schemas.microsoft.com/office/drawing/2014/main" id="{BD25E08D-8F98-49CC-ABFC-3546785B16C2}"/>
               </a:ext>
             </a:extLst>
           </p:cNvPr>
@@ -4029,7 +4029,7 @@
           <p:cNvPr id="22" name="table-text-140-4-0">
             <a:extLst xmlns:a="http://schemas.openxmlformats.org/drawingml/2006/main">
               <a:ext uri="{FF2B5EF4-FFF2-40B4-BE49-F238E27FC236}">
-                <a16:creationId xmlns:a16="http://schemas.microsoft.com/office/drawing/2014/main" id="{0892851F-C22C-415B-A849-F0AF6A3E835E}"/>
+                <a16:creationId xmlns:a16="http://schemas.microsoft.com/office/drawing/2014/main" id="{51412944-6618-4A4D-810F-585DDFE7FE20}"/>
               </a:ext>
             </a:extLst>
           </p:cNvPr>
@@ -4091,7 +4091,7 @@
           <p:cNvPr id="23" name="table-cell-140-4-1">
             <a:extLst xmlns:a="http://schemas.openxmlformats.org/drawingml/2006/main">
               <a:ext uri="{FF2B5EF4-FFF2-40B4-BE49-F238E27FC236}">
-                <a16:creationId xmlns:a16="http://schemas.microsoft.com/office/drawing/2014/main" id="{8E73FAF8-5B14-4944-A886-91AEA4C6E96F}"/>
+                <a16:creationId xmlns:a16="http://schemas.microsoft.com/office/drawing/2014/main" id="{13C58BF8-B881-4E89-9FF1-E8B55ACAEFF1}"/>
               </a:ext>
             </a:extLst>
           </p:cNvPr>
@@ -4124,7 +4124,7 @@
           <p:cNvPr id="24" name="table-text-140-4-1">
             <a:extLst xmlns:a="http://schemas.openxmlformats.org/drawingml/2006/main">
               <a:ext uri="{FF2B5EF4-FFF2-40B4-BE49-F238E27FC236}">
-                <a16:creationId xmlns:a16="http://schemas.microsoft.com/office/drawing/2014/main" id="{C4E0EA23-8071-4BF7-AA76-FE450C00F0F0}"/>
+                <a16:creationId xmlns:a16="http://schemas.microsoft.com/office/drawing/2014/main" id="{B6887214-9A64-42E4-9CC2-3211B89D6F01}"/>
               </a:ext>
             </a:extLst>
           </p:cNvPr>
@@ -4149,7 +4149,7 @@
         </p:spPr>
         <p:txBody>
           <a:bodyPr xmlns:a="http://schemas.openxmlformats.org/drawingml/2006/main" lIns="0" tIns="0" rIns="0" bIns="0" anchor="t">
-            <a:normAutofit fontScale="87439"/>
+            <a:normAutofit fontScale="81625"/>
           </a:bodyPr>
           <a:lstStyle xmlns:a="http://schemas.openxmlformats.org/drawingml/2006/main"/>
           <a:p xmlns:a="http://schemas.openxmlformats.org/drawingml/2006/main">
@@ -4186,7 +4186,7 @@
           <p:cNvPr id="25" name="table-cell-140-5-0">
             <a:extLst xmlns:a="http://schemas.openxmlformats.org/drawingml/2006/main">
               <a:ext uri="{FF2B5EF4-FFF2-40B4-BE49-F238E27FC236}">
-                <a16:creationId xmlns:a16="http://schemas.microsoft.com/office/drawing/2014/main" id="{EC35CD7C-3D99-43C4-92BF-5908D03579FC}"/>
+                <a16:creationId xmlns:a16="http://schemas.microsoft.com/office/drawing/2014/main" id="{6A24229C-6448-4BDB-A364-C003D127CD4C}"/>
               </a:ext>
             </a:extLst>
           </p:cNvPr>
@@ -4219,7 +4219,7 @@
           <p:cNvPr id="26" name="table-text-140-5-0">
             <a:extLst xmlns:a="http://schemas.openxmlformats.org/drawingml/2006/main">
               <a:ext uri="{FF2B5EF4-FFF2-40B4-BE49-F238E27FC236}">
-                <a16:creationId xmlns:a16="http://schemas.microsoft.com/office/drawing/2014/main" id="{67704026-5680-41D5-95D1-F9CC6A6A8B11}"/>
+                <a16:creationId xmlns:a16="http://schemas.microsoft.com/office/drawing/2014/main" id="{5A50B733-C25A-41E8-A11B-045A633142D5}"/>
               </a:ext>
             </a:extLst>
           </p:cNvPr>
@@ -4281,7 +4281,7 @@
           <p:cNvPr id="27" name="table-cell-140-5-1">
             <a:extLst xmlns:a="http://schemas.openxmlformats.org/drawingml/2006/main">
               <a:ext uri="{FF2B5EF4-FFF2-40B4-BE49-F238E27FC236}">
-                <a16:creationId xmlns:a16="http://schemas.microsoft.com/office/drawing/2014/main" id="{B0C98211-709E-4FF4-BCA5-7168A45F6F9D}"/>
+                <a16:creationId xmlns:a16="http://schemas.microsoft.com/office/drawing/2014/main" id="{8A60A336-C491-4516-BD3D-D87B2B7D59BD}"/>
               </a:ext>
             </a:extLst>
           </p:cNvPr>
@@ -4314,7 +4314,7 @@
           <p:cNvPr id="28" name="table-text-140-5-1">
             <a:extLst xmlns:a="http://schemas.openxmlformats.org/drawingml/2006/main">
               <a:ext uri="{FF2B5EF4-FFF2-40B4-BE49-F238E27FC236}">
-                <a16:creationId xmlns:a16="http://schemas.microsoft.com/office/drawing/2014/main" id="{021272D0-B226-4FD2-B59F-F09D9B51A833}"/>
+                <a16:creationId xmlns:a16="http://schemas.microsoft.com/office/drawing/2014/main" id="{0CA602FB-EA49-49D9-8256-695AA280F011}"/>
               </a:ext>
             </a:extLst>
           </p:cNvPr>
@@ -4376,7 +4376,7 @@
           <p:cNvPr id="29" name="table-cell-140-6-0">
             <a:extLst xmlns:a="http://schemas.openxmlformats.org/drawingml/2006/main">
               <a:ext uri="{FF2B5EF4-FFF2-40B4-BE49-F238E27FC236}">
-                <a16:creationId xmlns:a16="http://schemas.microsoft.com/office/drawing/2014/main" id="{DE63D5DA-0013-44A7-8769-A5135817B1AD}"/>
+                <a16:creationId xmlns:a16="http://schemas.microsoft.com/office/drawing/2014/main" id="{BBB2F96D-AD0C-4BC5-AF6E-3499229E0E35}"/>
               </a:ext>
             </a:extLst>
           </p:cNvPr>
@@ -4409,7 +4409,7 @@
           <p:cNvPr id="30" name="table-text-140-6-0">
             <a:extLst xmlns:a="http://schemas.openxmlformats.org/drawingml/2006/main">
               <a:ext uri="{FF2B5EF4-FFF2-40B4-BE49-F238E27FC236}">
-                <a16:creationId xmlns:a16="http://schemas.microsoft.com/office/drawing/2014/main" id="{2C85EEDF-FB0A-4EA0-A91C-01AC59BFC491}"/>
+                <a16:creationId xmlns:a16="http://schemas.microsoft.com/office/drawing/2014/main" id="{12A3A042-45F4-4A75-A27C-BFD41911262E}"/>
               </a:ext>
             </a:extLst>
           </p:cNvPr>
@@ -4471,7 +4471,7 @@
           <p:cNvPr id="31" name="table-cell-140-6-1">
             <a:extLst xmlns:a="http://schemas.openxmlformats.org/drawingml/2006/main">
               <a:ext uri="{FF2B5EF4-FFF2-40B4-BE49-F238E27FC236}">
-                <a16:creationId xmlns:a16="http://schemas.microsoft.com/office/drawing/2014/main" id="{B24125B0-906F-40B7-9F3D-BAA3CEDFD332}"/>
+                <a16:creationId xmlns:a16="http://schemas.microsoft.com/office/drawing/2014/main" id="{BFC215EA-6B5D-4305-909D-1024547B9769}"/>
               </a:ext>
             </a:extLst>
           </p:cNvPr>
@@ -4504,7 +4504,7 @@
           <p:cNvPr id="32" name="table-text-140-6-1">
             <a:extLst xmlns:a="http://schemas.openxmlformats.org/drawingml/2006/main">
               <a:ext uri="{FF2B5EF4-FFF2-40B4-BE49-F238E27FC236}">
-                <a16:creationId xmlns:a16="http://schemas.microsoft.com/office/drawing/2014/main" id="{4C87076F-1197-4F87-A141-226AD31569F5}"/>
+                <a16:creationId xmlns:a16="http://schemas.microsoft.com/office/drawing/2014/main" id="{FCE13271-4062-454D-8EAD-1FA0E370904B}"/>
               </a:ext>
             </a:extLst>
           </p:cNvPr>
@@ -4529,7 +4529,7 @@
         </p:spPr>
         <p:txBody>
           <a:bodyPr xmlns:a="http://schemas.openxmlformats.org/drawingml/2006/main" lIns="0" tIns="0" rIns="0" bIns="0" anchor="t">
-            <a:normAutofit fontScale="86632"/>
+            <a:normAutofit fontScale="85339"/>
           </a:bodyPr>
           <a:lstStyle xmlns:a="http://schemas.openxmlformats.org/drawingml/2006/main"/>
           <a:p xmlns:a="http://schemas.openxmlformats.org/drawingml/2006/main">
@@ -4566,7 +4566,7 @@
           <p:cNvPr id="33" name="table-cell-140-7-0">
             <a:extLst xmlns:a="http://schemas.openxmlformats.org/drawingml/2006/main">
               <a:ext uri="{FF2B5EF4-FFF2-40B4-BE49-F238E27FC236}">
-                <a16:creationId xmlns:a16="http://schemas.microsoft.com/office/drawing/2014/main" id="{D2C4144C-3341-4EEC-9FE2-0CE34D9C243B}"/>
+                <a16:creationId xmlns:a16="http://schemas.microsoft.com/office/drawing/2014/main" id="{0D073A63-B365-433E-9994-BAD5DC93A97E}"/>
               </a:ext>
             </a:extLst>
           </p:cNvPr>
@@ -4599,7 +4599,7 @@
           <p:cNvPr id="34" name="table-text-140-7-0">
             <a:extLst xmlns:a="http://schemas.openxmlformats.org/drawingml/2006/main">
               <a:ext uri="{FF2B5EF4-FFF2-40B4-BE49-F238E27FC236}">
-                <a16:creationId xmlns:a16="http://schemas.microsoft.com/office/drawing/2014/main" id="{551026A1-6933-436A-B7DD-0D9C78239CD2}"/>
+                <a16:creationId xmlns:a16="http://schemas.microsoft.com/office/drawing/2014/main" id="{DA5FA90D-F506-4E18-9D0A-A323F7D2027F}"/>
               </a:ext>
             </a:extLst>
           </p:cNvPr>
@@ -4661,7 +4661,7 @@
           <p:cNvPr id="35" name="table-cell-140-7-1">
             <a:extLst xmlns:a="http://schemas.openxmlformats.org/drawingml/2006/main">
               <a:ext uri="{FF2B5EF4-FFF2-40B4-BE49-F238E27FC236}">
-                <a16:creationId xmlns:a16="http://schemas.microsoft.com/office/drawing/2014/main" id="{2CC57728-693B-4697-B542-23A83338180B}"/>
+                <a16:creationId xmlns:a16="http://schemas.microsoft.com/office/drawing/2014/main" id="{C8C8F2CA-699C-42A0-938B-C6DAA6BC9D9C}"/>
               </a:ext>
             </a:extLst>
           </p:cNvPr>
@@ -4694,7 +4694,7 @@
           <p:cNvPr id="36" name="table-text-140-7-1">
             <a:extLst xmlns:a="http://schemas.openxmlformats.org/drawingml/2006/main">
               <a:ext uri="{FF2B5EF4-FFF2-40B4-BE49-F238E27FC236}">
-                <a16:creationId xmlns:a16="http://schemas.microsoft.com/office/drawing/2014/main" id="{60329524-EF18-440B-B769-CE511AEA1007}"/>
+                <a16:creationId xmlns:a16="http://schemas.microsoft.com/office/drawing/2014/main" id="{77C4960D-97F7-4277-9852-62833141246B}"/>
               </a:ext>
             </a:extLst>
           </p:cNvPr>
@@ -4756,7 +4756,7 @@
           <p:cNvPr id="37" name="table-cell-140-8-0">
             <a:extLst xmlns:a="http://schemas.openxmlformats.org/drawingml/2006/main">
               <a:ext uri="{FF2B5EF4-FFF2-40B4-BE49-F238E27FC236}">
-                <a16:creationId xmlns:a16="http://schemas.microsoft.com/office/drawing/2014/main" id="{FFD5713F-E291-4020-820F-ACEFB09BA164}"/>
+                <a16:creationId xmlns:a16="http://schemas.microsoft.com/office/drawing/2014/main" id="{6EDA3C89-84CD-44D4-A5CD-E760B05F9415}"/>
               </a:ext>
             </a:extLst>
           </p:cNvPr>
@@ -4789,7 +4789,7 @@
           <p:cNvPr id="38" name="table-text-140-8-0">
             <a:extLst xmlns:a="http://schemas.openxmlformats.org/drawingml/2006/main">
               <a:ext uri="{FF2B5EF4-FFF2-40B4-BE49-F238E27FC236}">
-                <a16:creationId xmlns:a16="http://schemas.microsoft.com/office/drawing/2014/main" id="{C7CC3F0E-8D3A-4AD1-BFDA-B9907C40CBBE}"/>
+                <a16:creationId xmlns:a16="http://schemas.microsoft.com/office/drawing/2014/main" id="{84EB5448-E009-48C4-BBA5-7E76753A55BD}"/>
               </a:ext>
             </a:extLst>
           </p:cNvPr>
@@ -4851,7 +4851,7 @@
           <p:cNvPr id="39" name="table-cell-140-8-1">
             <a:extLst xmlns:a="http://schemas.openxmlformats.org/drawingml/2006/main">
               <a:ext uri="{FF2B5EF4-FFF2-40B4-BE49-F238E27FC236}">
-                <a16:creationId xmlns:a16="http://schemas.microsoft.com/office/drawing/2014/main" id="{F90AF771-5D52-4731-9891-0B6736998F98}"/>
+                <a16:creationId xmlns:a16="http://schemas.microsoft.com/office/drawing/2014/main" id="{4B17B166-419C-4C06-B673-9E0DACF86DCB}"/>
               </a:ext>
             </a:extLst>
           </p:cNvPr>
@@ -4884,7 +4884,7 @@
           <p:cNvPr id="40" name="table-text-140-8-1">
             <a:extLst xmlns:a="http://schemas.openxmlformats.org/drawingml/2006/main">
               <a:ext uri="{FF2B5EF4-FFF2-40B4-BE49-F238E27FC236}">
-                <a16:creationId xmlns:a16="http://schemas.microsoft.com/office/drawing/2014/main" id="{F9C2756D-54DB-45C7-9639-9ED41102E1FD}"/>
+                <a16:creationId xmlns:a16="http://schemas.microsoft.com/office/drawing/2014/main" id="{F6C6122A-1158-4719-AD0C-A3799014328F}"/>
               </a:ext>
             </a:extLst>
           </p:cNvPr>
@@ -4946,7 +4946,7 @@
           <p:cNvPr id="41" name="table-cell-140-9-0">
             <a:extLst xmlns:a="http://schemas.openxmlformats.org/drawingml/2006/main">
               <a:ext uri="{FF2B5EF4-FFF2-40B4-BE49-F238E27FC236}">
-                <a16:creationId xmlns:a16="http://schemas.microsoft.com/office/drawing/2014/main" id="{C9C49059-80E5-4AFF-84A1-89F8D13CF967}"/>
+                <a16:creationId xmlns:a16="http://schemas.microsoft.com/office/drawing/2014/main" id="{88636FF7-75E6-47BC-AA03-3B0E3BEF20C9}"/>
               </a:ext>
             </a:extLst>
           </p:cNvPr>
@@ -4979,7 +4979,7 @@
           <p:cNvPr id="42" name="table-text-140-9-0">
             <a:extLst xmlns:a="http://schemas.openxmlformats.org/drawingml/2006/main">
               <a:ext uri="{FF2B5EF4-FFF2-40B4-BE49-F238E27FC236}">
-                <a16:creationId xmlns:a16="http://schemas.microsoft.com/office/drawing/2014/main" id="{23E53FE7-9C1D-43C6-BD4E-DC5E2426D635}"/>
+                <a16:creationId xmlns:a16="http://schemas.microsoft.com/office/drawing/2014/main" id="{1F3BCA62-A16B-456D-83C0-2201C5553E18}"/>
               </a:ext>
             </a:extLst>
           </p:cNvPr>
@@ -5041,7 +5041,7 @@
           <p:cNvPr id="43" name="table-cell-140-9-1">
             <a:extLst xmlns:a="http://schemas.openxmlformats.org/drawingml/2006/main">
               <a:ext uri="{FF2B5EF4-FFF2-40B4-BE49-F238E27FC236}">
-                <a16:creationId xmlns:a16="http://schemas.microsoft.com/office/drawing/2014/main" id="{751D45F1-C02A-4B13-B736-BA29EAA539EE}"/>
+                <a16:creationId xmlns:a16="http://schemas.microsoft.com/office/drawing/2014/main" id="{8635D890-E89B-49F7-9C0B-7BE255235D15}"/>
               </a:ext>
             </a:extLst>
           </p:cNvPr>
@@ -5074,7 +5074,7 @@
           <p:cNvPr id="44" name="table-text-140-9-1">
             <a:extLst xmlns:a="http://schemas.openxmlformats.org/drawingml/2006/main">
               <a:ext uri="{FF2B5EF4-FFF2-40B4-BE49-F238E27FC236}">
-                <a16:creationId xmlns:a16="http://schemas.microsoft.com/office/drawing/2014/main" id="{09862116-D319-4723-9E07-9BF177FB7487}"/>
+                <a16:creationId xmlns:a16="http://schemas.microsoft.com/office/drawing/2014/main" id="{3E5A6E42-69EE-490C-8700-4C01A8787794}"/>
               </a:ext>
             </a:extLst>
           </p:cNvPr>
@@ -5126,7 +5126,7 @@
                 <a:ea typeface="NanumGothic"/>
                 <a:cs typeface="NanumGothic"/>
               </a:rPr>
-              <a:t>Web release 통과(main.dart.js 3,709,343바이트, SHA-256 cb95f03f...cc537f), Android release APK 63,261,407바이트·SHA-256 f2a12703...146674 통과</a:t>
+              <a:t>Pages main.dart.js 3,709,337바이트·SHA-256 fd3f99ec...1718375, Android release APK 63,261,407바이트·SHA-256 9560dcd7...31552 통과</a:t>
             </a:r>
           </a:p>
         </p:txBody>
@@ -5136,7 +5136,7 @@
           <p:cNvPr id="45" name="table-cell-140-10-0">
             <a:extLst xmlns:a="http://schemas.openxmlformats.org/drawingml/2006/main">
               <a:ext uri="{FF2B5EF4-FFF2-40B4-BE49-F238E27FC236}">
-                <a16:creationId xmlns:a16="http://schemas.microsoft.com/office/drawing/2014/main" id="{C1009246-86C2-44A0-A60B-9AC5F208F2A4}"/>
+                <a16:creationId xmlns:a16="http://schemas.microsoft.com/office/drawing/2014/main" id="{C8D3B012-AF71-4B50-96AF-6630B62EAF9F}"/>
               </a:ext>
             </a:extLst>
           </p:cNvPr>
@@ -5169,7 +5169,7 @@
           <p:cNvPr id="46" name="table-text-140-10-0">
             <a:extLst xmlns:a="http://schemas.openxmlformats.org/drawingml/2006/main">
               <a:ext uri="{FF2B5EF4-FFF2-40B4-BE49-F238E27FC236}">
-                <a16:creationId xmlns:a16="http://schemas.microsoft.com/office/drawing/2014/main" id="{69D0ADC7-96F0-4477-B3E6-B0DA924043BA}"/>
+                <a16:creationId xmlns:a16="http://schemas.microsoft.com/office/drawing/2014/main" id="{A475293F-1172-4D8E-B8C6-3F72414380D4}"/>
               </a:ext>
             </a:extLst>
           </p:cNvPr>
@@ -5231,7 +5231,7 @@
           <p:cNvPr id="47" name="table-cell-140-10-1">
             <a:extLst xmlns:a="http://schemas.openxmlformats.org/drawingml/2006/main">
               <a:ext uri="{FF2B5EF4-FFF2-40B4-BE49-F238E27FC236}">
-                <a16:creationId xmlns:a16="http://schemas.microsoft.com/office/drawing/2014/main" id="{6A346BB2-9B5B-43FA-9A19-1B42A376DB64}"/>
+                <a16:creationId xmlns:a16="http://schemas.microsoft.com/office/drawing/2014/main" id="{2CBD407D-F199-4188-B3EF-398348A8030B}"/>
               </a:ext>
             </a:extLst>
           </p:cNvPr>
@@ -5264,7 +5264,7 @@
           <p:cNvPr id="48" name="table-text-140-10-1">
             <a:extLst xmlns:a="http://schemas.openxmlformats.org/drawingml/2006/main">
               <a:ext uri="{FF2B5EF4-FFF2-40B4-BE49-F238E27FC236}">
-                <a16:creationId xmlns:a16="http://schemas.microsoft.com/office/drawing/2014/main" id="{A54BC7C9-FDCE-412C-8FD1-90A86C690CBF}"/>
+                <a16:creationId xmlns:a16="http://schemas.microsoft.com/office/drawing/2014/main" id="{CAE794CA-EF6B-4229-85B0-B3FFC2165B28}"/>
               </a:ext>
             </a:extLst>
           </p:cNvPr>
@@ -5289,7 +5289,7 @@
         </p:spPr>
         <p:txBody>
           <a:bodyPr xmlns:a="http://schemas.openxmlformats.org/drawingml/2006/main" lIns="0" tIns="0" rIns="0" bIns="0" anchor="t">
-            <a:normAutofit fontScale="85311"/>
+            <a:normAutofit fontScale="83636"/>
           </a:bodyPr>
           <a:lstStyle xmlns:a="http://schemas.openxmlformats.org/drawingml/2006/main"/>
           <a:p xmlns:a="http://schemas.openxmlformats.org/drawingml/2006/main">
@@ -5316,7 +5316,7 @@
                 <a:ea typeface="NanumGothic"/>
                 <a:cs typeface="NanumGothic"/>
               </a:rPr>
-              <a:t>19소스 Golden 68건·freshness·실제 telemetry attestation·60.000초 H.264/avc1 MOV·identity transform·대표 27프레임 시각 검사 통과. Pages 재배포는 문서 재생성 뒤 수행</a:t>
+              <a:t>19소스 Golden 68건·freshness·실제 telemetry attestation·60.000초 H.264/avc1 MOV·identity transform·대표 27프레임 시각 검사 통과. Pages run 31373105599 성공 및 공개 URL HTTP 200</a:t>
             </a:r>
           </a:p>
         </p:txBody>
@@ -5326,7 +5326,7 @@
           <p:cNvPr id="49" name="table-cell-140-11-0">
             <a:extLst xmlns:a="http://schemas.openxmlformats.org/drawingml/2006/main">
               <a:ext uri="{FF2B5EF4-FFF2-40B4-BE49-F238E27FC236}">
-                <a16:creationId xmlns:a16="http://schemas.microsoft.com/office/drawing/2014/main" id="{1EE1B67C-5144-43B5-ACA2-A3EE68B09050}"/>
+                <a16:creationId xmlns:a16="http://schemas.microsoft.com/office/drawing/2014/main" id="{153AA41C-932F-4D3C-958C-B7B0A76993D7}"/>
               </a:ext>
             </a:extLst>
           </p:cNvPr>
@@ -5359,7 +5359,7 @@
           <p:cNvPr id="50" name="table-text-140-11-0">
             <a:extLst xmlns:a="http://schemas.openxmlformats.org/drawingml/2006/main">
               <a:ext uri="{FF2B5EF4-FFF2-40B4-BE49-F238E27FC236}">
-                <a16:creationId xmlns:a16="http://schemas.microsoft.com/office/drawing/2014/main" id="{27B097F3-1C8A-4C84-81FD-B1D5BC538E5D}"/>
+                <a16:creationId xmlns:a16="http://schemas.microsoft.com/office/drawing/2014/main" id="{35DB0270-BF9B-4136-9569-4A7AE01D8375}"/>
               </a:ext>
             </a:extLst>
           </p:cNvPr>
@@ -5421,7 +5421,7 @@
           <p:cNvPr id="51" name="table-cell-140-11-1">
             <a:extLst xmlns:a="http://schemas.openxmlformats.org/drawingml/2006/main">
               <a:ext uri="{FF2B5EF4-FFF2-40B4-BE49-F238E27FC236}">
-                <a16:creationId xmlns:a16="http://schemas.microsoft.com/office/drawing/2014/main" id="{C6A44366-6CD3-43C7-BE3F-FF633CCC5A81}"/>
+                <a16:creationId xmlns:a16="http://schemas.microsoft.com/office/drawing/2014/main" id="{74DAC825-7C2A-4D5C-B68E-46FC5D68E17A}"/>
               </a:ext>
             </a:extLst>
           </p:cNvPr>
@@ -5454,7 +5454,7 @@
           <p:cNvPr id="52" name="table-text-140-11-1">
             <a:extLst xmlns:a="http://schemas.openxmlformats.org/drawingml/2006/main">
               <a:ext uri="{FF2B5EF4-FFF2-40B4-BE49-F238E27FC236}">
-                <a16:creationId xmlns:a16="http://schemas.microsoft.com/office/drawing/2014/main" id="{BABF7543-CAB3-46F8-8AFF-BD4FFA518A99}"/>
+                <a16:creationId xmlns:a16="http://schemas.microsoft.com/office/drawing/2014/main" id="{C4EDA83A-0AE2-4A20-A67B-ED3258FBCB9E}"/>
               </a:ext>
             </a:extLst>
           </p:cNvPr>
@@ -5467,6 +5467,68 @@
           <a:xfrm xmlns:a="http://schemas.openxmlformats.org/drawingml/2006/main">
             <a:off x="3867150" y="7006590"/>
             <a:ext cx="3076575" cy="398145"/>
+          </a:xfrm>
+          <a:prstGeom xmlns:a="http://schemas.openxmlformats.org/drawingml/2006/main" prst="rect">
+            <a:avLst/>
+          </a:prstGeom>
+          <a:noFill xmlns:a="http://schemas.openxmlformats.org/drawingml/2006/main"/>
+          <a:ln xmlns:a="http://schemas.openxmlformats.org/drawingml/2006/main" w="0">
+            <a:noFill/>
+            <a:prstDash val="solid"/>
+          </a:ln>
+        </p:spPr>
+        <p:txBody>
+          <a:bodyPr xmlns:a="http://schemas.openxmlformats.org/drawingml/2006/main" lIns="0" tIns="0" rIns="0" bIns="0" anchor="t">
+            <a:normAutofit fontScale="82918"/>
+          </a:bodyPr>
+          <a:lstStyle xmlns:a="http://schemas.openxmlformats.org/drawingml/2006/main"/>
+          <a:p xmlns:a="http://schemas.openxmlformats.org/drawingml/2006/main">
+            <a:pPr algn="l">
+              <a:lnSpc>
+                <a:spcPct val="108000"/>
+              </a:lnSpc>
+              <a:buNone/>
+              <a:defRPr sz="1050" b="0">
+                <a:solidFill>
+                  <a:srgbClr val="173A3F"/>
+                </a:solidFill>
+                <a:latin typeface="NanumGothic"/>
+                <a:ea typeface="NanumGothic"/>
+                <a:cs typeface="NanumGothic"/>
+              </a:defRPr>
+            </a:pPr>
+            <a:r>
+              <a:rPr sz="1050" b="0">
+                <a:solidFill>
+                  <a:srgbClr val="173A3F"/>
+                </a:solidFill>
+                <a:latin typeface="NanumGothic"/>
+                <a:ea typeface="NanumGothic"/>
+                <a:cs typeface="NanumGothic"/>
+              </a:rPr>
+              <a:t>코드·레벨·영상·문서 레이아웃 핵심 감사 통과. 배포 전 발견한 telemetry shot_id 불일치는 실제 발사 회귀를 추가해 수정·재감사</a:t>
+            </a:r>
+          </a:p>
+        </p:txBody>
+      </p:sp>
+      <p:sp>
+        <p:nvSpPr>
+          <p:cNvPr id="53" name="paragraph-800.4">
+            <a:extLst xmlns:a="http://schemas.openxmlformats.org/drawingml/2006/main">
+              <a:ext uri="{FF2B5EF4-FFF2-40B4-BE49-F238E27FC236}">
+                <a16:creationId xmlns:a16="http://schemas.microsoft.com/office/drawing/2014/main" id="{1EC70BBF-2728-4C59-AAA1-4FAF2F4DAE59}"/>
+              </a:ext>
+            </a:extLst>
+          </p:cNvPr>
+          <p:cNvSpPr>
+            <a:spLocks xmlns:a="http://schemas.openxmlformats.org/drawingml/2006/main" noGrp="1"/>
+          </p:cNvSpPr>
+          <p:nvPr/>
+        </p:nvSpPr>
+        <p:spPr>
+          <a:xfrm xmlns:a="http://schemas.openxmlformats.org/drawingml/2006/main">
+            <a:off x="533400" y="7623810"/>
+            <a:ext cx="6496050" cy="809244"/>
           </a:xfrm>
           <a:prstGeom xmlns:a="http://schemas.openxmlformats.org/drawingml/2006/main" prst="rect">
             <a:avLst/>
@@ -5485,50 +5547,50 @@
           <a:p xmlns:a="http://schemas.openxmlformats.org/drawingml/2006/main">
             <a:pPr algn="l">
               <a:lnSpc>
-                <a:spcPct val="108000"/>
-              </a:lnSpc>
-              <a:buNone/>
-              <a:defRPr sz="1050" b="0">
-                <a:solidFill>
-                  <a:srgbClr val="173A3F"/>
-                </a:solidFill>
-                <a:latin typeface="NanumGothic"/>
-                <a:ea typeface="NanumGothic"/>
-                <a:cs typeface="NanumGothic"/>
-              </a:defRPr>
-            </a:pPr>
-            <a:r>
-              <a:rPr sz="1050" b="0">
-                <a:solidFill>
-                  <a:srgbClr val="173A3F"/>
-                </a:solidFill>
-                <a:latin typeface="NanumGothic"/>
-                <a:ea typeface="NanumGothic"/>
-                <a:cs typeface="NanumGothic"/>
-              </a:rPr>
-              <a:t>코드·레벨·영상 핵심 감사 통과. 최종 문서·배포 감사는 최신 산출물·Pages 확인 뒤 확정</a:t>
-            </a:r>
-          </a:p>
-        </p:txBody>
-      </p:sp>
-      <p:sp>
-        <p:nvSpPr>
-          <p:cNvPr id="53" name="paragraph-800.4">
-            <a:extLst xmlns:a="http://schemas.openxmlformats.org/drawingml/2006/main">
-              <a:ext uri="{FF2B5EF4-FFF2-40B4-BE49-F238E27FC236}">
-                <a16:creationId xmlns:a16="http://schemas.microsoft.com/office/drawing/2014/main" id="{50B8EBD2-6F13-41B1-AE1D-CE3B42F50D5F}"/>
-              </a:ext>
-            </a:extLst>
-          </p:cNvPr>
-          <p:cNvSpPr>
-            <a:spLocks xmlns:a="http://schemas.openxmlformats.org/drawingml/2006/main" noGrp="1"/>
-          </p:cNvSpPr>
-          <p:nvPr/>
-        </p:nvSpPr>
-        <p:spPr>
-          <a:xfrm xmlns:a="http://schemas.openxmlformats.org/drawingml/2006/main">
-            <a:off x="533400" y="7623810"/>
-            <a:ext cx="6496050" cy="809244"/>
+                <a:spcPct val="122000"/>
+              </a:lnSpc>
+              <a:buNone/>
+              <a:defRPr sz="1200" b="0">
+                <a:solidFill>
+                  <a:srgbClr val="173A3F"/>
+                </a:solidFill>
+                <a:latin typeface="NanumGothic"/>
+                <a:ea typeface="NanumGothic"/>
+                <a:cs typeface="NanumGothic"/>
+              </a:defRPr>
+            </a:pPr>
+            <a:r>
+              <a:rPr sz="1200" b="0">
+                <a:solidFill>
+                  <a:srgbClr val="173A3F"/>
+                </a:solidFill>
+                <a:latin typeface="NanumGothic"/>
+                <a:ea typeface="NanumGothic"/>
+                <a:cs typeface="NanumGothic"/>
+              </a:rPr>
+              <a:t>이번 단일 전체 실행에서 실패한 Golden 61개는 실제 렌더를 직접 비교했다. 차이는 모두 하단 조작 안내를 물체를 눌러 속성 고르기로 단축해 한 줄로 만든 영역에 국한됐고, 해당 6개 Golden 파일 묶음의 67개 테스트가 갱신 후 재통과했다.</a:t>
+            </a:r>
+          </a:p>
+        </p:txBody>
+      </p:sp>
+      <p:sp>
+        <p:nvSpPr>
+          <p:cNvPr id="54" name="subheading-897.36">
+            <a:extLst xmlns:a="http://schemas.openxmlformats.org/drawingml/2006/main">
+              <a:ext uri="{FF2B5EF4-FFF2-40B4-BE49-F238E27FC236}">
+                <a16:creationId xmlns:a16="http://schemas.microsoft.com/office/drawing/2014/main" id="{6616DC1B-4A1C-4B36-A996-5193D499834D}"/>
+              </a:ext>
+            </a:extLst>
+          </p:cNvPr>
+          <p:cNvSpPr>
+            <a:spLocks xmlns:a="http://schemas.openxmlformats.org/drawingml/2006/main" noGrp="1"/>
+          </p:cNvSpPr>
+          <p:nvPr/>
+        </p:nvSpPr>
+        <p:spPr>
+          <a:xfrm xmlns:a="http://schemas.openxmlformats.org/drawingml/2006/main">
+            <a:off x="533400" y="8547354"/>
+            <a:ext cx="6496050" cy="400050"/>
           </a:xfrm>
           <a:prstGeom xmlns:a="http://schemas.openxmlformats.org/drawingml/2006/main" prst="rect">
             <a:avLst/>
@@ -5547,68 +5609,6 @@
           <a:p xmlns:a="http://schemas.openxmlformats.org/drawingml/2006/main">
             <a:pPr algn="l">
               <a:lnSpc>
-                <a:spcPct val="122000"/>
-              </a:lnSpc>
-              <a:buNone/>
-              <a:defRPr sz="1200" b="0">
-                <a:solidFill>
-                  <a:srgbClr val="173A3F"/>
-                </a:solidFill>
-                <a:latin typeface="NanumGothic"/>
-                <a:ea typeface="NanumGothic"/>
-                <a:cs typeface="NanumGothic"/>
-              </a:defRPr>
-            </a:pPr>
-            <a:r>
-              <a:rPr sz="1200" b="0">
-                <a:solidFill>
-                  <a:srgbClr val="173A3F"/>
-                </a:solidFill>
-                <a:latin typeface="NanumGothic"/>
-                <a:ea typeface="NanumGothic"/>
-                <a:cs typeface="NanumGothic"/>
-              </a:rPr>
-              <a:t>이번 단일 전체 실행에서 실패한 Golden 61개는 실제 렌더를 직접 비교했다. 차이는 모두 하단 조작 안내를 물체를 눌러 속성 고르기로 단축해 한 줄로 만든 영역에 국한됐고, 해당 6개 Golden 파일 묶음의 67개 테스트가 갱신 후 재통과했다.</a:t>
-            </a:r>
-          </a:p>
-        </p:txBody>
-      </p:sp>
-      <p:sp>
-        <p:nvSpPr>
-          <p:cNvPr id="54" name="subheading-897.36">
-            <a:extLst xmlns:a="http://schemas.openxmlformats.org/drawingml/2006/main">
-              <a:ext uri="{FF2B5EF4-FFF2-40B4-BE49-F238E27FC236}">
-                <a16:creationId xmlns:a16="http://schemas.microsoft.com/office/drawing/2014/main" id="{52BB75E3-EB70-4EEC-AD38-DBCEBF24505A}"/>
-              </a:ext>
-            </a:extLst>
-          </p:cNvPr>
-          <p:cNvSpPr>
-            <a:spLocks xmlns:a="http://schemas.openxmlformats.org/drawingml/2006/main" noGrp="1"/>
-          </p:cNvSpPr>
-          <p:nvPr/>
-        </p:nvSpPr>
-        <p:spPr>
-          <a:xfrm xmlns:a="http://schemas.openxmlformats.org/drawingml/2006/main">
-            <a:off x="533400" y="8547354"/>
-            <a:ext cx="6496050" cy="400050"/>
-          </a:xfrm>
-          <a:prstGeom xmlns:a="http://schemas.openxmlformats.org/drawingml/2006/main" prst="rect">
-            <a:avLst/>
-          </a:prstGeom>
-          <a:noFill xmlns:a="http://schemas.openxmlformats.org/drawingml/2006/main"/>
-          <a:ln xmlns:a="http://schemas.openxmlformats.org/drawingml/2006/main" w="0">
-            <a:noFill/>
-            <a:prstDash val="solid"/>
-          </a:ln>
-        </p:spPr>
-        <p:txBody>
-          <a:bodyPr xmlns:a="http://schemas.openxmlformats.org/drawingml/2006/main" lIns="0" tIns="0" rIns="0" bIns="0" anchor="t">
-            <a:normAutofit fontScale="100000"/>
-          </a:bodyPr>
-          <a:lstStyle xmlns:a="http://schemas.openxmlformats.org/drawingml/2006/main"/>
-          <a:p xmlns:a="http://schemas.openxmlformats.org/drawingml/2006/main">
-            <a:pPr algn="l">
-              <a:lnSpc>
                 <a:spcPct val="120000"/>
               </a:lnSpc>
               <a:buNone/>
@@ -5638,7 +5638,7 @@
     </p:spTree>
     <p:extLst>
       <p:ext uri="{BB962C8B-B14F-4D97-AF65-F5344CB8AC3E}">
-        <p14:creationId xmlns:p14="http://schemas.microsoft.com/office/powerpoint/2010/main" val="1833639625"/>
+        <p14:creationId xmlns:p14="http://schemas.microsoft.com/office/powerpoint/2010/main" val="1747396053"/>
       </p:ext>
     </p:extLst>
   </p:cSld>
@@ -5669,7 +5669,7 @@
           <p:cNvPr id="6" name="running-label">
             <a:extLst xmlns:a="http://schemas.openxmlformats.org/drawingml/2006/main">
               <a:ext uri="{FF2B5EF4-FFF2-40B4-BE49-F238E27FC236}">
-                <a16:creationId xmlns:a16="http://schemas.microsoft.com/office/drawing/2014/main" id="{1FF77271-8E7E-4AB9-9713-31A9B942D378}"/>
+                <a16:creationId xmlns:a16="http://schemas.microsoft.com/office/drawing/2014/main" id="{9005AD1C-DA4D-4BF4-A463-C697882FBE2B}"/>
               </a:ext>
             </a:extLst>
           </p:cNvPr>
@@ -5731,7 +5731,7 @@
           <p:cNvPr id="2" name="page-number">
             <a:extLst xmlns:a="http://schemas.openxmlformats.org/drawingml/2006/main">
               <a:ext uri="{FF2B5EF4-FFF2-40B4-BE49-F238E27FC236}">
-                <a16:creationId xmlns:a16="http://schemas.microsoft.com/office/drawing/2014/main" id="{EDA4014F-81F2-4314-A2AA-BC19F74FA90E}"/>
+                <a16:creationId xmlns:a16="http://schemas.microsoft.com/office/drawing/2014/main" id="{6D15E633-4399-49BF-82F6-1DB8B4E23195}"/>
               </a:ext>
             </a:extLst>
           </p:cNvPr>
@@ -5793,7 +5793,7 @@
           <p:cNvPr id="3" name="header-rule">
             <a:extLst xmlns:a="http://schemas.openxmlformats.org/drawingml/2006/main">
               <a:ext uri="{FF2B5EF4-FFF2-40B4-BE49-F238E27FC236}">
-                <a16:creationId xmlns:a16="http://schemas.microsoft.com/office/drawing/2014/main" id="{9CE76609-A206-4D79-B957-B874334CFD38}"/>
+                <a16:creationId xmlns:a16="http://schemas.microsoft.com/office/drawing/2014/main" id="{0B31517B-219D-4D3E-8EDA-6A0ADD7B4F4D}"/>
               </a:ext>
             </a:extLst>
           </p:cNvPr>
@@ -5824,7 +5824,7 @@
           <p:cNvPr id="4" name="slide-title">
             <a:extLst xmlns:a="http://schemas.openxmlformats.org/drawingml/2006/main">
               <a:ext uri="{FF2B5EF4-FFF2-40B4-BE49-F238E27FC236}">
-                <a16:creationId xmlns:a16="http://schemas.microsoft.com/office/drawing/2014/main" id="{0E7A9BB7-374C-4298-A4B2-E3DE19A8297F}"/>
+                <a16:creationId xmlns:a16="http://schemas.microsoft.com/office/drawing/2014/main" id="{0F89C6C1-BF78-4E5A-90D7-8C2073ED5246}"/>
               </a:ext>
             </a:extLst>
           </p:cNvPr>
@@ -5886,7 +5886,7 @@
           <p:cNvPr id="5" name="paragraph-140">
             <a:extLst xmlns:a="http://schemas.openxmlformats.org/drawingml/2006/main">
               <a:ext uri="{FF2B5EF4-FFF2-40B4-BE49-F238E27FC236}">
-                <a16:creationId xmlns:a16="http://schemas.microsoft.com/office/drawing/2014/main" id="{FFB79BEC-0592-4597-B4BD-4A2FD18FF508}"/>
+                <a16:creationId xmlns:a16="http://schemas.microsoft.com/office/drawing/2014/main" id="{CBD32351-3691-4895-BFA2-B43AEAF228B3}"/>
               </a:ext>
             </a:extLst>
           </p:cNvPr>
@@ -5946,7 +5946,7 @@
     </p:spTree>
     <p:extLst>
       <p:ext uri="{BB962C8B-B14F-4D97-AF65-F5344CB8AC3E}">
-        <p14:creationId xmlns:p14="http://schemas.microsoft.com/office/powerpoint/2010/main" val="947361499"/>
+        <p14:creationId xmlns:p14="http://schemas.microsoft.com/office/powerpoint/2010/main" val="1912739392"/>
       </p:ext>
     </p:extLst>
   </p:cSld>
@@ -5977,7 +5977,7 @@
           <p:cNvPr id="11" name="running-label">
             <a:extLst xmlns:a="http://schemas.openxmlformats.org/drawingml/2006/main">
               <a:ext uri="{FF2B5EF4-FFF2-40B4-BE49-F238E27FC236}">
-                <a16:creationId xmlns:a16="http://schemas.microsoft.com/office/drawing/2014/main" id="{DEE2F3F3-71D9-4A81-BDC6-4F795ED9BA66}"/>
+                <a16:creationId xmlns:a16="http://schemas.microsoft.com/office/drawing/2014/main" id="{4ECB419C-4D53-4664-94B3-185A93C5306B}"/>
               </a:ext>
             </a:extLst>
           </p:cNvPr>
@@ -6039,7 +6039,7 @@
           <p:cNvPr id="2" name="page-number">
             <a:extLst xmlns:a="http://schemas.openxmlformats.org/drawingml/2006/main">
               <a:ext uri="{FF2B5EF4-FFF2-40B4-BE49-F238E27FC236}">
-                <a16:creationId xmlns:a16="http://schemas.microsoft.com/office/drawing/2014/main" id="{65016393-CEC4-4BBE-8484-7B57BCD80AD2}"/>
+                <a16:creationId xmlns:a16="http://schemas.microsoft.com/office/drawing/2014/main" id="{CAD104A0-3C65-4B4B-9B6C-61BBF74C35D9}"/>
               </a:ext>
             </a:extLst>
           </p:cNvPr>
@@ -6101,7 +6101,7 @@
           <p:cNvPr id="3" name="header-rule">
             <a:extLst xmlns:a="http://schemas.openxmlformats.org/drawingml/2006/main">
               <a:ext uri="{FF2B5EF4-FFF2-40B4-BE49-F238E27FC236}">
-                <a16:creationId xmlns:a16="http://schemas.microsoft.com/office/drawing/2014/main" id="{464CCB86-DA8B-4232-BC3C-86DE4E984259}"/>
+                <a16:creationId xmlns:a16="http://schemas.microsoft.com/office/drawing/2014/main" id="{91060D50-5914-4B84-8607-67C2135A65D3}"/>
               </a:ext>
             </a:extLst>
           </p:cNvPr>
@@ -6132,7 +6132,7 @@
           <p:cNvPr id="4" name="slide-title">
             <a:extLst xmlns:a="http://schemas.openxmlformats.org/drawingml/2006/main">
               <a:ext uri="{FF2B5EF4-FFF2-40B4-BE49-F238E27FC236}">
-                <a16:creationId xmlns:a16="http://schemas.microsoft.com/office/drawing/2014/main" id="{05B7ED4B-F126-46E7-B4EA-15DA7FBC8636}"/>
+                <a16:creationId xmlns:a16="http://schemas.microsoft.com/office/drawing/2014/main" id="{40B172DB-6BC1-4AE2-9236-E32B6535DF4D}"/>
               </a:ext>
             </a:extLst>
           </p:cNvPr>
@@ -6194,7 +6194,7 @@
           <p:cNvPr id="5" name="paragraph-140">
             <a:extLst xmlns:a="http://schemas.openxmlformats.org/drawingml/2006/main">
               <a:ext uri="{FF2B5EF4-FFF2-40B4-BE49-F238E27FC236}">
-                <a16:creationId xmlns:a16="http://schemas.microsoft.com/office/drawing/2014/main" id="{3ABBB89F-EBEF-4DEA-8CC3-E2D666974805}"/>
+                <a16:creationId xmlns:a16="http://schemas.microsoft.com/office/drawing/2014/main" id="{A94F039F-7CA7-4AC3-A335-E56AD5BABBA7}"/>
               </a:ext>
             </a:extLst>
           </p:cNvPr>
@@ -6256,7 +6256,7 @@
           <p:cNvPr id="6" name="subheading-212.64">
             <a:extLst xmlns:a="http://schemas.openxmlformats.org/drawingml/2006/main">
               <a:ext uri="{FF2B5EF4-FFF2-40B4-BE49-F238E27FC236}">
-                <a16:creationId xmlns:a16="http://schemas.microsoft.com/office/drawing/2014/main" id="{9525CC19-A93D-40A9-93BD-BD832EEEC904}"/>
+                <a16:creationId xmlns:a16="http://schemas.microsoft.com/office/drawing/2014/main" id="{95F3D124-BA9B-4CB0-B0AD-023B17CCEAB9}"/>
               </a:ext>
             </a:extLst>
           </p:cNvPr>
@@ -6322,7 +6322,7 @@
           <p:nvPr/>
         </p:nvPicPr>
         <p:blipFill>
-          <a:blip xmlns:r="http://schemas.openxmlformats.org/officeDocument/2006/relationships" xmlns:a="http://schemas.openxmlformats.org/drawingml/2006/main" r:embed="Rdc93c0e9c37244bc"/>
+          <a:blip xmlns:r="http://schemas.openxmlformats.org/officeDocument/2006/relationships" xmlns:a="http://schemas.openxmlformats.org/drawingml/2006/main" r:embed="R7a50ef5d2a9d4625"/>
           <a:stretch xmlns:a="http://schemas.openxmlformats.org/drawingml/2006/main"/>
         </p:blipFill>
         <p:spPr>
@@ -6342,7 +6342,7 @@
           <p:cNvPr id="8" name="image-caption-266.64">
             <a:extLst xmlns:a="http://schemas.openxmlformats.org/drawingml/2006/main">
               <a:ext uri="{FF2B5EF4-FFF2-40B4-BE49-F238E27FC236}">
-                <a16:creationId xmlns:a16="http://schemas.microsoft.com/office/drawing/2014/main" id="{7C523128-F7CF-492C-B644-63A4B9A2740D}"/>
+                <a16:creationId xmlns:a16="http://schemas.microsoft.com/office/drawing/2014/main" id="{D1AF7FCD-3819-4C32-A651-7E999525CF12}"/>
               </a:ext>
             </a:extLst>
           </p:cNvPr>
@@ -6404,7 +6404,7 @@
           <p:cNvPr id="9" name="bullets-650.64">
             <a:extLst xmlns:a="http://schemas.openxmlformats.org/drawingml/2006/main">
               <a:ext uri="{FF2B5EF4-FFF2-40B4-BE49-F238E27FC236}">
-                <a16:creationId xmlns:a16="http://schemas.microsoft.com/office/drawing/2014/main" id="{5182C661-34F0-4B9D-96AC-77D603BF4D56}"/>
+                <a16:creationId xmlns:a16="http://schemas.microsoft.com/office/drawing/2014/main" id="{A0584BC0-BA52-4DA3-91B6-CF5B99D23CD5}"/>
               </a:ext>
             </a:extLst>
           </p:cNvPr>
@@ -6529,7 +6529,7 @@
           <p:cNvPr id="10" name="subheading-801.92">
             <a:extLst xmlns:a="http://schemas.openxmlformats.org/drawingml/2006/main">
               <a:ext uri="{FF2B5EF4-FFF2-40B4-BE49-F238E27FC236}">
-                <a16:creationId xmlns:a16="http://schemas.microsoft.com/office/drawing/2014/main" id="{577E7712-728C-4107-811A-CFB795504DC9}"/>
+                <a16:creationId xmlns:a16="http://schemas.microsoft.com/office/drawing/2014/main" id="{88DDB466-261D-4EB5-812D-FB3D8A41B85B}"/>
               </a:ext>
             </a:extLst>
           </p:cNvPr>
@@ -6589,7 +6589,7 @@
     </p:spTree>
     <p:extLst>
       <p:ext uri="{BB962C8B-B14F-4D97-AF65-F5344CB8AC3E}">
-        <p14:creationId xmlns:p14="http://schemas.microsoft.com/office/powerpoint/2010/main" val="1947475265"/>
+        <p14:creationId xmlns:p14="http://schemas.microsoft.com/office/powerpoint/2010/main" val="976969535"/>
       </p:ext>
     </p:extLst>
   </p:cSld>
@@ -6620,7 +6620,7 @@
           <p:cNvPr id="9" name="running-label">
             <a:extLst xmlns:a="http://schemas.openxmlformats.org/drawingml/2006/main">
               <a:ext uri="{FF2B5EF4-FFF2-40B4-BE49-F238E27FC236}">
-                <a16:creationId xmlns:a16="http://schemas.microsoft.com/office/drawing/2014/main" id="{A7C45D5B-93FB-4969-A916-834B19F737CA}"/>
+                <a16:creationId xmlns:a16="http://schemas.microsoft.com/office/drawing/2014/main" id="{B53ED1B5-DBEA-4315-8380-E1CCBA1432A5}"/>
               </a:ext>
             </a:extLst>
           </p:cNvPr>
@@ -6682,7 +6682,7 @@
           <p:cNvPr id="2" name="page-number">
             <a:extLst xmlns:a="http://schemas.openxmlformats.org/drawingml/2006/main">
               <a:ext uri="{FF2B5EF4-FFF2-40B4-BE49-F238E27FC236}">
-                <a16:creationId xmlns:a16="http://schemas.microsoft.com/office/drawing/2014/main" id="{CBF714F0-FC12-47E4-95DB-5929DC168F18}"/>
+                <a16:creationId xmlns:a16="http://schemas.microsoft.com/office/drawing/2014/main" id="{5DB6B703-2152-4E23-AF78-BFFE45F71FCD}"/>
               </a:ext>
             </a:extLst>
           </p:cNvPr>
@@ -6744,7 +6744,7 @@
           <p:cNvPr id="3" name="header-rule">
             <a:extLst xmlns:a="http://schemas.openxmlformats.org/drawingml/2006/main">
               <a:ext uri="{FF2B5EF4-FFF2-40B4-BE49-F238E27FC236}">
-                <a16:creationId xmlns:a16="http://schemas.microsoft.com/office/drawing/2014/main" id="{615A0687-1DEF-4F86-8D2F-1FBCBE25A8DD}"/>
+                <a16:creationId xmlns:a16="http://schemas.microsoft.com/office/drawing/2014/main" id="{88F33648-5615-4767-8370-D596EC2D86D8}"/>
               </a:ext>
             </a:extLst>
           </p:cNvPr>
@@ -6775,7 +6775,7 @@
           <p:cNvPr id="4" name="slide-title">
             <a:extLst xmlns:a="http://schemas.openxmlformats.org/drawingml/2006/main">
               <a:ext uri="{FF2B5EF4-FFF2-40B4-BE49-F238E27FC236}">
-                <a16:creationId xmlns:a16="http://schemas.microsoft.com/office/drawing/2014/main" id="{7753480A-CE4A-4479-8396-AFC5A4008C6F}"/>
+                <a16:creationId xmlns:a16="http://schemas.microsoft.com/office/drawing/2014/main" id="{DEFAA717-993D-4B79-9958-F75D20A1FE93}"/>
               </a:ext>
             </a:extLst>
           </p:cNvPr>
@@ -6841,7 +6841,7 @@
           <p:nvPr/>
         </p:nvPicPr>
         <p:blipFill>
-          <a:blip xmlns:r="http://schemas.openxmlformats.org/officeDocument/2006/relationships" xmlns:a="http://schemas.openxmlformats.org/drawingml/2006/main" r:embed="Ra13d25d7b3e344a4"/>
+          <a:blip xmlns:r="http://schemas.openxmlformats.org/officeDocument/2006/relationships" xmlns:a="http://schemas.openxmlformats.org/drawingml/2006/main" r:embed="R8ae05c8fd1374ed4"/>
           <a:stretch xmlns:a="http://schemas.openxmlformats.org/drawingml/2006/main"/>
         </p:blipFill>
         <p:spPr>
@@ -6861,7 +6861,7 @@
           <p:cNvPr id="6" name="image-caption-140">
             <a:extLst xmlns:a="http://schemas.openxmlformats.org/drawingml/2006/main">
               <a:ext uri="{FF2B5EF4-FFF2-40B4-BE49-F238E27FC236}">
-                <a16:creationId xmlns:a16="http://schemas.microsoft.com/office/drawing/2014/main" id="{EBD0ED78-D182-4895-931B-FE782A213662}"/>
+                <a16:creationId xmlns:a16="http://schemas.microsoft.com/office/drawing/2014/main" id="{EF6B5C4F-B844-47B2-9EAE-7189E2816F21}"/>
               </a:ext>
             </a:extLst>
           </p:cNvPr>
@@ -6923,7 +6923,7 @@
           <p:cNvPr id="7" name="bullets-524">
             <a:extLst xmlns:a="http://schemas.openxmlformats.org/drawingml/2006/main">
               <a:ext uri="{FF2B5EF4-FFF2-40B4-BE49-F238E27FC236}">
-                <a16:creationId xmlns:a16="http://schemas.microsoft.com/office/drawing/2014/main" id="{032E5DE7-B1F1-44ED-9F4D-0798CD70A924}"/>
+                <a16:creationId xmlns:a16="http://schemas.microsoft.com/office/drawing/2014/main" id="{CC275052-DFAE-463D-BC7F-47179DF1AECA}"/>
               </a:ext>
             </a:extLst>
           </p:cNvPr>
@@ -7048,7 +7048,7 @@
           <p:cNvPr id="8" name="subheading-675.28">
             <a:extLst xmlns:a="http://schemas.openxmlformats.org/drawingml/2006/main">
               <a:ext uri="{FF2B5EF4-FFF2-40B4-BE49-F238E27FC236}">
-                <a16:creationId xmlns:a16="http://schemas.microsoft.com/office/drawing/2014/main" id="{51E09111-81D3-40B0-9EE7-AB0DC1ABAD89}"/>
+                <a16:creationId xmlns:a16="http://schemas.microsoft.com/office/drawing/2014/main" id="{580DC0C6-9923-4FDE-B43D-F32EF6A2FD74}"/>
               </a:ext>
             </a:extLst>
           </p:cNvPr>
@@ -7108,7 +7108,7 @@
     </p:spTree>
     <p:extLst>
       <p:ext uri="{BB962C8B-B14F-4D97-AF65-F5344CB8AC3E}">
-        <p14:creationId xmlns:p14="http://schemas.microsoft.com/office/powerpoint/2010/main" val="654521558"/>
+        <p14:creationId xmlns:p14="http://schemas.microsoft.com/office/powerpoint/2010/main" val="1215070720"/>
       </p:ext>
     </p:extLst>
   </p:cSld>
@@ -7139,7 +7139,7 @@
           <p:cNvPr id="9" name="running-label">
             <a:extLst xmlns:a="http://schemas.openxmlformats.org/drawingml/2006/main">
               <a:ext uri="{FF2B5EF4-FFF2-40B4-BE49-F238E27FC236}">
-                <a16:creationId xmlns:a16="http://schemas.microsoft.com/office/drawing/2014/main" id="{C4A0F6AF-F30D-4D2A-8AA0-8EB593D4CC46}"/>
+                <a16:creationId xmlns:a16="http://schemas.microsoft.com/office/drawing/2014/main" id="{F8ABE921-DDD3-4397-9CA4-3DF25BBAAD76}"/>
               </a:ext>
             </a:extLst>
           </p:cNvPr>
@@ -7201,7 +7201,7 @@
           <p:cNvPr id="2" name="page-number">
             <a:extLst xmlns:a="http://schemas.openxmlformats.org/drawingml/2006/main">
               <a:ext uri="{FF2B5EF4-FFF2-40B4-BE49-F238E27FC236}">
-                <a16:creationId xmlns:a16="http://schemas.microsoft.com/office/drawing/2014/main" id="{FA3DF8CE-3AE2-4B63-8881-98EEB276BC15}"/>
+                <a16:creationId xmlns:a16="http://schemas.microsoft.com/office/drawing/2014/main" id="{AB521F83-B896-4EB1-B1A6-538C12D09E5A}"/>
               </a:ext>
             </a:extLst>
           </p:cNvPr>
@@ -7263,7 +7263,7 @@
           <p:cNvPr id="3" name="header-rule">
             <a:extLst xmlns:a="http://schemas.openxmlformats.org/drawingml/2006/main">
               <a:ext uri="{FF2B5EF4-FFF2-40B4-BE49-F238E27FC236}">
-                <a16:creationId xmlns:a16="http://schemas.microsoft.com/office/drawing/2014/main" id="{E2185E88-D5C8-4400-95C2-CEBACF27E125}"/>
+                <a16:creationId xmlns:a16="http://schemas.microsoft.com/office/drawing/2014/main" id="{44D693CB-BF0B-4BE4-9156-7EA0F3822DEE}"/>
               </a:ext>
             </a:extLst>
           </p:cNvPr>
@@ -7294,7 +7294,7 @@
           <p:cNvPr id="4" name="slide-title">
             <a:extLst xmlns:a="http://schemas.openxmlformats.org/drawingml/2006/main">
               <a:ext uri="{FF2B5EF4-FFF2-40B4-BE49-F238E27FC236}">
-                <a16:creationId xmlns:a16="http://schemas.microsoft.com/office/drawing/2014/main" id="{BE452F96-66BB-4343-B4ED-8C875E48E8B5}"/>
+                <a16:creationId xmlns:a16="http://schemas.microsoft.com/office/drawing/2014/main" id="{00D43619-7701-4FA0-9539-CA71024E0884}"/>
               </a:ext>
             </a:extLst>
           </p:cNvPr>
@@ -7360,7 +7360,7 @@
           <p:nvPr/>
         </p:nvPicPr>
         <p:blipFill>
-          <a:blip xmlns:r="http://schemas.openxmlformats.org/officeDocument/2006/relationships" xmlns:a="http://schemas.openxmlformats.org/drawingml/2006/main" r:embed="R5f7f7a83100c43c2"/>
+          <a:blip xmlns:r="http://schemas.openxmlformats.org/officeDocument/2006/relationships" xmlns:a="http://schemas.openxmlformats.org/drawingml/2006/main" r:embed="Rb918ad3a256c4507"/>
           <a:stretch xmlns:a="http://schemas.openxmlformats.org/drawingml/2006/main"/>
         </p:blipFill>
         <p:spPr>
@@ -7380,7 +7380,7 @@
           <p:cNvPr id="6" name="image-caption-140">
             <a:extLst xmlns:a="http://schemas.openxmlformats.org/drawingml/2006/main">
               <a:ext uri="{FF2B5EF4-FFF2-40B4-BE49-F238E27FC236}">
-                <a16:creationId xmlns:a16="http://schemas.microsoft.com/office/drawing/2014/main" id="{BD507D24-8A91-4611-8780-9A36A769E329}"/>
+                <a16:creationId xmlns:a16="http://schemas.microsoft.com/office/drawing/2014/main" id="{3FC9C9FC-B49E-429A-AAD1-5CE334C2D94C}"/>
               </a:ext>
             </a:extLst>
           </p:cNvPr>
@@ -7442,7 +7442,7 @@
           <p:cNvPr id="7" name="bullets-524">
             <a:extLst xmlns:a="http://schemas.openxmlformats.org/drawingml/2006/main">
               <a:ext uri="{FF2B5EF4-FFF2-40B4-BE49-F238E27FC236}">
-                <a16:creationId xmlns:a16="http://schemas.microsoft.com/office/drawing/2014/main" id="{E154D557-71AE-47BE-9D1D-965E70EC62FF}"/>
+                <a16:creationId xmlns:a16="http://schemas.microsoft.com/office/drawing/2014/main" id="{F76C6242-4C12-43B9-B04A-FB560B81C366}"/>
               </a:ext>
             </a:extLst>
           </p:cNvPr>
@@ -7567,7 +7567,7 @@
           <p:cNvPr id="8" name="paragraph-675.28">
             <a:extLst xmlns:a="http://schemas.openxmlformats.org/drawingml/2006/main">
               <a:ext uri="{FF2B5EF4-FFF2-40B4-BE49-F238E27FC236}">
-                <a16:creationId xmlns:a16="http://schemas.microsoft.com/office/drawing/2014/main" id="{0979C4E0-ACBD-4CB0-BD14-D0762C78A634}"/>
+                <a16:creationId xmlns:a16="http://schemas.microsoft.com/office/drawing/2014/main" id="{608D8542-580B-4479-802F-DF365E8BF9EB}"/>
               </a:ext>
             </a:extLst>
           </p:cNvPr>
@@ -7627,7 +7627,7 @@
     </p:spTree>
     <p:extLst>
       <p:ext uri="{BB962C8B-B14F-4D97-AF65-F5344CB8AC3E}">
-        <p14:creationId xmlns:p14="http://schemas.microsoft.com/office/powerpoint/2010/main" val="526992792"/>
+        <p14:creationId xmlns:p14="http://schemas.microsoft.com/office/powerpoint/2010/main" val="606315692"/>
       </p:ext>
     </p:extLst>
   </p:cSld>
@@ -7658,7 +7658,7 @@
           <p:cNvPr id="7" name="running-label">
             <a:extLst xmlns:a="http://schemas.openxmlformats.org/drawingml/2006/main">
               <a:ext uri="{FF2B5EF4-FFF2-40B4-BE49-F238E27FC236}">
-                <a16:creationId xmlns:a16="http://schemas.microsoft.com/office/drawing/2014/main" id="{E762C7B3-5FF2-464D-825C-941F4FF074AE}"/>
+                <a16:creationId xmlns:a16="http://schemas.microsoft.com/office/drawing/2014/main" id="{B194A385-D1C3-4CDA-AB29-4BD985474B8C}"/>
               </a:ext>
             </a:extLst>
           </p:cNvPr>
@@ -7720,7 +7720,7 @@
           <p:cNvPr id="2" name="page-number">
             <a:extLst xmlns:a="http://schemas.openxmlformats.org/drawingml/2006/main">
               <a:ext uri="{FF2B5EF4-FFF2-40B4-BE49-F238E27FC236}">
-                <a16:creationId xmlns:a16="http://schemas.microsoft.com/office/drawing/2014/main" id="{BB78A1EB-C93E-4935-A160-DCA94CD998FD}"/>
+                <a16:creationId xmlns:a16="http://schemas.microsoft.com/office/drawing/2014/main" id="{ABAF0F59-F2E8-4D00-8600-0EC7B8D0ACE1}"/>
               </a:ext>
             </a:extLst>
           </p:cNvPr>
@@ -7782,7 +7782,7 @@
           <p:cNvPr id="3" name="header-rule">
             <a:extLst xmlns:a="http://schemas.openxmlformats.org/drawingml/2006/main">
               <a:ext uri="{FF2B5EF4-FFF2-40B4-BE49-F238E27FC236}">
-                <a16:creationId xmlns:a16="http://schemas.microsoft.com/office/drawing/2014/main" id="{6C470168-147A-4498-85B6-016B361A1946}"/>
+                <a16:creationId xmlns:a16="http://schemas.microsoft.com/office/drawing/2014/main" id="{39E2855C-2409-4F0F-B141-277D672C8D39}"/>
               </a:ext>
             </a:extLst>
           </p:cNvPr>
@@ -7813,7 +7813,7 @@
           <p:cNvPr id="4" name="slide-title">
             <a:extLst xmlns:a="http://schemas.openxmlformats.org/drawingml/2006/main">
               <a:ext uri="{FF2B5EF4-FFF2-40B4-BE49-F238E27FC236}">
-                <a16:creationId xmlns:a16="http://schemas.microsoft.com/office/drawing/2014/main" id="{2780DBF6-E73F-4307-9505-01C24DD67B5C}"/>
+                <a16:creationId xmlns:a16="http://schemas.microsoft.com/office/drawing/2014/main" id="{52182B53-CCFA-45D7-87FA-68486FCEDA1D}"/>
               </a:ext>
             </a:extLst>
           </p:cNvPr>
@@ -7879,7 +7879,7 @@
           <p:nvPr/>
         </p:nvPicPr>
         <p:blipFill>
-          <a:blip xmlns:r="http://schemas.openxmlformats.org/officeDocument/2006/relationships" xmlns:a="http://schemas.openxmlformats.org/drawingml/2006/main" r:embed="R045aee1eb0ad4afa"/>
+          <a:blip xmlns:r="http://schemas.openxmlformats.org/officeDocument/2006/relationships" xmlns:a="http://schemas.openxmlformats.org/drawingml/2006/main" r:embed="Ra48e3dcb16704bbe"/>
           <a:stretch xmlns:a="http://schemas.openxmlformats.org/drawingml/2006/main"/>
         </p:blipFill>
         <p:spPr>
@@ -7899,7 +7899,7 @@
           <p:cNvPr id="6" name="image-caption-140">
             <a:extLst xmlns:a="http://schemas.openxmlformats.org/drawingml/2006/main">
               <a:ext uri="{FF2B5EF4-FFF2-40B4-BE49-F238E27FC236}">
-                <a16:creationId xmlns:a16="http://schemas.microsoft.com/office/drawing/2014/main" id="{9DBB339A-66F3-4276-95CE-95108327D3EC}"/>
+                <a16:creationId xmlns:a16="http://schemas.microsoft.com/office/drawing/2014/main" id="{221263A2-3FD5-4005-BF3D-7E5D9F23060D}"/>
               </a:ext>
             </a:extLst>
           </p:cNvPr>
@@ -7959,7 +7959,7 @@
     </p:spTree>
     <p:extLst>
       <p:ext uri="{BB962C8B-B14F-4D97-AF65-F5344CB8AC3E}">
-        <p14:creationId xmlns:p14="http://schemas.microsoft.com/office/powerpoint/2010/main" val="814376465"/>
+        <p14:creationId xmlns:p14="http://schemas.microsoft.com/office/powerpoint/2010/main" val="1552943969"/>
       </p:ext>
     </p:extLst>
   </p:cSld>
@@ -7990,7 +7990,7 @@
           <p:cNvPr id="103" name="running-label">
             <a:extLst xmlns:a="http://schemas.openxmlformats.org/drawingml/2006/main">
               <a:ext uri="{FF2B5EF4-FFF2-40B4-BE49-F238E27FC236}">
-                <a16:creationId xmlns:a16="http://schemas.microsoft.com/office/drawing/2014/main" id="{AA508BBD-7705-45A3-B272-78881195AD4D}"/>
+                <a16:creationId xmlns:a16="http://schemas.microsoft.com/office/drawing/2014/main" id="{E3BB1FEF-C80E-4479-BC89-1B86335B7140}"/>
               </a:ext>
             </a:extLst>
           </p:cNvPr>
@@ -8052,7 +8052,7 @@
           <p:cNvPr id="2" name="page-number">
             <a:extLst xmlns:a="http://schemas.openxmlformats.org/drawingml/2006/main">
               <a:ext uri="{FF2B5EF4-FFF2-40B4-BE49-F238E27FC236}">
-                <a16:creationId xmlns:a16="http://schemas.microsoft.com/office/drawing/2014/main" id="{5F40320E-24D6-4DD4-BBC1-CBB6DE9197ED}"/>
+                <a16:creationId xmlns:a16="http://schemas.microsoft.com/office/drawing/2014/main" id="{3509487E-FBE9-4160-B1D3-F94D205F03C0}"/>
               </a:ext>
             </a:extLst>
           </p:cNvPr>
@@ -8114,7 +8114,7 @@
           <p:cNvPr id="3" name="header-rule">
             <a:extLst xmlns:a="http://schemas.openxmlformats.org/drawingml/2006/main">
               <a:ext uri="{FF2B5EF4-FFF2-40B4-BE49-F238E27FC236}">
-                <a16:creationId xmlns:a16="http://schemas.microsoft.com/office/drawing/2014/main" id="{910C9A89-CCB8-43BA-A937-A7F5B85FD08B}"/>
+                <a16:creationId xmlns:a16="http://schemas.microsoft.com/office/drawing/2014/main" id="{44D774BC-9ADB-48C5-AD47-84E7E7A8827A}"/>
               </a:ext>
             </a:extLst>
           </p:cNvPr>
@@ -8145,7 +8145,7 @@
           <p:cNvPr id="4" name="slide-title">
             <a:extLst xmlns:a="http://schemas.openxmlformats.org/drawingml/2006/main">
               <a:ext uri="{FF2B5EF4-FFF2-40B4-BE49-F238E27FC236}">
-                <a16:creationId xmlns:a16="http://schemas.microsoft.com/office/drawing/2014/main" id="{73C24E29-A651-40B0-8D71-EE8EE35E4B3C}"/>
+                <a16:creationId xmlns:a16="http://schemas.microsoft.com/office/drawing/2014/main" id="{EFC7C6DC-DD4F-49C0-A4F4-5309CEF3E09B}"/>
               </a:ext>
             </a:extLst>
           </p:cNvPr>
@@ -8207,7 +8207,7 @@
           <p:cNvPr id="5" name="subheading-140">
             <a:extLst xmlns:a="http://schemas.openxmlformats.org/drawingml/2006/main">
               <a:ext uri="{FF2B5EF4-FFF2-40B4-BE49-F238E27FC236}">
-                <a16:creationId xmlns:a16="http://schemas.microsoft.com/office/drawing/2014/main" id="{B50BEAD5-AC7E-41BC-BD03-3F917D357759}"/>
+                <a16:creationId xmlns:a16="http://schemas.microsoft.com/office/drawing/2014/main" id="{2ECFB253-156E-42CA-8117-A51971D7DF7E}"/>
               </a:ext>
             </a:extLst>
           </p:cNvPr>
@@ -8269,7 +8269,7 @@
           <p:cNvPr id="6" name="table-cell-194-0-0">
             <a:extLst xmlns:a="http://schemas.openxmlformats.org/drawingml/2006/main">
               <a:ext uri="{FF2B5EF4-FFF2-40B4-BE49-F238E27FC236}">
-                <a16:creationId xmlns:a16="http://schemas.microsoft.com/office/drawing/2014/main" id="{B92E0BBF-7BEC-4EE4-8058-9E66253804A1}"/>
+                <a16:creationId xmlns:a16="http://schemas.microsoft.com/office/drawing/2014/main" id="{CA6F96FD-1927-464E-93BF-138EB58ACD2E}"/>
               </a:ext>
             </a:extLst>
           </p:cNvPr>
@@ -8302,7 +8302,7 @@
           <p:cNvPr id="7" name="table-text-194-0-0">
             <a:extLst xmlns:a="http://schemas.openxmlformats.org/drawingml/2006/main">
               <a:ext uri="{FF2B5EF4-FFF2-40B4-BE49-F238E27FC236}">
-                <a16:creationId xmlns:a16="http://schemas.microsoft.com/office/drawing/2014/main" id="{E5387D9E-07CD-44C4-BF31-D7F88CF3A193}"/>
+                <a16:creationId xmlns:a16="http://schemas.microsoft.com/office/drawing/2014/main" id="{8A955B13-34B0-4357-B4FF-2A25C0A0AC70}"/>
               </a:ext>
             </a:extLst>
           </p:cNvPr>
@@ -8364,7 +8364,7 @@
           <p:cNvPr id="8" name="table-cell-194-0-1">
             <a:extLst xmlns:a="http://schemas.openxmlformats.org/drawingml/2006/main">
               <a:ext uri="{FF2B5EF4-FFF2-40B4-BE49-F238E27FC236}">
-                <a16:creationId xmlns:a16="http://schemas.microsoft.com/office/drawing/2014/main" id="{DAFF4054-7090-4C40-8305-EE220234BC4C}"/>
+                <a16:creationId xmlns:a16="http://schemas.microsoft.com/office/drawing/2014/main" id="{2B571D2A-3380-4317-B6A5-95F687A1638B}"/>
               </a:ext>
             </a:extLst>
           </p:cNvPr>
@@ -8397,7 +8397,7 @@
           <p:cNvPr id="9" name="table-text-194-0-1">
             <a:extLst xmlns:a="http://schemas.openxmlformats.org/drawingml/2006/main">
               <a:ext uri="{FF2B5EF4-FFF2-40B4-BE49-F238E27FC236}">
-                <a16:creationId xmlns:a16="http://schemas.microsoft.com/office/drawing/2014/main" id="{94BD6DDC-F0F4-4F36-AE01-86C493F934FA}"/>
+                <a16:creationId xmlns:a16="http://schemas.microsoft.com/office/drawing/2014/main" id="{E8B64070-87BD-45C9-B302-9337FC0191A3}"/>
               </a:ext>
             </a:extLst>
           </p:cNvPr>
@@ -8459,7 +8459,7 @@
           <p:cNvPr id="10" name="table-cell-194-0-2">
             <a:extLst xmlns:a="http://schemas.openxmlformats.org/drawingml/2006/main">
               <a:ext uri="{FF2B5EF4-FFF2-40B4-BE49-F238E27FC236}">
-                <a16:creationId xmlns:a16="http://schemas.microsoft.com/office/drawing/2014/main" id="{6AAD8461-0C01-47E1-84A2-8325BBAA355D}"/>
+                <a16:creationId xmlns:a16="http://schemas.microsoft.com/office/drawing/2014/main" id="{629E5E5D-D4CC-4006-ABC9-38B1693E4357}"/>
               </a:ext>
             </a:extLst>
           </p:cNvPr>
@@ -8492,7 +8492,7 @@
           <p:cNvPr id="11" name="table-text-194-0-2">
             <a:extLst xmlns:a="http://schemas.openxmlformats.org/drawingml/2006/main">
               <a:ext uri="{FF2B5EF4-FFF2-40B4-BE49-F238E27FC236}">
-                <a16:creationId xmlns:a16="http://schemas.microsoft.com/office/drawing/2014/main" id="{868A2A9E-51AD-46EA-9DBA-EB06BC4C5045}"/>
+                <a16:creationId xmlns:a16="http://schemas.microsoft.com/office/drawing/2014/main" id="{84828715-DE66-49F0-98A9-10DC85CDBE46}"/>
               </a:ext>
             </a:extLst>
           </p:cNvPr>
@@ -8554,7 +8554,7 @@
           <p:cNvPr id="12" name="table-cell-194-0-3">
             <a:extLst xmlns:a="http://schemas.openxmlformats.org/drawingml/2006/main">
               <a:ext uri="{FF2B5EF4-FFF2-40B4-BE49-F238E27FC236}">
-                <a16:creationId xmlns:a16="http://schemas.microsoft.com/office/drawing/2014/main" id="{2DB7FD45-F4BB-49B4-A705-ECD293C61B98}"/>
+                <a16:creationId xmlns:a16="http://schemas.microsoft.com/office/drawing/2014/main" id="{529784FD-626A-4E67-8F3A-010767FCB33C}"/>
               </a:ext>
             </a:extLst>
           </p:cNvPr>
@@ -8587,7 +8587,7 @@
           <p:cNvPr id="13" name="table-text-194-0-3">
             <a:extLst xmlns:a="http://schemas.openxmlformats.org/drawingml/2006/main">
               <a:ext uri="{FF2B5EF4-FFF2-40B4-BE49-F238E27FC236}">
-                <a16:creationId xmlns:a16="http://schemas.microsoft.com/office/drawing/2014/main" id="{EA4F1470-1F2B-4026-9E65-3D121935D2BB}"/>
+                <a16:creationId xmlns:a16="http://schemas.microsoft.com/office/drawing/2014/main" id="{57636E65-F131-497A-A97F-76F083426490}"/>
               </a:ext>
             </a:extLst>
           </p:cNvPr>
@@ -8649,7 +8649,7 @@
           <p:cNvPr id="14" name="table-cell-194-1-0">
             <a:extLst xmlns:a="http://schemas.openxmlformats.org/drawingml/2006/main">
               <a:ext uri="{FF2B5EF4-FFF2-40B4-BE49-F238E27FC236}">
-                <a16:creationId xmlns:a16="http://schemas.microsoft.com/office/drawing/2014/main" id="{B2C4D341-DD63-447B-AAFF-71AE1ACA1AFB}"/>
+                <a16:creationId xmlns:a16="http://schemas.microsoft.com/office/drawing/2014/main" id="{DF42CDAF-B116-48C1-94AB-6E01AA8DC3F0}"/>
               </a:ext>
             </a:extLst>
           </p:cNvPr>
@@ -8682,7 +8682,7 @@
           <p:cNvPr id="15" name="table-text-194-1-0">
             <a:extLst xmlns:a="http://schemas.openxmlformats.org/drawingml/2006/main">
               <a:ext uri="{FF2B5EF4-FFF2-40B4-BE49-F238E27FC236}">
-                <a16:creationId xmlns:a16="http://schemas.microsoft.com/office/drawing/2014/main" id="{51C4FE92-A2D3-4FB3-A148-A24322DAF500}"/>
+                <a16:creationId xmlns:a16="http://schemas.microsoft.com/office/drawing/2014/main" id="{61AAF227-5DE0-4E2D-9B63-6A1AA6E65112}"/>
               </a:ext>
             </a:extLst>
           </p:cNvPr>
@@ -8744,7 +8744,7 @@
           <p:cNvPr id="16" name="table-cell-194-1-1">
             <a:extLst xmlns:a="http://schemas.openxmlformats.org/drawingml/2006/main">
               <a:ext uri="{FF2B5EF4-FFF2-40B4-BE49-F238E27FC236}">
-                <a16:creationId xmlns:a16="http://schemas.microsoft.com/office/drawing/2014/main" id="{6F60E044-9F47-4EC7-98B8-C47E5231BA26}"/>
+                <a16:creationId xmlns:a16="http://schemas.microsoft.com/office/drawing/2014/main" id="{881592BE-C39E-4D20-AD32-6221ECE45990}"/>
               </a:ext>
             </a:extLst>
           </p:cNvPr>
@@ -8777,7 +8777,7 @@
           <p:cNvPr id="17" name="table-text-194-1-1">
             <a:extLst xmlns:a="http://schemas.openxmlformats.org/drawingml/2006/main">
               <a:ext uri="{FF2B5EF4-FFF2-40B4-BE49-F238E27FC236}">
-                <a16:creationId xmlns:a16="http://schemas.microsoft.com/office/drawing/2014/main" id="{FEB58DE4-5732-4286-BC55-B5C54812750C}"/>
+                <a16:creationId xmlns:a16="http://schemas.microsoft.com/office/drawing/2014/main" id="{0129C553-A012-49FE-9584-B4F028E5C3EA}"/>
               </a:ext>
             </a:extLst>
           </p:cNvPr>
@@ -8839,7 +8839,7 @@
           <p:cNvPr id="18" name="table-cell-194-1-2">
             <a:extLst xmlns:a="http://schemas.openxmlformats.org/drawingml/2006/main">
               <a:ext uri="{FF2B5EF4-FFF2-40B4-BE49-F238E27FC236}">
-                <a16:creationId xmlns:a16="http://schemas.microsoft.com/office/drawing/2014/main" id="{39EB981B-E7A4-40D8-B5B9-8414CFB05A89}"/>
+                <a16:creationId xmlns:a16="http://schemas.microsoft.com/office/drawing/2014/main" id="{7D23125F-B66F-4C8A-8A1D-FF76C57A536C}"/>
               </a:ext>
             </a:extLst>
           </p:cNvPr>
@@ -8872,7 +8872,7 @@
           <p:cNvPr id="19" name="table-text-194-1-2">
             <a:extLst xmlns:a="http://schemas.openxmlformats.org/drawingml/2006/main">
               <a:ext uri="{FF2B5EF4-FFF2-40B4-BE49-F238E27FC236}">
-                <a16:creationId xmlns:a16="http://schemas.microsoft.com/office/drawing/2014/main" id="{E26162CC-25F4-4503-8936-2893194F5B53}"/>
+                <a16:creationId xmlns:a16="http://schemas.microsoft.com/office/drawing/2014/main" id="{44E9F890-CA83-4EA0-92E7-EE7452309EDB}"/>
               </a:ext>
             </a:extLst>
           </p:cNvPr>
@@ -8934,7 +8934,7 @@
           <p:cNvPr id="20" name="table-cell-194-1-3">
             <a:extLst xmlns:a="http://schemas.openxmlformats.org/drawingml/2006/main">
               <a:ext uri="{FF2B5EF4-FFF2-40B4-BE49-F238E27FC236}">
-                <a16:creationId xmlns:a16="http://schemas.microsoft.com/office/drawing/2014/main" id="{117FCA5C-1269-4EE8-BCBE-3C4E7DBA5CD0}"/>
+                <a16:creationId xmlns:a16="http://schemas.microsoft.com/office/drawing/2014/main" id="{63D9D0C2-0618-43C7-B54F-3F3332C4C4FA}"/>
               </a:ext>
             </a:extLst>
           </p:cNvPr>
@@ -8967,7 +8967,7 @@
           <p:cNvPr id="21" name="table-text-194-1-3">
             <a:extLst xmlns:a="http://schemas.openxmlformats.org/drawingml/2006/main">
               <a:ext uri="{FF2B5EF4-FFF2-40B4-BE49-F238E27FC236}">
-                <a16:creationId xmlns:a16="http://schemas.microsoft.com/office/drawing/2014/main" id="{23BD8AC3-CD78-4316-B03A-D38DCC43615D}"/>
+                <a16:creationId xmlns:a16="http://schemas.microsoft.com/office/drawing/2014/main" id="{AAF2F984-E985-4881-BA46-3BBA7C88A565}"/>
               </a:ext>
             </a:extLst>
           </p:cNvPr>
@@ -8992,7 +8992,7 @@
         </p:spPr>
         <p:txBody>
           <a:bodyPr xmlns:a="http://schemas.openxmlformats.org/drawingml/2006/main" lIns="0" tIns="0" rIns="0" bIns="0" anchor="t">
-            <a:normAutofit fontScale="100000"/>
+            <a:normAutofit fontScale="98319"/>
           </a:bodyPr>
           <a:lstStyle xmlns:a="http://schemas.openxmlformats.org/drawingml/2006/main"/>
           <a:p xmlns:a="http://schemas.openxmlformats.org/drawingml/2006/main">
@@ -9029,7 +9029,7 @@
           <p:cNvPr id="22" name="table-cell-194-2-0">
             <a:extLst xmlns:a="http://schemas.openxmlformats.org/drawingml/2006/main">
               <a:ext uri="{FF2B5EF4-FFF2-40B4-BE49-F238E27FC236}">
-                <a16:creationId xmlns:a16="http://schemas.microsoft.com/office/drawing/2014/main" id="{D52DB0A2-AD34-449E-AE48-393DCDED0705}"/>
+                <a16:creationId xmlns:a16="http://schemas.microsoft.com/office/drawing/2014/main" id="{8533A540-0AE9-4C06-8BC9-7D31D9CEE600}"/>
               </a:ext>
             </a:extLst>
           </p:cNvPr>
@@ -9062,7 +9062,7 @@
           <p:cNvPr id="23" name="table-text-194-2-0">
             <a:extLst xmlns:a="http://schemas.openxmlformats.org/drawingml/2006/main">
               <a:ext uri="{FF2B5EF4-FFF2-40B4-BE49-F238E27FC236}">
-                <a16:creationId xmlns:a16="http://schemas.microsoft.com/office/drawing/2014/main" id="{FE95AC97-0A2D-4A1E-88CA-8286DB0C6C77}"/>
+                <a16:creationId xmlns:a16="http://schemas.microsoft.com/office/drawing/2014/main" id="{D4F9B669-2C54-4992-88C8-D5D172D5D890}"/>
               </a:ext>
             </a:extLst>
           </p:cNvPr>
@@ -9124,7 +9124,7 @@
           <p:cNvPr id="24" name="table-cell-194-2-1">
             <a:extLst xmlns:a="http://schemas.openxmlformats.org/drawingml/2006/main">
               <a:ext uri="{FF2B5EF4-FFF2-40B4-BE49-F238E27FC236}">
-                <a16:creationId xmlns:a16="http://schemas.microsoft.com/office/drawing/2014/main" id="{B63D3968-22DA-4113-8D82-355399F737F4}"/>
+                <a16:creationId xmlns:a16="http://schemas.microsoft.com/office/drawing/2014/main" id="{620C3561-0CB6-4E7A-977E-882156F84BD6}"/>
               </a:ext>
             </a:extLst>
           </p:cNvPr>
@@ -9157,7 +9157,7 @@
           <p:cNvPr id="25" name="table-text-194-2-1">
             <a:extLst xmlns:a="http://schemas.openxmlformats.org/drawingml/2006/main">
               <a:ext uri="{FF2B5EF4-FFF2-40B4-BE49-F238E27FC236}">
-                <a16:creationId xmlns:a16="http://schemas.microsoft.com/office/drawing/2014/main" id="{1935B8A4-A247-4D0D-AD9D-975FF4F021C3}"/>
+                <a16:creationId xmlns:a16="http://schemas.microsoft.com/office/drawing/2014/main" id="{62AE6806-97FA-4E44-9DF4-8CB703E912D6}"/>
               </a:ext>
             </a:extLst>
           </p:cNvPr>
@@ -9219,7 +9219,7 @@
           <p:cNvPr id="26" name="table-cell-194-2-2">
             <a:extLst xmlns:a="http://schemas.openxmlformats.org/drawingml/2006/main">
               <a:ext uri="{FF2B5EF4-FFF2-40B4-BE49-F238E27FC236}">
-                <a16:creationId xmlns:a16="http://schemas.microsoft.com/office/drawing/2014/main" id="{A848A73B-EFF2-4251-9E94-4238DA6E02F2}"/>
+                <a16:creationId xmlns:a16="http://schemas.microsoft.com/office/drawing/2014/main" id="{52844883-D8EB-46EB-8283-75C79378EAFD}"/>
               </a:ext>
             </a:extLst>
           </p:cNvPr>
@@ -9252,7 +9252,7 @@
           <p:cNvPr id="27" name="table-text-194-2-2">
             <a:extLst xmlns:a="http://schemas.openxmlformats.org/drawingml/2006/main">
               <a:ext uri="{FF2B5EF4-FFF2-40B4-BE49-F238E27FC236}">
-                <a16:creationId xmlns:a16="http://schemas.microsoft.com/office/drawing/2014/main" id="{4F36143C-1AC4-46BD-B426-355E88A323EE}"/>
+                <a16:creationId xmlns:a16="http://schemas.microsoft.com/office/drawing/2014/main" id="{E50C4BA0-F8CA-4BBC-A40C-90B517A98835}"/>
               </a:ext>
             </a:extLst>
           </p:cNvPr>
@@ -9314,7 +9314,7 @@
           <p:cNvPr id="28" name="table-cell-194-2-3">
             <a:extLst xmlns:a="http://schemas.openxmlformats.org/drawingml/2006/main">
               <a:ext uri="{FF2B5EF4-FFF2-40B4-BE49-F238E27FC236}">
-                <a16:creationId xmlns:a16="http://schemas.microsoft.com/office/drawing/2014/main" id="{ADB5B8F8-9C36-4358-B5C7-4FFBD102DCA0}"/>
+                <a16:creationId xmlns:a16="http://schemas.microsoft.com/office/drawing/2014/main" id="{B60DF553-0099-4B8D-BE04-AECFDA35FD31}"/>
               </a:ext>
             </a:extLst>
           </p:cNvPr>
@@ -9347,7 +9347,7 @@
           <p:cNvPr id="29" name="table-text-194-2-3">
             <a:extLst xmlns:a="http://schemas.openxmlformats.org/drawingml/2006/main">
               <a:ext uri="{FF2B5EF4-FFF2-40B4-BE49-F238E27FC236}">
-                <a16:creationId xmlns:a16="http://schemas.microsoft.com/office/drawing/2014/main" id="{7A767D78-DA65-4B27-B32A-83754F6836EF}"/>
+                <a16:creationId xmlns:a16="http://schemas.microsoft.com/office/drawing/2014/main" id="{6D72ACB8-F36C-4C83-952B-6DFEFDECC7D0}"/>
               </a:ext>
             </a:extLst>
           </p:cNvPr>
@@ -9372,7 +9372,7 @@
         </p:spPr>
         <p:txBody>
           <a:bodyPr xmlns:a="http://schemas.openxmlformats.org/drawingml/2006/main" lIns="0" tIns="0" rIns="0" bIns="0" anchor="t">
-            <a:normAutofit fontScale="78958"/>
+            <a:normAutofit fontScale="77358"/>
           </a:bodyPr>
           <a:lstStyle xmlns:a="http://schemas.openxmlformats.org/drawingml/2006/main"/>
           <a:p xmlns:a="http://schemas.openxmlformats.org/drawingml/2006/main">
@@ -9409,7 +9409,7 @@
           <p:cNvPr id="30" name="table-cell-194-3-0">
             <a:extLst xmlns:a="http://schemas.openxmlformats.org/drawingml/2006/main">
               <a:ext uri="{FF2B5EF4-FFF2-40B4-BE49-F238E27FC236}">
-                <a16:creationId xmlns:a16="http://schemas.microsoft.com/office/drawing/2014/main" id="{ABAD3364-7CCE-452E-AE00-3FCD772FCDAB}"/>
+                <a16:creationId xmlns:a16="http://schemas.microsoft.com/office/drawing/2014/main" id="{FA9A67F2-0DD3-4373-9225-A7A40E2BEB7B}"/>
               </a:ext>
             </a:extLst>
           </p:cNvPr>
@@ -9442,7 +9442,7 @@
           <p:cNvPr id="31" name="table-text-194-3-0">
             <a:extLst xmlns:a="http://schemas.openxmlformats.org/drawingml/2006/main">
               <a:ext uri="{FF2B5EF4-FFF2-40B4-BE49-F238E27FC236}">
-                <a16:creationId xmlns:a16="http://schemas.microsoft.com/office/drawing/2014/main" id="{5CD1E92A-11E7-482C-8359-237AE92EC014}"/>
+                <a16:creationId xmlns:a16="http://schemas.microsoft.com/office/drawing/2014/main" id="{0CB08AA0-615B-43F9-B8AD-DAF3FFC66475}"/>
               </a:ext>
             </a:extLst>
           </p:cNvPr>
@@ -9504,7 +9504,7 @@
           <p:cNvPr id="32" name="table-cell-194-3-1">
             <a:extLst xmlns:a="http://schemas.openxmlformats.org/drawingml/2006/main">
               <a:ext uri="{FF2B5EF4-FFF2-40B4-BE49-F238E27FC236}">
-                <a16:creationId xmlns:a16="http://schemas.microsoft.com/office/drawing/2014/main" id="{D62B62DE-CA34-4F6D-823A-F845A75FDF69}"/>
+                <a16:creationId xmlns:a16="http://schemas.microsoft.com/office/drawing/2014/main" id="{A09F1ED5-43B5-4732-B16E-EA50078FAA1D}"/>
               </a:ext>
             </a:extLst>
           </p:cNvPr>
@@ -9537,7 +9537,7 @@
           <p:cNvPr id="33" name="table-text-194-3-1">
             <a:extLst xmlns:a="http://schemas.openxmlformats.org/drawingml/2006/main">
               <a:ext uri="{FF2B5EF4-FFF2-40B4-BE49-F238E27FC236}">
-                <a16:creationId xmlns:a16="http://schemas.microsoft.com/office/drawing/2014/main" id="{0835D17C-9DB2-4CB2-BDC0-C7970345ADF0}"/>
+                <a16:creationId xmlns:a16="http://schemas.microsoft.com/office/drawing/2014/main" id="{C66933D2-E250-4262-BF8F-E722FE6B564F}"/>
               </a:ext>
             </a:extLst>
           </p:cNvPr>
@@ -9599,7 +9599,7 @@
           <p:cNvPr id="34" name="table-cell-194-3-2">
             <a:extLst xmlns:a="http://schemas.openxmlformats.org/drawingml/2006/main">
               <a:ext uri="{FF2B5EF4-FFF2-40B4-BE49-F238E27FC236}">
-                <a16:creationId xmlns:a16="http://schemas.microsoft.com/office/drawing/2014/main" id="{97AAEBD0-1BEA-40E4-9576-09F8EB599097}"/>
+                <a16:creationId xmlns:a16="http://schemas.microsoft.com/office/drawing/2014/main" id="{E94BAE54-2338-44DA-ABB9-D613FD8C8A97}"/>
               </a:ext>
             </a:extLst>
           </p:cNvPr>
@@ -9632,7 +9632,7 @@
           <p:cNvPr id="35" name="table-text-194-3-2">
             <a:extLst xmlns:a="http://schemas.openxmlformats.org/drawingml/2006/main">
               <a:ext uri="{FF2B5EF4-FFF2-40B4-BE49-F238E27FC236}">
-                <a16:creationId xmlns:a16="http://schemas.microsoft.com/office/drawing/2014/main" id="{ABEAE0C1-88C2-4BC7-92A4-CBEB37B5DE94}"/>
+                <a16:creationId xmlns:a16="http://schemas.microsoft.com/office/drawing/2014/main" id="{4A11BC5F-2429-400C-A5BC-C88614B71511}"/>
               </a:ext>
             </a:extLst>
           </p:cNvPr>
@@ -9694,7 +9694,7 @@
           <p:cNvPr id="36" name="table-cell-194-3-3">
             <a:extLst xmlns:a="http://schemas.openxmlformats.org/drawingml/2006/main">
               <a:ext uri="{FF2B5EF4-FFF2-40B4-BE49-F238E27FC236}">
-                <a16:creationId xmlns:a16="http://schemas.microsoft.com/office/drawing/2014/main" id="{C7FE9B6E-CBF1-4EC9-A917-5D97033D4B22}"/>
+                <a16:creationId xmlns:a16="http://schemas.microsoft.com/office/drawing/2014/main" id="{DC1B3CC6-3454-4B90-B406-2F32CF64DBF8}"/>
               </a:ext>
             </a:extLst>
           </p:cNvPr>
@@ -9727,7 +9727,7 @@
           <p:cNvPr id="37" name="table-text-194-3-3">
             <a:extLst xmlns:a="http://schemas.openxmlformats.org/drawingml/2006/main">
               <a:ext uri="{FF2B5EF4-FFF2-40B4-BE49-F238E27FC236}">
-                <a16:creationId xmlns:a16="http://schemas.microsoft.com/office/drawing/2014/main" id="{E90EAF61-0D59-4281-80FE-F5471F38EA56}"/>
+                <a16:creationId xmlns:a16="http://schemas.microsoft.com/office/drawing/2014/main" id="{4769E614-3760-4271-98A4-5EB4011BCF72}"/>
               </a:ext>
             </a:extLst>
           </p:cNvPr>
@@ -9789,7 +9789,7 @@
           <p:cNvPr id="38" name="table-cell-194-4-0">
             <a:extLst xmlns:a="http://schemas.openxmlformats.org/drawingml/2006/main">
               <a:ext uri="{FF2B5EF4-FFF2-40B4-BE49-F238E27FC236}">
-                <a16:creationId xmlns:a16="http://schemas.microsoft.com/office/drawing/2014/main" id="{DEE00430-0FC9-41E6-8722-BBD82FC79E22}"/>
+                <a16:creationId xmlns:a16="http://schemas.microsoft.com/office/drawing/2014/main" id="{E8FA6993-642D-419E-BCCF-22CEC2ACE0A0}"/>
               </a:ext>
             </a:extLst>
           </p:cNvPr>
@@ -9822,7 +9822,7 @@
           <p:cNvPr id="39" name="table-text-194-4-0">
             <a:extLst xmlns:a="http://schemas.openxmlformats.org/drawingml/2006/main">
               <a:ext uri="{FF2B5EF4-FFF2-40B4-BE49-F238E27FC236}">
-                <a16:creationId xmlns:a16="http://schemas.microsoft.com/office/drawing/2014/main" id="{3926CFA4-1D8A-49EA-8359-C12DE7319A56}"/>
+                <a16:creationId xmlns:a16="http://schemas.microsoft.com/office/drawing/2014/main" id="{3DC3BEF7-7C2B-4A77-94DA-A13CC182ECC7}"/>
               </a:ext>
             </a:extLst>
           </p:cNvPr>
@@ -9884,7 +9884,7 @@
           <p:cNvPr id="40" name="table-cell-194-4-1">
             <a:extLst xmlns:a="http://schemas.openxmlformats.org/drawingml/2006/main">
               <a:ext uri="{FF2B5EF4-FFF2-40B4-BE49-F238E27FC236}">
-                <a16:creationId xmlns:a16="http://schemas.microsoft.com/office/drawing/2014/main" id="{9F759D5F-7BAA-4105-B307-F9766A461BCF}"/>
+                <a16:creationId xmlns:a16="http://schemas.microsoft.com/office/drawing/2014/main" id="{99C53D6F-D83F-4CA7-A930-AC28BF9F4AA6}"/>
               </a:ext>
             </a:extLst>
           </p:cNvPr>
@@ -9917,7 +9917,7 @@
           <p:cNvPr id="41" name="table-text-194-4-1">
             <a:extLst xmlns:a="http://schemas.openxmlformats.org/drawingml/2006/main">
               <a:ext uri="{FF2B5EF4-FFF2-40B4-BE49-F238E27FC236}">
-                <a16:creationId xmlns:a16="http://schemas.microsoft.com/office/drawing/2014/main" id="{C58073B4-9D0C-4788-BA06-32E86BFDC96F}"/>
+                <a16:creationId xmlns:a16="http://schemas.microsoft.com/office/drawing/2014/main" id="{86D2E92E-48F0-4DE8-9590-BD844EE23CFD}"/>
               </a:ext>
             </a:extLst>
           </p:cNvPr>
@@ -9979,7 +9979,7 @@
           <p:cNvPr id="42" name="table-cell-194-4-2">
             <a:extLst xmlns:a="http://schemas.openxmlformats.org/drawingml/2006/main">
               <a:ext uri="{FF2B5EF4-FFF2-40B4-BE49-F238E27FC236}">
-                <a16:creationId xmlns:a16="http://schemas.microsoft.com/office/drawing/2014/main" id="{4690E277-5DF2-4C1E-89AA-F9646EEA4515}"/>
+                <a16:creationId xmlns:a16="http://schemas.microsoft.com/office/drawing/2014/main" id="{BFC6E21C-B284-4109-B8F4-D768721B4322}"/>
               </a:ext>
             </a:extLst>
           </p:cNvPr>
@@ -10012,7 +10012,7 @@
           <p:cNvPr id="43" name="table-text-194-4-2">
             <a:extLst xmlns:a="http://schemas.openxmlformats.org/drawingml/2006/main">
               <a:ext uri="{FF2B5EF4-FFF2-40B4-BE49-F238E27FC236}">
-                <a16:creationId xmlns:a16="http://schemas.microsoft.com/office/drawing/2014/main" id="{F823DA6A-55DA-458A-9E2C-763FAF790502}"/>
+                <a16:creationId xmlns:a16="http://schemas.microsoft.com/office/drawing/2014/main" id="{07439E71-7ECA-4782-AE6B-761CC0727818}"/>
               </a:ext>
             </a:extLst>
           </p:cNvPr>
@@ -10074,7 +10074,7 @@
           <p:cNvPr id="44" name="table-cell-194-4-3">
             <a:extLst xmlns:a="http://schemas.openxmlformats.org/drawingml/2006/main">
               <a:ext uri="{FF2B5EF4-FFF2-40B4-BE49-F238E27FC236}">
-                <a16:creationId xmlns:a16="http://schemas.microsoft.com/office/drawing/2014/main" id="{2A56173F-2B8E-4603-B584-BD7EAC895233}"/>
+                <a16:creationId xmlns:a16="http://schemas.microsoft.com/office/drawing/2014/main" id="{F28BAD0D-63C9-4ADD-BC1F-B631CFA6124F}"/>
               </a:ext>
             </a:extLst>
           </p:cNvPr>
@@ -10107,7 +10107,7 @@
           <p:cNvPr id="45" name="table-text-194-4-3">
             <a:extLst xmlns:a="http://schemas.openxmlformats.org/drawingml/2006/main">
               <a:ext uri="{FF2B5EF4-FFF2-40B4-BE49-F238E27FC236}">
-                <a16:creationId xmlns:a16="http://schemas.microsoft.com/office/drawing/2014/main" id="{AB14ED6F-E391-4A07-B887-7A1AC9C68ECC}"/>
+                <a16:creationId xmlns:a16="http://schemas.microsoft.com/office/drawing/2014/main" id="{6B212FE3-6180-4DBD-81E7-733E2A12F92B}"/>
               </a:ext>
             </a:extLst>
           </p:cNvPr>
@@ -10169,7 +10169,7 @@
           <p:cNvPr id="46" name="table-cell-194-5-0">
             <a:extLst xmlns:a="http://schemas.openxmlformats.org/drawingml/2006/main">
               <a:ext uri="{FF2B5EF4-FFF2-40B4-BE49-F238E27FC236}">
-                <a16:creationId xmlns:a16="http://schemas.microsoft.com/office/drawing/2014/main" id="{97F7EC79-79D1-48EE-BE26-06AC3EF0F0C9}"/>
+                <a16:creationId xmlns:a16="http://schemas.microsoft.com/office/drawing/2014/main" id="{A48D42C3-A2FD-42AC-9EF4-D0A2C0E56622}"/>
               </a:ext>
             </a:extLst>
           </p:cNvPr>
@@ -10202,7 +10202,7 @@
           <p:cNvPr id="47" name="table-text-194-5-0">
             <a:extLst xmlns:a="http://schemas.openxmlformats.org/drawingml/2006/main">
               <a:ext uri="{FF2B5EF4-FFF2-40B4-BE49-F238E27FC236}">
-                <a16:creationId xmlns:a16="http://schemas.microsoft.com/office/drawing/2014/main" id="{7C0688EF-1028-4FEE-BAA7-35DCDCAB233E}"/>
+                <a16:creationId xmlns:a16="http://schemas.microsoft.com/office/drawing/2014/main" id="{1F0D117A-EF27-4B7B-9B4A-635C809C0578}"/>
               </a:ext>
             </a:extLst>
           </p:cNvPr>
@@ -10264,7 +10264,7 @@
           <p:cNvPr id="48" name="table-cell-194-5-1">
             <a:extLst xmlns:a="http://schemas.openxmlformats.org/drawingml/2006/main">
               <a:ext uri="{FF2B5EF4-FFF2-40B4-BE49-F238E27FC236}">
-                <a16:creationId xmlns:a16="http://schemas.microsoft.com/office/drawing/2014/main" id="{FD88E32B-57C5-4BEA-ACA7-9FD0A12F2615}"/>
+                <a16:creationId xmlns:a16="http://schemas.microsoft.com/office/drawing/2014/main" id="{24DAA579-D85D-40C1-80B3-26B757301566}"/>
               </a:ext>
             </a:extLst>
           </p:cNvPr>
@@ -10297,7 +10297,7 @@
           <p:cNvPr id="49" name="table-text-194-5-1">
             <a:extLst xmlns:a="http://schemas.openxmlformats.org/drawingml/2006/main">
               <a:ext uri="{FF2B5EF4-FFF2-40B4-BE49-F238E27FC236}">
-                <a16:creationId xmlns:a16="http://schemas.microsoft.com/office/drawing/2014/main" id="{9BD455FB-D8C1-4714-A133-2918F58EB7F8}"/>
+                <a16:creationId xmlns:a16="http://schemas.microsoft.com/office/drawing/2014/main" id="{05686431-9F1E-4068-94D3-2B0AFC29AE92}"/>
               </a:ext>
             </a:extLst>
           </p:cNvPr>
@@ -10359,7 +10359,7 @@
           <p:cNvPr id="50" name="table-cell-194-5-2">
             <a:extLst xmlns:a="http://schemas.openxmlformats.org/drawingml/2006/main">
               <a:ext uri="{FF2B5EF4-FFF2-40B4-BE49-F238E27FC236}">
-                <a16:creationId xmlns:a16="http://schemas.microsoft.com/office/drawing/2014/main" id="{2664E17D-9954-43B8-96B2-ADA822A0478B}"/>
+                <a16:creationId xmlns:a16="http://schemas.microsoft.com/office/drawing/2014/main" id="{1288C0D4-F6F4-4A05-81DD-6B0FC0989665}"/>
               </a:ext>
             </a:extLst>
           </p:cNvPr>
@@ -10392,7 +10392,7 @@
           <p:cNvPr id="51" name="table-text-194-5-2">
             <a:extLst xmlns:a="http://schemas.openxmlformats.org/drawingml/2006/main">
               <a:ext uri="{FF2B5EF4-FFF2-40B4-BE49-F238E27FC236}">
-                <a16:creationId xmlns:a16="http://schemas.microsoft.com/office/drawing/2014/main" id="{81C9CD60-BC5D-4341-B7EF-EB9714B98512}"/>
+                <a16:creationId xmlns:a16="http://schemas.microsoft.com/office/drawing/2014/main" id="{A55ED8E1-FE6A-4919-9E9F-3E8F4F0E63DB}"/>
               </a:ext>
             </a:extLst>
           </p:cNvPr>
@@ -10454,7 +10454,7 @@
           <p:cNvPr id="52" name="table-cell-194-5-3">
             <a:extLst xmlns:a="http://schemas.openxmlformats.org/drawingml/2006/main">
               <a:ext uri="{FF2B5EF4-FFF2-40B4-BE49-F238E27FC236}">
-                <a16:creationId xmlns:a16="http://schemas.microsoft.com/office/drawing/2014/main" id="{A395298B-6522-411A-9537-4C5051722294}"/>
+                <a16:creationId xmlns:a16="http://schemas.microsoft.com/office/drawing/2014/main" id="{304D53BB-66F6-49B3-9F17-4A7898672442}"/>
               </a:ext>
             </a:extLst>
           </p:cNvPr>
@@ -10487,7 +10487,7 @@
           <p:cNvPr id="53" name="table-text-194-5-3">
             <a:extLst xmlns:a="http://schemas.openxmlformats.org/drawingml/2006/main">
               <a:ext uri="{FF2B5EF4-FFF2-40B4-BE49-F238E27FC236}">
-                <a16:creationId xmlns:a16="http://schemas.microsoft.com/office/drawing/2014/main" id="{0943BA5F-BC93-49E3-8AB9-1DD04AD6B947}"/>
+                <a16:creationId xmlns:a16="http://schemas.microsoft.com/office/drawing/2014/main" id="{74475426-D321-4589-927A-4E784763010D}"/>
               </a:ext>
             </a:extLst>
           </p:cNvPr>
@@ -10549,7 +10549,7 @@
           <p:cNvPr id="54" name="table-cell-194-6-0">
             <a:extLst xmlns:a="http://schemas.openxmlformats.org/drawingml/2006/main">
               <a:ext uri="{FF2B5EF4-FFF2-40B4-BE49-F238E27FC236}">
-                <a16:creationId xmlns:a16="http://schemas.microsoft.com/office/drawing/2014/main" id="{8F558593-B497-471D-ABB0-96014EEE6459}"/>
+                <a16:creationId xmlns:a16="http://schemas.microsoft.com/office/drawing/2014/main" id="{5A0F7C92-A653-4128-84DF-1D708549BCDA}"/>
               </a:ext>
             </a:extLst>
           </p:cNvPr>
@@ -10582,7 +10582,7 @@
           <p:cNvPr id="55" name="table-text-194-6-0">
             <a:extLst xmlns:a="http://schemas.openxmlformats.org/drawingml/2006/main">
               <a:ext uri="{FF2B5EF4-FFF2-40B4-BE49-F238E27FC236}">
-                <a16:creationId xmlns:a16="http://schemas.microsoft.com/office/drawing/2014/main" id="{75C378AD-6C1D-42CD-8A16-E75C13E34FDC}"/>
+                <a16:creationId xmlns:a16="http://schemas.microsoft.com/office/drawing/2014/main" id="{880B93FE-88A9-4573-93D5-37FAC1C17D52}"/>
               </a:ext>
             </a:extLst>
           </p:cNvPr>
@@ -10644,7 +10644,7 @@
           <p:cNvPr id="56" name="table-cell-194-6-1">
             <a:extLst xmlns:a="http://schemas.openxmlformats.org/drawingml/2006/main">
               <a:ext uri="{FF2B5EF4-FFF2-40B4-BE49-F238E27FC236}">
-                <a16:creationId xmlns:a16="http://schemas.microsoft.com/office/drawing/2014/main" id="{6E186AA6-4824-4CAD-B25B-497842E9D488}"/>
+                <a16:creationId xmlns:a16="http://schemas.microsoft.com/office/drawing/2014/main" id="{05B0F2E8-604C-460D-BB23-201408EFA34B}"/>
               </a:ext>
             </a:extLst>
           </p:cNvPr>
@@ -10677,7 +10677,7 @@
           <p:cNvPr id="57" name="table-text-194-6-1">
             <a:extLst xmlns:a="http://schemas.openxmlformats.org/drawingml/2006/main">
               <a:ext uri="{FF2B5EF4-FFF2-40B4-BE49-F238E27FC236}">
-                <a16:creationId xmlns:a16="http://schemas.microsoft.com/office/drawing/2014/main" id="{F91E154F-673A-4519-95FE-381A3BC5AE15}"/>
+                <a16:creationId xmlns:a16="http://schemas.microsoft.com/office/drawing/2014/main" id="{2AA21395-5822-4319-8FDC-814F4FB272F1}"/>
               </a:ext>
             </a:extLst>
           </p:cNvPr>
@@ -10739,7 +10739,7 @@
           <p:cNvPr id="58" name="table-cell-194-6-2">
             <a:extLst xmlns:a="http://schemas.openxmlformats.org/drawingml/2006/main">
               <a:ext uri="{FF2B5EF4-FFF2-40B4-BE49-F238E27FC236}">
-                <a16:creationId xmlns:a16="http://schemas.microsoft.com/office/drawing/2014/main" id="{98FB0CFB-FBD1-497F-9675-3C65854B065F}"/>
+                <a16:creationId xmlns:a16="http://schemas.microsoft.com/office/drawing/2014/main" id="{61C3C650-7F36-4EA1-907E-05747101C061}"/>
               </a:ext>
             </a:extLst>
           </p:cNvPr>
@@ -10772,7 +10772,7 @@
           <p:cNvPr id="59" name="table-text-194-6-2">
             <a:extLst xmlns:a="http://schemas.openxmlformats.org/drawingml/2006/main">
               <a:ext uri="{FF2B5EF4-FFF2-40B4-BE49-F238E27FC236}">
-                <a16:creationId xmlns:a16="http://schemas.microsoft.com/office/drawing/2014/main" id="{0893BAEB-BD6C-45AD-AC0F-AA983E0541E5}"/>
+                <a16:creationId xmlns:a16="http://schemas.microsoft.com/office/drawing/2014/main" id="{7B310604-FB7F-469A-8282-6833E38D39E9}"/>
               </a:ext>
             </a:extLst>
           </p:cNvPr>
@@ -10834,7 +10834,7 @@
           <p:cNvPr id="60" name="table-cell-194-6-3">
             <a:extLst xmlns:a="http://schemas.openxmlformats.org/drawingml/2006/main">
               <a:ext uri="{FF2B5EF4-FFF2-40B4-BE49-F238E27FC236}">
-                <a16:creationId xmlns:a16="http://schemas.microsoft.com/office/drawing/2014/main" id="{9299F5C6-B495-425E-886E-B8B397EB3640}"/>
+                <a16:creationId xmlns:a16="http://schemas.microsoft.com/office/drawing/2014/main" id="{95637B2D-80ED-46F0-A9A3-62C8C1A05A96}"/>
               </a:ext>
             </a:extLst>
           </p:cNvPr>
@@ -10867,7 +10867,7 @@
           <p:cNvPr id="61" name="table-text-194-6-3">
             <a:extLst xmlns:a="http://schemas.openxmlformats.org/drawingml/2006/main">
               <a:ext uri="{FF2B5EF4-FFF2-40B4-BE49-F238E27FC236}">
-                <a16:creationId xmlns:a16="http://schemas.microsoft.com/office/drawing/2014/main" id="{B7EA6CB0-8DB1-4882-BC6E-5B9333D3B859}"/>
+                <a16:creationId xmlns:a16="http://schemas.microsoft.com/office/drawing/2014/main" id="{A40A39F5-7E81-48C4-B7B4-57ADD2BC6401}"/>
               </a:ext>
             </a:extLst>
           </p:cNvPr>
@@ -10892,7 +10892,7 @@
         </p:spPr>
         <p:txBody>
           <a:bodyPr xmlns:a="http://schemas.openxmlformats.org/drawingml/2006/main" lIns="0" tIns="0" rIns="0" bIns="0" anchor="t">
-            <a:normAutofit fontScale="82296"/>
+            <a:normAutofit fontScale="77358"/>
           </a:bodyPr>
           <a:lstStyle xmlns:a="http://schemas.openxmlformats.org/drawingml/2006/main"/>
           <a:p xmlns:a="http://schemas.openxmlformats.org/drawingml/2006/main">
@@ -10929,7 +10929,7 @@
           <p:cNvPr id="62" name="table-cell-194-7-0">
             <a:extLst xmlns:a="http://schemas.openxmlformats.org/drawingml/2006/main">
               <a:ext uri="{FF2B5EF4-FFF2-40B4-BE49-F238E27FC236}">
-                <a16:creationId xmlns:a16="http://schemas.microsoft.com/office/drawing/2014/main" id="{EAD91186-49B6-4972-B125-367630609633}"/>
+                <a16:creationId xmlns:a16="http://schemas.microsoft.com/office/drawing/2014/main" id="{CE198A9E-2894-49EE-8C2F-9EB2CAF10EFB}"/>
               </a:ext>
             </a:extLst>
           </p:cNvPr>
@@ -10962,7 +10962,7 @@
           <p:cNvPr id="63" name="table-text-194-7-0">
             <a:extLst xmlns:a="http://schemas.openxmlformats.org/drawingml/2006/main">
               <a:ext uri="{FF2B5EF4-FFF2-40B4-BE49-F238E27FC236}">
-                <a16:creationId xmlns:a16="http://schemas.microsoft.com/office/drawing/2014/main" id="{0B447CFF-0AD2-4087-98D6-D31C05E4BC5B}"/>
+                <a16:creationId xmlns:a16="http://schemas.microsoft.com/office/drawing/2014/main" id="{EE78111E-FA64-4463-8D8C-288193E4EC30}"/>
               </a:ext>
             </a:extLst>
           </p:cNvPr>
@@ -11024,7 +11024,7 @@
           <p:cNvPr id="64" name="table-cell-194-7-1">
             <a:extLst xmlns:a="http://schemas.openxmlformats.org/drawingml/2006/main">
               <a:ext uri="{FF2B5EF4-FFF2-40B4-BE49-F238E27FC236}">
-                <a16:creationId xmlns:a16="http://schemas.microsoft.com/office/drawing/2014/main" id="{59E135AB-AF19-4DA3-8483-1AA84FB09B03}"/>
+                <a16:creationId xmlns:a16="http://schemas.microsoft.com/office/drawing/2014/main" id="{302D7F53-E7D7-4820-9F69-BA4492351AAE}"/>
               </a:ext>
             </a:extLst>
           </p:cNvPr>
@@ -11057,7 +11057,7 @@
           <p:cNvPr id="65" name="table-text-194-7-1">
             <a:extLst xmlns:a="http://schemas.openxmlformats.org/drawingml/2006/main">
               <a:ext uri="{FF2B5EF4-FFF2-40B4-BE49-F238E27FC236}">
-                <a16:creationId xmlns:a16="http://schemas.microsoft.com/office/drawing/2014/main" id="{9786168A-A405-4729-A1A2-BE33A58F16BA}"/>
+                <a16:creationId xmlns:a16="http://schemas.microsoft.com/office/drawing/2014/main" id="{06128016-884D-4992-B4FC-1F1BE138C9F3}"/>
               </a:ext>
             </a:extLst>
           </p:cNvPr>
@@ -11119,7 +11119,7 @@
           <p:cNvPr id="66" name="table-cell-194-7-2">
             <a:extLst xmlns:a="http://schemas.openxmlformats.org/drawingml/2006/main">
               <a:ext uri="{FF2B5EF4-FFF2-40B4-BE49-F238E27FC236}">
-                <a16:creationId xmlns:a16="http://schemas.microsoft.com/office/drawing/2014/main" id="{95A715FF-A7E8-4541-A591-3883BB5E59C5}"/>
+                <a16:creationId xmlns:a16="http://schemas.microsoft.com/office/drawing/2014/main" id="{A790F57E-7524-4EE1-A747-34E6CFFE5936}"/>
               </a:ext>
             </a:extLst>
           </p:cNvPr>
@@ -11152,7 +11152,7 @@
           <p:cNvPr id="67" name="table-text-194-7-2">
             <a:extLst xmlns:a="http://schemas.openxmlformats.org/drawingml/2006/main">
               <a:ext uri="{FF2B5EF4-FFF2-40B4-BE49-F238E27FC236}">
-                <a16:creationId xmlns:a16="http://schemas.microsoft.com/office/drawing/2014/main" id="{CA84908D-3698-4701-B755-EB3958BA3982}"/>
+                <a16:creationId xmlns:a16="http://schemas.microsoft.com/office/drawing/2014/main" id="{0FD584F4-B86A-4EA4-9F9E-186B657B69EA}"/>
               </a:ext>
             </a:extLst>
           </p:cNvPr>
@@ -11214,7 +11214,7 @@
           <p:cNvPr id="68" name="table-cell-194-7-3">
             <a:extLst xmlns:a="http://schemas.openxmlformats.org/drawingml/2006/main">
               <a:ext uri="{FF2B5EF4-FFF2-40B4-BE49-F238E27FC236}">
-                <a16:creationId xmlns:a16="http://schemas.microsoft.com/office/drawing/2014/main" id="{3F9AD58F-5F21-41D3-B804-2717430482DF}"/>
+                <a16:creationId xmlns:a16="http://schemas.microsoft.com/office/drawing/2014/main" id="{C1F37995-5C45-4C0F-8A93-33D1B7A4A20F}"/>
               </a:ext>
             </a:extLst>
           </p:cNvPr>
@@ -11247,7 +11247,7 @@
           <p:cNvPr id="69" name="table-text-194-7-3">
             <a:extLst xmlns:a="http://schemas.openxmlformats.org/drawingml/2006/main">
               <a:ext uri="{FF2B5EF4-FFF2-40B4-BE49-F238E27FC236}">
-                <a16:creationId xmlns:a16="http://schemas.microsoft.com/office/drawing/2014/main" id="{3D8A0E64-C9FD-4390-A25F-E323FD039DBC}"/>
+                <a16:creationId xmlns:a16="http://schemas.microsoft.com/office/drawing/2014/main" id="{25011A5F-CD86-423B-BEB4-DFC07AC40104}"/>
               </a:ext>
             </a:extLst>
           </p:cNvPr>
@@ -11272,7 +11272,7 @@
         </p:spPr>
         <p:txBody>
           <a:bodyPr xmlns:a="http://schemas.openxmlformats.org/drawingml/2006/main" lIns="0" tIns="0" rIns="0" bIns="0" anchor="t">
-            <a:normAutofit fontScale="87304"/>
+            <a:normAutofit fontScale="85612"/>
           </a:bodyPr>
           <a:lstStyle xmlns:a="http://schemas.openxmlformats.org/drawingml/2006/main"/>
           <a:p xmlns:a="http://schemas.openxmlformats.org/drawingml/2006/main">
@@ -11309,7 +11309,7 @@
           <p:cNvPr id="70" name="subheading-699.9000000000001">
             <a:extLst xmlns:a="http://schemas.openxmlformats.org/drawingml/2006/main">
               <a:ext uri="{FF2B5EF4-FFF2-40B4-BE49-F238E27FC236}">
-                <a16:creationId xmlns:a16="http://schemas.microsoft.com/office/drawing/2014/main" id="{537276B4-2A26-42A4-A745-2F74872C2CAC}"/>
+                <a16:creationId xmlns:a16="http://schemas.microsoft.com/office/drawing/2014/main" id="{0A0376E2-47C2-4B5E-9328-E330DB60F8DD}"/>
               </a:ext>
             </a:extLst>
           </p:cNvPr>
@@ -11371,7 +11371,7 @@
           <p:cNvPr id="71" name="table-cell-753.9000000000001-0-0">
             <a:extLst xmlns:a="http://schemas.openxmlformats.org/drawingml/2006/main">
               <a:ext uri="{FF2B5EF4-FFF2-40B4-BE49-F238E27FC236}">
-                <a16:creationId xmlns:a16="http://schemas.microsoft.com/office/drawing/2014/main" id="{29A058CF-D071-496C-8A72-9CE3C000C70C}"/>
+                <a16:creationId xmlns:a16="http://schemas.microsoft.com/office/drawing/2014/main" id="{93DC46BC-E52A-466E-9BA9-0B157B2C58DE}"/>
               </a:ext>
             </a:extLst>
           </p:cNvPr>
@@ -11404,7 +11404,7 @@
           <p:cNvPr id="72" name="table-text-753.9000000000001-0-0">
             <a:extLst xmlns:a="http://schemas.openxmlformats.org/drawingml/2006/main">
               <a:ext uri="{FF2B5EF4-FFF2-40B4-BE49-F238E27FC236}">
-                <a16:creationId xmlns:a16="http://schemas.microsoft.com/office/drawing/2014/main" id="{DE5BABE6-F2B5-4CFD-B9A0-2F17A72AE66D}"/>
+                <a16:creationId xmlns:a16="http://schemas.microsoft.com/office/drawing/2014/main" id="{3E0FC0A3-BD3A-4200-9DDC-9EF0D0EA1A70}"/>
               </a:ext>
             </a:extLst>
           </p:cNvPr>
@@ -11466,7 +11466,7 @@
           <p:cNvPr id="73" name="table-cell-753.9000000000001-0-1">
             <a:extLst xmlns:a="http://schemas.openxmlformats.org/drawingml/2006/main">
               <a:ext uri="{FF2B5EF4-FFF2-40B4-BE49-F238E27FC236}">
-                <a16:creationId xmlns:a16="http://schemas.microsoft.com/office/drawing/2014/main" id="{BA9E8EB1-4822-4A46-827B-966B2FC04280}"/>
+                <a16:creationId xmlns:a16="http://schemas.microsoft.com/office/drawing/2014/main" id="{0A427255-A5D4-48C6-9C45-C10B50EEE131}"/>
               </a:ext>
             </a:extLst>
           </p:cNvPr>
@@ -11499,7 +11499,7 @@
           <p:cNvPr id="74" name="table-text-753.9000000000001-0-1">
             <a:extLst xmlns:a="http://schemas.openxmlformats.org/drawingml/2006/main">
               <a:ext uri="{FF2B5EF4-FFF2-40B4-BE49-F238E27FC236}">
-                <a16:creationId xmlns:a16="http://schemas.microsoft.com/office/drawing/2014/main" id="{CF7A5EC7-1BEC-483C-807C-979BC1EE3EA0}"/>
+                <a16:creationId xmlns:a16="http://schemas.microsoft.com/office/drawing/2014/main" id="{0FAF844F-223B-4A27-9541-07AEC19F6797}"/>
               </a:ext>
             </a:extLst>
           </p:cNvPr>
@@ -11561,7 +11561,7 @@
           <p:cNvPr id="75" name="table-cell-753.9000000000001-0-2">
             <a:extLst xmlns:a="http://schemas.openxmlformats.org/drawingml/2006/main">
               <a:ext uri="{FF2B5EF4-FFF2-40B4-BE49-F238E27FC236}">
-                <a16:creationId xmlns:a16="http://schemas.microsoft.com/office/drawing/2014/main" id="{F6EFEC38-8FE9-443F-9018-0F48D18CED30}"/>
+                <a16:creationId xmlns:a16="http://schemas.microsoft.com/office/drawing/2014/main" id="{4DE8F74A-6827-407C-9FF6-D0A848B2BAB6}"/>
               </a:ext>
             </a:extLst>
           </p:cNvPr>
@@ -11594,7 +11594,7 @@
           <p:cNvPr id="76" name="table-text-753.9000000000001-0-2">
             <a:extLst xmlns:a="http://schemas.openxmlformats.org/drawingml/2006/main">
               <a:ext uri="{FF2B5EF4-FFF2-40B4-BE49-F238E27FC236}">
-                <a16:creationId xmlns:a16="http://schemas.microsoft.com/office/drawing/2014/main" id="{CB1AB45A-74A7-4180-9BD9-2EB72FA6A480}"/>
+                <a16:creationId xmlns:a16="http://schemas.microsoft.com/office/drawing/2014/main" id="{0DF44210-6BE3-422D-9A2D-3CDD62535943}"/>
               </a:ext>
             </a:extLst>
           </p:cNvPr>
@@ -11656,7 +11656,7 @@
           <p:cNvPr id="77" name="table-cell-753.9000000000001-0-3">
             <a:extLst xmlns:a="http://schemas.openxmlformats.org/drawingml/2006/main">
               <a:ext uri="{FF2B5EF4-FFF2-40B4-BE49-F238E27FC236}">
-                <a16:creationId xmlns:a16="http://schemas.microsoft.com/office/drawing/2014/main" id="{DC4CE1DD-C22A-4749-B45D-A8C449A625DC}"/>
+                <a16:creationId xmlns:a16="http://schemas.microsoft.com/office/drawing/2014/main" id="{C3136655-252C-42D0-92CA-303C0028DCE1}"/>
               </a:ext>
             </a:extLst>
           </p:cNvPr>
@@ -11689,7 +11689,7 @@
           <p:cNvPr id="78" name="table-text-753.9000000000001-0-3">
             <a:extLst xmlns:a="http://schemas.openxmlformats.org/drawingml/2006/main">
               <a:ext uri="{FF2B5EF4-FFF2-40B4-BE49-F238E27FC236}">
-                <a16:creationId xmlns:a16="http://schemas.microsoft.com/office/drawing/2014/main" id="{4F69B78E-8006-4C45-9052-6BFF981D7077}"/>
+                <a16:creationId xmlns:a16="http://schemas.microsoft.com/office/drawing/2014/main" id="{5DBC041A-B433-427A-AD9F-2746AB8A57EB}"/>
               </a:ext>
             </a:extLst>
           </p:cNvPr>
@@ -11751,7 +11751,7 @@
           <p:cNvPr id="79" name="table-cell-753.9000000000001-1-0">
             <a:extLst xmlns:a="http://schemas.openxmlformats.org/drawingml/2006/main">
               <a:ext uri="{FF2B5EF4-FFF2-40B4-BE49-F238E27FC236}">
-                <a16:creationId xmlns:a16="http://schemas.microsoft.com/office/drawing/2014/main" id="{CF7CEAD8-23DE-42CE-812C-2BDD690297C8}"/>
+                <a16:creationId xmlns:a16="http://schemas.microsoft.com/office/drawing/2014/main" id="{37EC7159-2194-46F1-A0AE-91A48D8889FD}"/>
               </a:ext>
             </a:extLst>
           </p:cNvPr>
@@ -11784,7 +11784,7 @@
           <p:cNvPr id="80" name="table-text-753.9000000000001-1-0">
             <a:extLst xmlns:a="http://schemas.openxmlformats.org/drawingml/2006/main">
               <a:ext uri="{FF2B5EF4-FFF2-40B4-BE49-F238E27FC236}">
-                <a16:creationId xmlns:a16="http://schemas.microsoft.com/office/drawing/2014/main" id="{B250B2BD-A2DB-4F12-AD09-0899C8B81C22}"/>
+                <a16:creationId xmlns:a16="http://schemas.microsoft.com/office/drawing/2014/main" id="{90C5CB86-6827-4266-BDC1-396D19E13DE3}"/>
               </a:ext>
             </a:extLst>
           </p:cNvPr>
@@ -11846,7 +11846,7 @@
           <p:cNvPr id="81" name="table-cell-753.9000000000001-1-1">
             <a:extLst xmlns:a="http://schemas.openxmlformats.org/drawingml/2006/main">
               <a:ext uri="{FF2B5EF4-FFF2-40B4-BE49-F238E27FC236}">
-                <a16:creationId xmlns:a16="http://schemas.microsoft.com/office/drawing/2014/main" id="{DBA93510-F7FE-4A5F-8B22-A7AD4907A12B}"/>
+                <a16:creationId xmlns:a16="http://schemas.microsoft.com/office/drawing/2014/main" id="{FE1065A2-A8C3-486A-828A-2052CF887D22}"/>
               </a:ext>
             </a:extLst>
           </p:cNvPr>
@@ -11879,7 +11879,7 @@
           <p:cNvPr id="82" name="table-text-753.9000000000001-1-1">
             <a:extLst xmlns:a="http://schemas.openxmlformats.org/drawingml/2006/main">
               <a:ext uri="{FF2B5EF4-FFF2-40B4-BE49-F238E27FC236}">
-                <a16:creationId xmlns:a16="http://schemas.microsoft.com/office/drawing/2014/main" id="{2B62688B-3D02-4AF0-AB34-599C5572C615}"/>
+                <a16:creationId xmlns:a16="http://schemas.microsoft.com/office/drawing/2014/main" id="{0CC5A3BC-69DC-44C8-8515-9D01D853CEF9}"/>
               </a:ext>
             </a:extLst>
           </p:cNvPr>
@@ -11941,7 +11941,7 @@
           <p:cNvPr id="83" name="table-cell-753.9000000000001-1-2">
             <a:extLst xmlns:a="http://schemas.openxmlformats.org/drawingml/2006/main">
               <a:ext uri="{FF2B5EF4-FFF2-40B4-BE49-F238E27FC236}">
-                <a16:creationId xmlns:a16="http://schemas.microsoft.com/office/drawing/2014/main" id="{C2BC08F3-8E73-4FCB-8925-F23D810762B3}"/>
+                <a16:creationId xmlns:a16="http://schemas.microsoft.com/office/drawing/2014/main" id="{F1CC96E7-8CD0-4D87-B4E3-8C273F7B07B7}"/>
               </a:ext>
             </a:extLst>
           </p:cNvPr>
@@ -11974,7 +11974,7 @@
           <p:cNvPr id="84" name="table-text-753.9000000000001-1-2">
             <a:extLst xmlns:a="http://schemas.openxmlformats.org/drawingml/2006/main">
               <a:ext uri="{FF2B5EF4-FFF2-40B4-BE49-F238E27FC236}">
-                <a16:creationId xmlns:a16="http://schemas.microsoft.com/office/drawing/2014/main" id="{CCCF4C92-FF1B-4B18-B6AB-755061CEC583}"/>
+                <a16:creationId xmlns:a16="http://schemas.microsoft.com/office/drawing/2014/main" id="{04AF94A5-BA17-4850-A157-00DF9145B83A}"/>
               </a:ext>
             </a:extLst>
           </p:cNvPr>
@@ -12036,7 +12036,7 @@
           <p:cNvPr id="85" name="table-cell-753.9000000000001-1-3">
             <a:extLst xmlns:a="http://schemas.openxmlformats.org/drawingml/2006/main">
               <a:ext uri="{FF2B5EF4-FFF2-40B4-BE49-F238E27FC236}">
-                <a16:creationId xmlns:a16="http://schemas.microsoft.com/office/drawing/2014/main" id="{51137668-601A-46A9-9764-0F95D7CE20B2}"/>
+                <a16:creationId xmlns:a16="http://schemas.microsoft.com/office/drawing/2014/main" id="{6ECEB897-0A6C-49BE-886E-24A17BF00193}"/>
               </a:ext>
             </a:extLst>
           </p:cNvPr>
@@ -12069,7 +12069,7 @@
           <p:cNvPr id="86" name="table-text-753.9000000000001-1-3">
             <a:extLst xmlns:a="http://schemas.openxmlformats.org/drawingml/2006/main">
               <a:ext uri="{FF2B5EF4-FFF2-40B4-BE49-F238E27FC236}">
-                <a16:creationId xmlns:a16="http://schemas.microsoft.com/office/drawing/2014/main" id="{07EA763C-7BFD-46C2-90A8-399C3DB64E10}"/>
+                <a16:creationId xmlns:a16="http://schemas.microsoft.com/office/drawing/2014/main" id="{AF234B19-FC77-4D52-84CA-6427866394CB}"/>
               </a:ext>
             </a:extLst>
           </p:cNvPr>
@@ -12131,7 +12131,7 @@
           <p:cNvPr id="87" name="table-cell-753.9000000000001-2-0">
             <a:extLst xmlns:a="http://schemas.openxmlformats.org/drawingml/2006/main">
               <a:ext uri="{FF2B5EF4-FFF2-40B4-BE49-F238E27FC236}">
-                <a16:creationId xmlns:a16="http://schemas.microsoft.com/office/drawing/2014/main" id="{866020F5-1356-48B2-A46A-0FE67E54F15E}"/>
+                <a16:creationId xmlns:a16="http://schemas.microsoft.com/office/drawing/2014/main" id="{84E5FCB1-7A92-4CE5-AD81-FCB21ADC0E32}"/>
               </a:ext>
             </a:extLst>
           </p:cNvPr>
@@ -12164,7 +12164,7 @@
           <p:cNvPr id="88" name="table-text-753.9000000000001-2-0">
             <a:extLst xmlns:a="http://schemas.openxmlformats.org/drawingml/2006/main">
               <a:ext uri="{FF2B5EF4-FFF2-40B4-BE49-F238E27FC236}">
-                <a16:creationId xmlns:a16="http://schemas.microsoft.com/office/drawing/2014/main" id="{B64E1FEA-487F-45CC-954B-0089973DCA7B}"/>
+                <a16:creationId xmlns:a16="http://schemas.microsoft.com/office/drawing/2014/main" id="{B9A2A229-771F-4FC3-B187-6707C981CB0B}"/>
               </a:ext>
             </a:extLst>
           </p:cNvPr>
@@ -12226,7 +12226,7 @@
           <p:cNvPr id="89" name="table-cell-753.9000000000001-2-1">
             <a:extLst xmlns:a="http://schemas.openxmlformats.org/drawingml/2006/main">
               <a:ext uri="{FF2B5EF4-FFF2-40B4-BE49-F238E27FC236}">
-                <a16:creationId xmlns:a16="http://schemas.microsoft.com/office/drawing/2014/main" id="{05F029AD-9582-4075-8292-AF288AE23B36}"/>
+                <a16:creationId xmlns:a16="http://schemas.microsoft.com/office/drawing/2014/main" id="{0B09202A-B0FC-4B00-86AB-2B775A0D0BC6}"/>
               </a:ext>
             </a:extLst>
           </p:cNvPr>
@@ -12259,7 +12259,7 @@
           <p:cNvPr id="90" name="table-text-753.9000000000001-2-1">
             <a:extLst xmlns:a="http://schemas.openxmlformats.org/drawingml/2006/main">
               <a:ext uri="{FF2B5EF4-FFF2-40B4-BE49-F238E27FC236}">
-                <a16:creationId xmlns:a16="http://schemas.microsoft.com/office/drawing/2014/main" id="{BA898A4A-1D40-43AF-9582-5FB143672C6C}"/>
+                <a16:creationId xmlns:a16="http://schemas.microsoft.com/office/drawing/2014/main" id="{0B934F14-E8C0-4695-9AC8-06D209F74B7E}"/>
               </a:ext>
             </a:extLst>
           </p:cNvPr>
@@ -12321,7 +12321,7 @@
           <p:cNvPr id="91" name="table-cell-753.9000000000001-2-2">
             <a:extLst xmlns:a="http://schemas.openxmlformats.org/drawingml/2006/main">
               <a:ext uri="{FF2B5EF4-FFF2-40B4-BE49-F238E27FC236}">
-                <a16:creationId xmlns:a16="http://schemas.microsoft.com/office/drawing/2014/main" id="{F7B4F548-9562-434F-937D-FCAA165292FF}"/>
+                <a16:creationId xmlns:a16="http://schemas.microsoft.com/office/drawing/2014/main" id="{330D4BC4-D17D-4440-9669-837445197CFD}"/>
               </a:ext>
             </a:extLst>
           </p:cNvPr>
@@ -12354,7 +12354,7 @@
           <p:cNvPr id="92" name="table-text-753.9000000000001-2-2">
             <a:extLst xmlns:a="http://schemas.openxmlformats.org/drawingml/2006/main">
               <a:ext uri="{FF2B5EF4-FFF2-40B4-BE49-F238E27FC236}">
-                <a16:creationId xmlns:a16="http://schemas.microsoft.com/office/drawing/2014/main" id="{688BCF54-1BEB-488E-9849-37F830A873B0}"/>
+                <a16:creationId xmlns:a16="http://schemas.microsoft.com/office/drawing/2014/main" id="{06602160-09E4-42C2-8B15-889D5323F459}"/>
               </a:ext>
             </a:extLst>
           </p:cNvPr>
@@ -12416,7 +12416,7 @@
           <p:cNvPr id="93" name="table-cell-753.9000000000001-2-3">
             <a:extLst xmlns:a="http://schemas.openxmlformats.org/drawingml/2006/main">
               <a:ext uri="{FF2B5EF4-FFF2-40B4-BE49-F238E27FC236}">
-                <a16:creationId xmlns:a16="http://schemas.microsoft.com/office/drawing/2014/main" id="{0E0886B8-9064-41DC-984A-E33D835E16C7}"/>
+                <a16:creationId xmlns:a16="http://schemas.microsoft.com/office/drawing/2014/main" id="{E71DBAF2-67E1-4854-B6D3-5F51EA8C69FA}"/>
               </a:ext>
             </a:extLst>
           </p:cNvPr>
@@ -12449,7 +12449,7 @@
           <p:cNvPr id="94" name="table-text-753.9000000000001-2-3">
             <a:extLst xmlns:a="http://schemas.openxmlformats.org/drawingml/2006/main">
               <a:ext uri="{FF2B5EF4-FFF2-40B4-BE49-F238E27FC236}">
-                <a16:creationId xmlns:a16="http://schemas.microsoft.com/office/drawing/2014/main" id="{264F6B06-2499-4CE3-B03D-E94B59E121CB}"/>
+                <a16:creationId xmlns:a16="http://schemas.microsoft.com/office/drawing/2014/main" id="{81993435-F2E9-4DDC-87C6-87A015B0E7B5}"/>
               </a:ext>
             </a:extLst>
           </p:cNvPr>
@@ -12511,7 +12511,7 @@
           <p:cNvPr id="95" name="table-cell-753.9000000000001-3-0">
             <a:extLst xmlns:a="http://schemas.openxmlformats.org/drawingml/2006/main">
               <a:ext uri="{FF2B5EF4-FFF2-40B4-BE49-F238E27FC236}">
-                <a16:creationId xmlns:a16="http://schemas.microsoft.com/office/drawing/2014/main" id="{2BFC43AB-E38F-4FC9-A24F-57C69BFF8C42}"/>
+                <a16:creationId xmlns:a16="http://schemas.microsoft.com/office/drawing/2014/main" id="{92A3B40F-6D6B-4577-AC04-FA7BC8288934}"/>
               </a:ext>
             </a:extLst>
           </p:cNvPr>
@@ -12544,7 +12544,7 @@
           <p:cNvPr id="96" name="table-text-753.9000000000001-3-0">
             <a:extLst xmlns:a="http://schemas.openxmlformats.org/drawingml/2006/main">
               <a:ext uri="{FF2B5EF4-FFF2-40B4-BE49-F238E27FC236}">
-                <a16:creationId xmlns:a16="http://schemas.microsoft.com/office/drawing/2014/main" id="{8FCEE199-626D-4AE0-8CAF-20A39CBB8ABF}"/>
+                <a16:creationId xmlns:a16="http://schemas.microsoft.com/office/drawing/2014/main" id="{E59AC338-0312-4916-906B-02A6037996AE}"/>
               </a:ext>
             </a:extLst>
           </p:cNvPr>
@@ -12606,7 +12606,7 @@
           <p:cNvPr id="97" name="table-cell-753.9000000000001-3-1">
             <a:extLst xmlns:a="http://schemas.openxmlformats.org/drawingml/2006/main">
               <a:ext uri="{FF2B5EF4-FFF2-40B4-BE49-F238E27FC236}">
-                <a16:creationId xmlns:a16="http://schemas.microsoft.com/office/drawing/2014/main" id="{763FC5F3-ED2E-4F3E-A05D-F26E0F78A6C9}"/>
+                <a16:creationId xmlns:a16="http://schemas.microsoft.com/office/drawing/2014/main" id="{CEF952C7-2229-412A-BB9E-EED59A4EA277}"/>
               </a:ext>
             </a:extLst>
           </p:cNvPr>
@@ -12639,7 +12639,7 @@
           <p:cNvPr id="98" name="table-text-753.9000000000001-3-1">
             <a:extLst xmlns:a="http://schemas.openxmlformats.org/drawingml/2006/main">
               <a:ext uri="{FF2B5EF4-FFF2-40B4-BE49-F238E27FC236}">
-                <a16:creationId xmlns:a16="http://schemas.microsoft.com/office/drawing/2014/main" id="{312942F3-762B-47B8-BC07-31FA0043EDA1}"/>
+                <a16:creationId xmlns:a16="http://schemas.microsoft.com/office/drawing/2014/main" id="{EE7FE882-AFD0-4DB4-8A4E-55F9EEECB969}"/>
               </a:ext>
             </a:extLst>
           </p:cNvPr>
@@ -12701,7 +12701,7 @@
           <p:cNvPr id="99" name="table-cell-753.9000000000001-3-2">
             <a:extLst xmlns:a="http://schemas.openxmlformats.org/drawingml/2006/main">
               <a:ext uri="{FF2B5EF4-FFF2-40B4-BE49-F238E27FC236}">
-                <a16:creationId xmlns:a16="http://schemas.microsoft.com/office/drawing/2014/main" id="{0CDB90EB-6973-4371-BAB9-41B27CB87160}"/>
+                <a16:creationId xmlns:a16="http://schemas.microsoft.com/office/drawing/2014/main" id="{56C898D9-D4A4-4DBB-A68F-DBFC8414C8D0}"/>
               </a:ext>
             </a:extLst>
           </p:cNvPr>
@@ -12734,7 +12734,7 @@
           <p:cNvPr id="100" name="table-text-753.9000000000001-3-2">
             <a:extLst xmlns:a="http://schemas.openxmlformats.org/drawingml/2006/main">
               <a:ext uri="{FF2B5EF4-FFF2-40B4-BE49-F238E27FC236}">
-                <a16:creationId xmlns:a16="http://schemas.microsoft.com/office/drawing/2014/main" id="{144D33DA-A27D-4DF9-928A-3441D1FFB3ED}"/>
+                <a16:creationId xmlns:a16="http://schemas.microsoft.com/office/drawing/2014/main" id="{270321BC-DE7F-471C-8AD1-FA1BDF2DEB48}"/>
               </a:ext>
             </a:extLst>
           </p:cNvPr>
@@ -12759,7 +12759,7 @@
         </p:spPr>
         <p:txBody>
           <a:bodyPr xmlns:a="http://schemas.openxmlformats.org/drawingml/2006/main" lIns="0" tIns="0" rIns="0" bIns="0" anchor="t">
-            <a:normAutofit fontScale="91088"/>
+            <a:normAutofit fontScale="83858"/>
           </a:bodyPr>
           <a:lstStyle xmlns:a="http://schemas.openxmlformats.org/drawingml/2006/main"/>
           <a:p xmlns:a="http://schemas.openxmlformats.org/drawingml/2006/main">
@@ -12796,7 +12796,7 @@
           <p:cNvPr id="101" name="table-cell-753.9000000000001-3-3">
             <a:extLst xmlns:a="http://schemas.openxmlformats.org/drawingml/2006/main">
               <a:ext uri="{FF2B5EF4-FFF2-40B4-BE49-F238E27FC236}">
-                <a16:creationId xmlns:a16="http://schemas.microsoft.com/office/drawing/2014/main" id="{023F0DF0-2C93-487F-A747-C4AD7439A7E1}"/>
+                <a16:creationId xmlns:a16="http://schemas.microsoft.com/office/drawing/2014/main" id="{8CD0830A-93C8-4726-A29E-CD127A685308}"/>
               </a:ext>
             </a:extLst>
           </p:cNvPr>
@@ -12829,7 +12829,7 @@
           <p:cNvPr id="102" name="table-text-753.9000000000001-3-3">
             <a:extLst xmlns:a="http://schemas.openxmlformats.org/drawingml/2006/main">
               <a:ext uri="{FF2B5EF4-FFF2-40B4-BE49-F238E27FC236}">
-                <a16:creationId xmlns:a16="http://schemas.microsoft.com/office/drawing/2014/main" id="{B35F0859-3496-49EE-AE2F-FECE787D132B}"/>
+                <a16:creationId xmlns:a16="http://schemas.microsoft.com/office/drawing/2014/main" id="{3BC7745B-E585-4C7D-A5A6-639D1FE45350}"/>
               </a:ext>
             </a:extLst>
           </p:cNvPr>
@@ -12889,7 +12889,7 @@
     </p:spTree>
     <p:extLst>
       <p:ext uri="{BB962C8B-B14F-4D97-AF65-F5344CB8AC3E}">
-        <p14:creationId xmlns:p14="http://schemas.microsoft.com/office/powerpoint/2010/main" val="363088756"/>
+        <p14:creationId xmlns:p14="http://schemas.microsoft.com/office/powerpoint/2010/main" val="1668204854"/>
       </p:ext>
     </p:extLst>
   </p:cSld>
@@ -12920,7 +12920,7 @@
           <p:cNvPr id="6" name="running-label">
             <a:extLst xmlns:a="http://schemas.openxmlformats.org/drawingml/2006/main">
               <a:ext uri="{FF2B5EF4-FFF2-40B4-BE49-F238E27FC236}">
-                <a16:creationId xmlns:a16="http://schemas.microsoft.com/office/drawing/2014/main" id="{B7C618FE-ED01-4F2D-858A-33AF82A10E5F}"/>
+                <a16:creationId xmlns:a16="http://schemas.microsoft.com/office/drawing/2014/main" id="{AB73C19C-DDB8-4604-A5C2-6A68003657AA}"/>
               </a:ext>
             </a:extLst>
           </p:cNvPr>
@@ -12982,7 +12982,7 @@
           <p:cNvPr id="2" name="page-number">
             <a:extLst xmlns:a="http://schemas.openxmlformats.org/drawingml/2006/main">
               <a:ext uri="{FF2B5EF4-FFF2-40B4-BE49-F238E27FC236}">
-                <a16:creationId xmlns:a16="http://schemas.microsoft.com/office/drawing/2014/main" id="{22742003-40AA-4E16-8B95-9CBFEB3C7D56}"/>
+                <a16:creationId xmlns:a16="http://schemas.microsoft.com/office/drawing/2014/main" id="{37364B31-7CF1-4DD1-84FC-8246DF52B337}"/>
               </a:ext>
             </a:extLst>
           </p:cNvPr>
@@ -13044,7 +13044,7 @@
           <p:cNvPr id="3" name="header-rule">
             <a:extLst xmlns:a="http://schemas.openxmlformats.org/drawingml/2006/main">
               <a:ext uri="{FF2B5EF4-FFF2-40B4-BE49-F238E27FC236}">
-                <a16:creationId xmlns:a16="http://schemas.microsoft.com/office/drawing/2014/main" id="{5AEC1659-30F4-4C8E-A4F7-7330A7B6495D}"/>
+                <a16:creationId xmlns:a16="http://schemas.microsoft.com/office/drawing/2014/main" id="{16ADF384-98FF-4098-8108-3A13D7FA4B2D}"/>
               </a:ext>
             </a:extLst>
           </p:cNvPr>
@@ -13075,7 +13075,7 @@
           <p:cNvPr id="4" name="slide-title">
             <a:extLst xmlns:a="http://schemas.openxmlformats.org/drawingml/2006/main">
               <a:ext uri="{FF2B5EF4-FFF2-40B4-BE49-F238E27FC236}">
-                <a16:creationId xmlns:a16="http://schemas.microsoft.com/office/drawing/2014/main" id="{F649C78D-7FE5-4D94-98C0-467EBDA897BE}"/>
+                <a16:creationId xmlns:a16="http://schemas.microsoft.com/office/drawing/2014/main" id="{2A5C098A-D23E-4917-9747-E68319314FDF}"/>
               </a:ext>
             </a:extLst>
           </p:cNvPr>
@@ -13137,7 +13137,7 @@
           <p:cNvPr id="5" name="paragraph-140">
             <a:extLst xmlns:a="http://schemas.openxmlformats.org/drawingml/2006/main">
               <a:ext uri="{FF2B5EF4-FFF2-40B4-BE49-F238E27FC236}">
-                <a16:creationId xmlns:a16="http://schemas.microsoft.com/office/drawing/2014/main" id="{51C4D1DA-02C5-41A8-90E2-5608ED8239DA}"/>
+                <a16:creationId xmlns:a16="http://schemas.microsoft.com/office/drawing/2014/main" id="{5B14BA4F-145B-4008-B3B8-6E2921D7A863}"/>
               </a:ext>
             </a:extLst>
           </p:cNvPr>
@@ -13197,7 +13197,7 @@
     </p:spTree>
     <p:extLst>
       <p:ext uri="{BB962C8B-B14F-4D97-AF65-F5344CB8AC3E}">
-        <p14:creationId xmlns:p14="http://schemas.microsoft.com/office/powerpoint/2010/main" val="947339066"/>
+        <p14:creationId xmlns:p14="http://schemas.microsoft.com/office/powerpoint/2010/main" val="1776191915"/>
       </p:ext>
     </p:extLst>
   </p:cSld>
@@ -13228,7 +13228,7 @@
           <p:cNvPr id="6" name="running-label">
             <a:extLst xmlns:a="http://schemas.openxmlformats.org/drawingml/2006/main">
               <a:ext uri="{FF2B5EF4-FFF2-40B4-BE49-F238E27FC236}">
-                <a16:creationId xmlns:a16="http://schemas.microsoft.com/office/drawing/2014/main" id="{04F5C538-616E-4168-85BF-597FAC552A3F}"/>
+                <a16:creationId xmlns:a16="http://schemas.microsoft.com/office/drawing/2014/main" id="{048A30B5-5A60-4C70-ACEF-3399F75FCCD1}"/>
               </a:ext>
             </a:extLst>
           </p:cNvPr>
@@ -13290,7 +13290,7 @@
           <p:cNvPr id="2" name="page-number">
             <a:extLst xmlns:a="http://schemas.openxmlformats.org/drawingml/2006/main">
               <a:ext uri="{FF2B5EF4-FFF2-40B4-BE49-F238E27FC236}">
-                <a16:creationId xmlns:a16="http://schemas.microsoft.com/office/drawing/2014/main" id="{9A7FAFDB-F8F7-46BB-ADB2-FCE91ED3A4A4}"/>
+                <a16:creationId xmlns:a16="http://schemas.microsoft.com/office/drawing/2014/main" id="{883EFA79-2913-4921-A47E-3AB057CE1605}"/>
               </a:ext>
             </a:extLst>
           </p:cNvPr>
@@ -13352,7 +13352,7 @@
           <p:cNvPr id="3" name="header-rule">
             <a:extLst xmlns:a="http://schemas.openxmlformats.org/drawingml/2006/main">
               <a:ext uri="{FF2B5EF4-FFF2-40B4-BE49-F238E27FC236}">
-                <a16:creationId xmlns:a16="http://schemas.microsoft.com/office/drawing/2014/main" id="{352B5E76-E74F-48D8-A8C6-00651648A158}"/>
+                <a16:creationId xmlns:a16="http://schemas.microsoft.com/office/drawing/2014/main" id="{BB8C54AF-0871-4989-8160-6F4611CA29F9}"/>
               </a:ext>
             </a:extLst>
           </p:cNvPr>
@@ -13383,7 +13383,7 @@
           <p:cNvPr id="4" name="slide-title">
             <a:extLst xmlns:a="http://schemas.openxmlformats.org/drawingml/2006/main">
               <a:ext uri="{FF2B5EF4-FFF2-40B4-BE49-F238E27FC236}">
-                <a16:creationId xmlns:a16="http://schemas.microsoft.com/office/drawing/2014/main" id="{156CB328-7762-4550-96A6-30C0010DBC6A}"/>
+                <a16:creationId xmlns:a16="http://schemas.microsoft.com/office/drawing/2014/main" id="{53FA59FA-739B-4B18-9492-88ED4D4569C2}"/>
               </a:ext>
             </a:extLst>
           </p:cNvPr>
@@ -13445,7 +13445,7 @@
           <p:cNvPr id="5" name="bullets-140">
             <a:extLst xmlns:a="http://schemas.openxmlformats.org/drawingml/2006/main">
               <a:ext uri="{FF2B5EF4-FFF2-40B4-BE49-F238E27FC236}">
-                <a16:creationId xmlns:a16="http://schemas.microsoft.com/office/drawing/2014/main" id="{4A67B9BD-29A7-4063-834C-967B34BB41BB}"/>
+                <a16:creationId xmlns:a16="http://schemas.microsoft.com/office/drawing/2014/main" id="{7574D757-478C-4CF1-B04A-F072542860D1}"/>
               </a:ext>
             </a:extLst>
           </p:cNvPr>
@@ -13628,7 +13628,7 @@
     </p:spTree>
     <p:extLst>
       <p:ext uri="{BB962C8B-B14F-4D97-AF65-F5344CB8AC3E}">
-        <p14:creationId xmlns:p14="http://schemas.microsoft.com/office/powerpoint/2010/main" val="1585221862"/>
+        <p14:creationId xmlns:p14="http://schemas.microsoft.com/office/powerpoint/2010/main" val="498191405"/>
       </p:ext>
     </p:extLst>
   </p:cSld>
@@ -13659,7 +13659,7 @@
           <p:cNvPr id="7" name="running-label">
             <a:extLst xmlns:a="http://schemas.openxmlformats.org/drawingml/2006/main">
               <a:ext uri="{FF2B5EF4-FFF2-40B4-BE49-F238E27FC236}">
-                <a16:creationId xmlns:a16="http://schemas.microsoft.com/office/drawing/2014/main" id="{90D95BED-F30C-4E80-B366-457EEE6F3F21}"/>
+                <a16:creationId xmlns:a16="http://schemas.microsoft.com/office/drawing/2014/main" id="{29F07199-7853-4F10-94B0-8405849AE474}"/>
               </a:ext>
             </a:extLst>
           </p:cNvPr>
@@ -13721,7 +13721,7 @@
           <p:cNvPr id="2" name="page-number">
             <a:extLst xmlns:a="http://schemas.openxmlformats.org/drawingml/2006/main">
               <a:ext uri="{FF2B5EF4-FFF2-40B4-BE49-F238E27FC236}">
-                <a16:creationId xmlns:a16="http://schemas.microsoft.com/office/drawing/2014/main" id="{A8048762-A1A9-4F0C-878E-97F984308BAC}"/>
+                <a16:creationId xmlns:a16="http://schemas.microsoft.com/office/drawing/2014/main" id="{98D5011C-1ECF-4BB9-AF93-C3D590B2FBF8}"/>
               </a:ext>
             </a:extLst>
           </p:cNvPr>
@@ -13783,7 +13783,7 @@
           <p:cNvPr id="3" name="header-rule">
             <a:extLst xmlns:a="http://schemas.openxmlformats.org/drawingml/2006/main">
               <a:ext uri="{FF2B5EF4-FFF2-40B4-BE49-F238E27FC236}">
-                <a16:creationId xmlns:a16="http://schemas.microsoft.com/office/drawing/2014/main" id="{BCC86739-325C-4B47-A2BE-140EE7B49C34}"/>
+                <a16:creationId xmlns:a16="http://schemas.microsoft.com/office/drawing/2014/main" id="{18A3D842-5727-4579-9453-E71D3C3389E1}"/>
               </a:ext>
             </a:extLst>
           </p:cNvPr>
@@ -13814,7 +13814,7 @@
           <p:cNvPr id="4" name="slide-title">
             <a:extLst xmlns:a="http://schemas.openxmlformats.org/drawingml/2006/main">
               <a:ext uri="{FF2B5EF4-FFF2-40B4-BE49-F238E27FC236}">
-                <a16:creationId xmlns:a16="http://schemas.microsoft.com/office/drawing/2014/main" id="{F10B74DA-ED15-4F98-87C0-80360961D32D}"/>
+                <a16:creationId xmlns:a16="http://schemas.microsoft.com/office/drawing/2014/main" id="{F8CBC7E7-97D3-4392-AD6C-740C3675C47A}"/>
               </a:ext>
             </a:extLst>
           </p:cNvPr>
@@ -13876,7 +13876,7 @@
           <p:cNvPr id="5" name="bullets-140">
             <a:extLst xmlns:a="http://schemas.openxmlformats.org/drawingml/2006/main">
               <a:ext uri="{FF2B5EF4-FFF2-40B4-BE49-F238E27FC236}">
-                <a16:creationId xmlns:a16="http://schemas.microsoft.com/office/drawing/2014/main" id="{49A863FB-4052-4CC9-9E12-65700CC34222}"/>
+                <a16:creationId xmlns:a16="http://schemas.microsoft.com/office/drawing/2014/main" id="{1F615FE1-6E21-4EB4-862C-5B0D3199B86D}"/>
               </a:ext>
             </a:extLst>
           </p:cNvPr>
@@ -13888,7 +13888,7 @@
         <p:spPr>
           <a:xfrm xmlns:a="http://schemas.openxmlformats.org/drawingml/2006/main">
             <a:off x="533400" y="1333500"/>
-            <a:ext cx="6496050" cy="2037588"/>
+            <a:ext cx="6496050" cy="1805940"/>
           </a:xfrm>
           <a:prstGeom xmlns:a="http://schemas.openxmlformats.org/drawingml/2006/main" prst="rect">
             <a:avLst/>
@@ -13931,7 +13931,7 @@
                 <a:ea typeface="NanumGothic"/>
                 <a:cs typeface="NanumGothic"/>
               </a:rPr>
-              <a:t>기능 기준: main 작업 트리 / 기반 커밋 bfb7a39734cad39b458273a6bca55a5485950d7c</a:t>
+              <a:t>기능 기준: main / 배포 커밋 69744c6d3183b4933817066f80221c2f8fd69630</a:t>
             </a:r>
           </a:p>
           <a:p xmlns:a="http://schemas.openxmlformats.org/drawingml/2006/main">
@@ -14058,21 +14058,21 @@
       </p:sp>
       <p:sp>
         <p:nvSpPr>
-          <p:cNvPr id="6" name="bullets-363.91999999999996">
-            <a:extLst xmlns:a="http://schemas.openxmlformats.org/drawingml/2006/main">
-              <a:ext uri="{FF2B5EF4-FFF2-40B4-BE49-F238E27FC236}">
-                <a16:creationId xmlns:a16="http://schemas.microsoft.com/office/drawing/2014/main" id="{0361D03C-EBDB-4FD6-8A40-E9CD11906F85}"/>
-              </a:ext>
-            </a:extLst>
-          </p:cNvPr>
-          <p:cNvSpPr>
-            <a:spLocks xmlns:a="http://schemas.openxmlformats.org/drawingml/2006/main" noGrp="1"/>
-          </p:cNvSpPr>
-          <p:nvPr/>
-        </p:nvSpPr>
-        <p:spPr>
-          <a:xfrm xmlns:a="http://schemas.openxmlformats.org/drawingml/2006/main">
-            <a:off x="533400" y="3466338"/>
+          <p:cNvPr id="6" name="bullets-339.6">
+            <a:extLst xmlns:a="http://schemas.openxmlformats.org/drawingml/2006/main">
+              <a:ext uri="{FF2B5EF4-FFF2-40B4-BE49-F238E27FC236}">
+                <a16:creationId xmlns:a16="http://schemas.microsoft.com/office/drawing/2014/main" id="{97D3731D-3652-473E-B40D-F660D9899D7E}"/>
+              </a:ext>
+            </a:extLst>
+          </p:cNvPr>
+          <p:cNvSpPr>
+            <a:spLocks xmlns:a="http://schemas.openxmlformats.org/drawingml/2006/main" noGrp="1"/>
+          </p:cNvSpPr>
+          <p:nvPr/>
+        </p:nvSpPr>
+        <p:spPr>
+          <a:xfrm xmlns:a="http://schemas.openxmlformats.org/drawingml/2006/main">
+            <a:off x="533400" y="3234690"/>
             <a:ext cx="6496050" cy="653796"/>
           </a:xfrm>
           <a:prstGeom xmlns:a="http://schemas.openxmlformats.org/drawingml/2006/main" prst="rect">
@@ -14116,7 +14116,7 @@
                 <a:ea typeface="NanumGothic"/>
                 <a:cs typeface="NanumGothic"/>
               </a:rPr>
-              <a:t>배포 기록: GitHub Pages run 31315470165 (https://github.com/good5229/Property_shot/actions/runs/31315470165)</a:t>
+              <a:t>배포 기록: GitHub Pages run 31373105599 (https://github.com/good5229/Property_shot/actions/runs/31373105599)</a:t>
             </a:r>
           </a:p>
         </p:txBody>
@@ -14124,7 +14124,7 @@
     </p:spTree>
     <p:extLst>
       <p:ext uri="{BB962C8B-B14F-4D97-AF65-F5344CB8AC3E}">
-        <p14:creationId xmlns:p14="http://schemas.microsoft.com/office/powerpoint/2010/main" val="966143934"/>
+        <p14:creationId xmlns:p14="http://schemas.microsoft.com/office/powerpoint/2010/main" val="1223423864"/>
       </p:ext>
     </p:extLst>
   </p:cSld>
@@ -14155,7 +14155,7 @@
           <p:cNvPr id="6" name="running-label">
             <a:extLst xmlns:a="http://schemas.openxmlformats.org/drawingml/2006/main">
               <a:ext uri="{FF2B5EF4-FFF2-40B4-BE49-F238E27FC236}">
-                <a16:creationId xmlns:a16="http://schemas.microsoft.com/office/drawing/2014/main" id="{093C9138-EDA5-424A-BD7F-4AA96A200F4D}"/>
+                <a16:creationId xmlns:a16="http://schemas.microsoft.com/office/drawing/2014/main" id="{1BF53D55-6BA6-449B-92CD-70347B10E6FA}"/>
               </a:ext>
             </a:extLst>
           </p:cNvPr>
@@ -14217,7 +14217,7 @@
           <p:cNvPr id="2" name="page-number">
             <a:extLst xmlns:a="http://schemas.openxmlformats.org/drawingml/2006/main">
               <a:ext uri="{FF2B5EF4-FFF2-40B4-BE49-F238E27FC236}">
-                <a16:creationId xmlns:a16="http://schemas.microsoft.com/office/drawing/2014/main" id="{4CF4D730-652B-4F64-AA27-B0FAF3592927}"/>
+                <a16:creationId xmlns:a16="http://schemas.microsoft.com/office/drawing/2014/main" id="{71F06BCF-3E06-4623-A2AB-2784F3E5E695}"/>
               </a:ext>
             </a:extLst>
           </p:cNvPr>
@@ -14279,7 +14279,7 @@
           <p:cNvPr id="3" name="header-rule">
             <a:extLst xmlns:a="http://schemas.openxmlformats.org/drawingml/2006/main">
               <a:ext uri="{FF2B5EF4-FFF2-40B4-BE49-F238E27FC236}">
-                <a16:creationId xmlns:a16="http://schemas.microsoft.com/office/drawing/2014/main" id="{BC12432A-7997-4F43-BF33-8F873B8AC861}"/>
+                <a16:creationId xmlns:a16="http://schemas.microsoft.com/office/drawing/2014/main" id="{23BE4BF7-0791-4621-BEF9-191DDC600DAD}"/>
               </a:ext>
             </a:extLst>
           </p:cNvPr>
@@ -14310,7 +14310,7 @@
           <p:cNvPr id="4" name="slide-title">
             <a:extLst xmlns:a="http://schemas.openxmlformats.org/drawingml/2006/main">
               <a:ext uri="{FF2B5EF4-FFF2-40B4-BE49-F238E27FC236}">
-                <a16:creationId xmlns:a16="http://schemas.microsoft.com/office/drawing/2014/main" id="{9E1521C3-CF72-424E-96D4-163CDB98141D}"/>
+                <a16:creationId xmlns:a16="http://schemas.microsoft.com/office/drawing/2014/main" id="{40C2E3B1-2B1F-4E29-B707-CA035976E40D}"/>
               </a:ext>
             </a:extLst>
           </p:cNvPr>
@@ -14372,7 +14372,7 @@
           <p:cNvPr id="5" name="paragraph-140">
             <a:extLst xmlns:a="http://schemas.openxmlformats.org/drawingml/2006/main">
               <a:ext uri="{FF2B5EF4-FFF2-40B4-BE49-F238E27FC236}">
-                <a16:creationId xmlns:a16="http://schemas.microsoft.com/office/drawing/2014/main" id="{7FAD7431-D962-4709-AE4A-4938B45544C4}"/>
+                <a16:creationId xmlns:a16="http://schemas.microsoft.com/office/drawing/2014/main" id="{7DD272DC-2032-498C-96CC-B793623F0391}"/>
               </a:ext>
             </a:extLst>
           </p:cNvPr>
@@ -14424,7 +14424,7 @@
                 <a:ea typeface="NanumGothic"/>
                 <a:cs typeface="NanumGothic"/>
               </a:rPr>
-              <a:t>작성일: 2026-08-10 KST 기능 기준: main 작업 트리 / 기반 커밋 bfb7a39734cad39b458273a6bca55a5485950d7c 제출 형식: AI 활용 기술 PDF</a:t>
+              <a:t>작성일: 2026-08-10 KST 기능 기준: main / 배포 커밋 69744c6d3183b4933817066f80221c2f8fd69630 제출 형식: AI 활용 기술 PDF</a:t>
             </a:r>
           </a:p>
         </p:txBody>
@@ -14432,7 +14432,7 @@
     </p:spTree>
     <p:extLst>
       <p:ext uri="{BB962C8B-B14F-4D97-AF65-F5344CB8AC3E}">
-        <p14:creationId xmlns:p14="http://schemas.microsoft.com/office/powerpoint/2010/main" val="1583900443"/>
+        <p14:creationId xmlns:p14="http://schemas.microsoft.com/office/powerpoint/2010/main" val="678895742"/>
       </p:ext>
     </p:extLst>
   </p:cSld>
@@ -14463,7 +14463,7 @@
           <p:cNvPr id="27" name="running-label">
             <a:extLst xmlns:a="http://schemas.openxmlformats.org/drawingml/2006/main">
               <a:ext uri="{FF2B5EF4-FFF2-40B4-BE49-F238E27FC236}">
-                <a16:creationId xmlns:a16="http://schemas.microsoft.com/office/drawing/2014/main" id="{AAC80FF5-6258-4DF5-93DA-82BD44C9E503}"/>
+                <a16:creationId xmlns:a16="http://schemas.microsoft.com/office/drawing/2014/main" id="{A6A690B8-6CA7-4360-9011-0B94F4910FBB}"/>
               </a:ext>
             </a:extLst>
           </p:cNvPr>
@@ -14525,7 +14525,7 @@
           <p:cNvPr id="2" name="page-number">
             <a:extLst xmlns:a="http://schemas.openxmlformats.org/drawingml/2006/main">
               <a:ext uri="{FF2B5EF4-FFF2-40B4-BE49-F238E27FC236}">
-                <a16:creationId xmlns:a16="http://schemas.microsoft.com/office/drawing/2014/main" id="{376790C4-0C53-494A-98D6-B481F7A8AB2F}"/>
+                <a16:creationId xmlns:a16="http://schemas.microsoft.com/office/drawing/2014/main" id="{FCF47960-131A-4F5B-8128-93C9673E7B98}"/>
               </a:ext>
             </a:extLst>
           </p:cNvPr>
@@ -14587,7 +14587,7 @@
           <p:cNvPr id="3" name="header-rule">
             <a:extLst xmlns:a="http://schemas.openxmlformats.org/drawingml/2006/main">
               <a:ext uri="{FF2B5EF4-FFF2-40B4-BE49-F238E27FC236}">
-                <a16:creationId xmlns:a16="http://schemas.microsoft.com/office/drawing/2014/main" id="{4E083182-C2F6-4841-88DB-93C12D697BFC}"/>
+                <a16:creationId xmlns:a16="http://schemas.microsoft.com/office/drawing/2014/main" id="{F5DD19A9-D89F-4BF1-B1B2-C299DD4F0FF8}"/>
               </a:ext>
             </a:extLst>
           </p:cNvPr>
@@ -14618,7 +14618,7 @@
           <p:cNvPr id="4" name="slide-title">
             <a:extLst xmlns:a="http://schemas.openxmlformats.org/drawingml/2006/main">
               <a:ext uri="{FF2B5EF4-FFF2-40B4-BE49-F238E27FC236}">
-                <a16:creationId xmlns:a16="http://schemas.microsoft.com/office/drawing/2014/main" id="{9040705E-814C-47DE-A24B-D5494DD39CBB}"/>
+                <a16:creationId xmlns:a16="http://schemas.microsoft.com/office/drawing/2014/main" id="{71AAE0DA-50BA-4BA2-B54E-3D7A1A80AA1E}"/>
               </a:ext>
             </a:extLst>
           </p:cNvPr>
@@ -14680,7 +14680,7 @@
           <p:cNvPr id="5" name="paragraph-140">
             <a:extLst xmlns:a="http://schemas.openxmlformats.org/drawingml/2006/main">
               <a:ext uri="{FF2B5EF4-FFF2-40B4-BE49-F238E27FC236}">
-                <a16:creationId xmlns:a16="http://schemas.microsoft.com/office/drawing/2014/main" id="{35A6A18A-7537-494E-BA0E-83442BF35B88}"/>
+                <a16:creationId xmlns:a16="http://schemas.microsoft.com/office/drawing/2014/main" id="{6AD56050-1A5C-46EC-8F40-CF1A5A29DBF3}"/>
               </a:ext>
             </a:extLst>
           </p:cNvPr>
@@ -14742,7 +14742,7 @@
           <p:cNvPr id="6" name="table-cell-236.96-0-0">
             <a:extLst xmlns:a="http://schemas.openxmlformats.org/drawingml/2006/main">
               <a:ext uri="{FF2B5EF4-FFF2-40B4-BE49-F238E27FC236}">
-                <a16:creationId xmlns:a16="http://schemas.microsoft.com/office/drawing/2014/main" id="{99F9EC1C-3FCE-438B-B4A2-20DC7D2080ED}"/>
+                <a16:creationId xmlns:a16="http://schemas.microsoft.com/office/drawing/2014/main" id="{C01714BF-96DA-4579-93D9-5130A9657EA9}"/>
               </a:ext>
             </a:extLst>
           </p:cNvPr>
@@ -14775,7 +14775,7 @@
           <p:cNvPr id="7" name="table-text-236.96-0-0">
             <a:extLst xmlns:a="http://schemas.openxmlformats.org/drawingml/2006/main">
               <a:ext uri="{FF2B5EF4-FFF2-40B4-BE49-F238E27FC236}">
-                <a16:creationId xmlns:a16="http://schemas.microsoft.com/office/drawing/2014/main" id="{8511895B-A0EB-40E4-B132-F64E76D876E9}"/>
+                <a16:creationId xmlns:a16="http://schemas.microsoft.com/office/drawing/2014/main" id="{F68B82B5-6857-4CF2-A62A-046C0F845D27}"/>
               </a:ext>
             </a:extLst>
           </p:cNvPr>
@@ -14837,7 +14837,7 @@
           <p:cNvPr id="8" name="table-cell-236.96-0-1">
             <a:extLst xmlns:a="http://schemas.openxmlformats.org/drawingml/2006/main">
               <a:ext uri="{FF2B5EF4-FFF2-40B4-BE49-F238E27FC236}">
-                <a16:creationId xmlns:a16="http://schemas.microsoft.com/office/drawing/2014/main" id="{56463397-0ADC-46B9-9473-196EC9318442}"/>
+                <a16:creationId xmlns:a16="http://schemas.microsoft.com/office/drawing/2014/main" id="{5AEAE7DE-317E-4523-AA60-3053C2EF21F3}"/>
               </a:ext>
             </a:extLst>
           </p:cNvPr>
@@ -14870,7 +14870,7 @@
           <p:cNvPr id="9" name="table-text-236.96-0-1">
             <a:extLst xmlns:a="http://schemas.openxmlformats.org/drawingml/2006/main">
               <a:ext uri="{FF2B5EF4-FFF2-40B4-BE49-F238E27FC236}">
-                <a16:creationId xmlns:a16="http://schemas.microsoft.com/office/drawing/2014/main" id="{7F0E5D50-482B-4464-A447-3BDE81EA7C93}"/>
+                <a16:creationId xmlns:a16="http://schemas.microsoft.com/office/drawing/2014/main" id="{B3C8286D-C009-444A-9C1D-1B59F344D505}"/>
               </a:ext>
             </a:extLst>
           </p:cNvPr>
@@ -14932,7 +14932,7 @@
           <p:cNvPr id="10" name="table-cell-236.96-1-0">
             <a:extLst xmlns:a="http://schemas.openxmlformats.org/drawingml/2006/main">
               <a:ext uri="{FF2B5EF4-FFF2-40B4-BE49-F238E27FC236}">
-                <a16:creationId xmlns:a16="http://schemas.microsoft.com/office/drawing/2014/main" id="{73C4F9F0-CA80-4275-AC89-3639FF7167CC}"/>
+                <a16:creationId xmlns:a16="http://schemas.microsoft.com/office/drawing/2014/main" id="{7C553E0F-1AD4-47CF-B5AB-1CC70AF2BAB6}"/>
               </a:ext>
             </a:extLst>
           </p:cNvPr>
@@ -14965,7 +14965,7 @@
           <p:cNvPr id="11" name="table-text-236.96-1-0">
             <a:extLst xmlns:a="http://schemas.openxmlformats.org/drawingml/2006/main">
               <a:ext uri="{FF2B5EF4-FFF2-40B4-BE49-F238E27FC236}">
-                <a16:creationId xmlns:a16="http://schemas.microsoft.com/office/drawing/2014/main" id="{532E0889-24EF-4C47-AA75-7364982EB092}"/>
+                <a16:creationId xmlns:a16="http://schemas.microsoft.com/office/drawing/2014/main" id="{20193B11-8FC4-4080-9AFF-957DBB5E4031}"/>
               </a:ext>
             </a:extLst>
           </p:cNvPr>
@@ -15027,7 +15027,7 @@
           <p:cNvPr id="12" name="table-cell-236.96-1-1">
             <a:extLst xmlns:a="http://schemas.openxmlformats.org/drawingml/2006/main">
               <a:ext uri="{FF2B5EF4-FFF2-40B4-BE49-F238E27FC236}">
-                <a16:creationId xmlns:a16="http://schemas.microsoft.com/office/drawing/2014/main" id="{309C669D-F8F1-4A12-B3D8-E1614343A543}"/>
+                <a16:creationId xmlns:a16="http://schemas.microsoft.com/office/drawing/2014/main" id="{7F603093-01FD-4416-9009-1F6CAE005BD0}"/>
               </a:ext>
             </a:extLst>
           </p:cNvPr>
@@ -15060,7 +15060,7 @@
           <p:cNvPr id="13" name="table-text-236.96-1-1">
             <a:extLst xmlns:a="http://schemas.openxmlformats.org/drawingml/2006/main">
               <a:ext uri="{FF2B5EF4-FFF2-40B4-BE49-F238E27FC236}">
-                <a16:creationId xmlns:a16="http://schemas.microsoft.com/office/drawing/2014/main" id="{7A1CBF47-D5B5-467C-9C7B-6DE6A9BE7640}"/>
+                <a16:creationId xmlns:a16="http://schemas.microsoft.com/office/drawing/2014/main" id="{986F21D9-8C16-4DB1-B8A2-AE0198EE7BD1}"/>
               </a:ext>
             </a:extLst>
           </p:cNvPr>
@@ -15122,7 +15122,7 @@
           <p:cNvPr id="14" name="table-cell-236.96-2-0">
             <a:extLst xmlns:a="http://schemas.openxmlformats.org/drawingml/2006/main">
               <a:ext uri="{FF2B5EF4-FFF2-40B4-BE49-F238E27FC236}">
-                <a16:creationId xmlns:a16="http://schemas.microsoft.com/office/drawing/2014/main" id="{4FC62158-A0C6-467C-9BC3-5B395270D8D7}"/>
+                <a16:creationId xmlns:a16="http://schemas.microsoft.com/office/drawing/2014/main" id="{A48836F9-6190-46EE-B2AE-BC3C73DEC122}"/>
               </a:ext>
             </a:extLst>
           </p:cNvPr>
@@ -15155,7 +15155,7 @@
           <p:cNvPr id="15" name="table-text-236.96-2-0">
             <a:extLst xmlns:a="http://schemas.openxmlformats.org/drawingml/2006/main">
               <a:ext uri="{FF2B5EF4-FFF2-40B4-BE49-F238E27FC236}">
-                <a16:creationId xmlns:a16="http://schemas.microsoft.com/office/drawing/2014/main" id="{EFC76376-7BBF-49D1-9C2E-764E32481AD2}"/>
+                <a16:creationId xmlns:a16="http://schemas.microsoft.com/office/drawing/2014/main" id="{2E086E79-0CA2-4511-B76A-32B2567575F2}"/>
               </a:ext>
             </a:extLst>
           </p:cNvPr>
@@ -15217,7 +15217,7 @@
           <p:cNvPr id="16" name="table-cell-236.96-2-1">
             <a:extLst xmlns:a="http://schemas.openxmlformats.org/drawingml/2006/main">
               <a:ext uri="{FF2B5EF4-FFF2-40B4-BE49-F238E27FC236}">
-                <a16:creationId xmlns:a16="http://schemas.microsoft.com/office/drawing/2014/main" id="{B717871D-63B6-41CF-BBAE-D7656D5E1220}"/>
+                <a16:creationId xmlns:a16="http://schemas.microsoft.com/office/drawing/2014/main" id="{D8F66DA5-0948-4F5B-95C5-FEE9C86D6719}"/>
               </a:ext>
             </a:extLst>
           </p:cNvPr>
@@ -15250,7 +15250,7 @@
           <p:cNvPr id="17" name="table-text-236.96-2-1">
             <a:extLst xmlns:a="http://schemas.openxmlformats.org/drawingml/2006/main">
               <a:ext uri="{FF2B5EF4-FFF2-40B4-BE49-F238E27FC236}">
-                <a16:creationId xmlns:a16="http://schemas.microsoft.com/office/drawing/2014/main" id="{D7B8C60E-4EFA-4151-8E9D-E3E0E126C077}"/>
+                <a16:creationId xmlns:a16="http://schemas.microsoft.com/office/drawing/2014/main" id="{1C811738-18DD-4733-8A82-AC52EF44D942}"/>
               </a:ext>
             </a:extLst>
           </p:cNvPr>
@@ -15275,7 +15275,7 @@
         </p:spPr>
         <p:txBody>
           <a:bodyPr xmlns:a="http://schemas.openxmlformats.org/drawingml/2006/main" lIns="0" tIns="0" rIns="0" bIns="0" anchor="t">
-            <a:normAutofit fontScale="100000"/>
+            <a:normAutofit fontScale="98118"/>
           </a:bodyPr>
           <a:lstStyle xmlns:a="http://schemas.openxmlformats.org/drawingml/2006/main"/>
           <a:p xmlns:a="http://schemas.openxmlformats.org/drawingml/2006/main">
@@ -15312,7 +15312,7 @@
           <p:cNvPr id="18" name="table-cell-236.96-3-0">
             <a:extLst xmlns:a="http://schemas.openxmlformats.org/drawingml/2006/main">
               <a:ext uri="{FF2B5EF4-FFF2-40B4-BE49-F238E27FC236}">
-                <a16:creationId xmlns:a16="http://schemas.microsoft.com/office/drawing/2014/main" id="{C7E521D1-CB83-4E20-8863-1CE93217E2BA}"/>
+                <a16:creationId xmlns:a16="http://schemas.microsoft.com/office/drawing/2014/main" id="{F8173B26-11FA-47ED-8EE3-BC7FE811CB7E}"/>
               </a:ext>
             </a:extLst>
           </p:cNvPr>
@@ -15345,7 +15345,7 @@
           <p:cNvPr id="19" name="table-text-236.96-3-0">
             <a:extLst xmlns:a="http://schemas.openxmlformats.org/drawingml/2006/main">
               <a:ext uri="{FF2B5EF4-FFF2-40B4-BE49-F238E27FC236}">
-                <a16:creationId xmlns:a16="http://schemas.microsoft.com/office/drawing/2014/main" id="{6B3371C4-7705-4B7E-9837-6B0DF9394EB6}"/>
+                <a16:creationId xmlns:a16="http://schemas.microsoft.com/office/drawing/2014/main" id="{38D890BB-3697-4282-A2BC-B6C48C3C325F}"/>
               </a:ext>
             </a:extLst>
           </p:cNvPr>
@@ -15407,7 +15407,7 @@
           <p:cNvPr id="20" name="table-cell-236.96-3-1">
             <a:extLst xmlns:a="http://schemas.openxmlformats.org/drawingml/2006/main">
               <a:ext uri="{FF2B5EF4-FFF2-40B4-BE49-F238E27FC236}">
-                <a16:creationId xmlns:a16="http://schemas.microsoft.com/office/drawing/2014/main" id="{5FA8E8CF-0F3A-401B-8F68-BDDB72C32EE6}"/>
+                <a16:creationId xmlns:a16="http://schemas.microsoft.com/office/drawing/2014/main" id="{94075722-383B-4AEE-A217-3E028ABDE1F5}"/>
               </a:ext>
             </a:extLst>
           </p:cNvPr>
@@ -15440,7 +15440,7 @@
           <p:cNvPr id="21" name="table-text-236.96-3-1">
             <a:extLst xmlns:a="http://schemas.openxmlformats.org/drawingml/2006/main">
               <a:ext uri="{FF2B5EF4-FFF2-40B4-BE49-F238E27FC236}">
-                <a16:creationId xmlns:a16="http://schemas.microsoft.com/office/drawing/2014/main" id="{DB850C5A-9224-4857-AC9B-8174B1B696A8}"/>
+                <a16:creationId xmlns:a16="http://schemas.microsoft.com/office/drawing/2014/main" id="{3853DAA1-916C-4E94-8B17-BB808C34FBDC}"/>
               </a:ext>
             </a:extLst>
           </p:cNvPr>
@@ -15465,7 +15465,7 @@
         </p:spPr>
         <p:txBody>
           <a:bodyPr xmlns:a="http://schemas.openxmlformats.org/drawingml/2006/main" lIns="0" tIns="0" rIns="0" bIns="0" anchor="t">
-            <a:normAutofit fontScale="91553"/>
+            <a:normAutofit fontScale="84254"/>
           </a:bodyPr>
           <a:lstStyle xmlns:a="http://schemas.openxmlformats.org/drawingml/2006/main"/>
           <a:p xmlns:a="http://schemas.openxmlformats.org/drawingml/2006/main">
@@ -15502,7 +15502,7 @@
           <p:cNvPr id="22" name="table-cell-236.96-4-0">
             <a:extLst xmlns:a="http://schemas.openxmlformats.org/drawingml/2006/main">
               <a:ext uri="{FF2B5EF4-FFF2-40B4-BE49-F238E27FC236}">
-                <a16:creationId xmlns:a16="http://schemas.microsoft.com/office/drawing/2014/main" id="{A4527BF2-10BD-4AE2-B7C5-5A777BB5885B}"/>
+                <a16:creationId xmlns:a16="http://schemas.microsoft.com/office/drawing/2014/main" id="{4B6171CC-6CEA-47D5-A49B-01EE3FE7BB99}"/>
               </a:ext>
             </a:extLst>
           </p:cNvPr>
@@ -15535,7 +15535,7 @@
           <p:cNvPr id="23" name="table-text-236.96-4-0">
             <a:extLst xmlns:a="http://schemas.openxmlformats.org/drawingml/2006/main">
               <a:ext uri="{FF2B5EF4-FFF2-40B4-BE49-F238E27FC236}">
-                <a16:creationId xmlns:a16="http://schemas.microsoft.com/office/drawing/2014/main" id="{070C01A9-D007-4C9D-AC19-DFDB720705E9}"/>
+                <a16:creationId xmlns:a16="http://schemas.microsoft.com/office/drawing/2014/main" id="{8A79084B-2551-4BB7-AA0F-02CB2090EC47}"/>
               </a:ext>
             </a:extLst>
           </p:cNvPr>
@@ -15597,7 +15597,7 @@
           <p:cNvPr id="24" name="table-cell-236.96-4-1">
             <a:extLst xmlns:a="http://schemas.openxmlformats.org/drawingml/2006/main">
               <a:ext uri="{FF2B5EF4-FFF2-40B4-BE49-F238E27FC236}">
-                <a16:creationId xmlns:a16="http://schemas.microsoft.com/office/drawing/2014/main" id="{7E353828-2BB7-48D6-81A1-0EE30C045109}"/>
+                <a16:creationId xmlns:a16="http://schemas.microsoft.com/office/drawing/2014/main" id="{DE53F44F-0F03-459C-A342-B7F86535E213}"/>
               </a:ext>
             </a:extLst>
           </p:cNvPr>
@@ -15630,7 +15630,7 @@
           <p:cNvPr id="25" name="table-text-236.96-4-1">
             <a:extLst xmlns:a="http://schemas.openxmlformats.org/drawingml/2006/main">
               <a:ext uri="{FF2B5EF4-FFF2-40B4-BE49-F238E27FC236}">
-                <a16:creationId xmlns:a16="http://schemas.microsoft.com/office/drawing/2014/main" id="{8029A724-29B5-495D-BE17-380EECA6E6AE}"/>
+                <a16:creationId xmlns:a16="http://schemas.microsoft.com/office/drawing/2014/main" id="{68432696-9B46-45C3-8CF7-1169852EA3DC}"/>
               </a:ext>
             </a:extLst>
           </p:cNvPr>
@@ -15655,7 +15655,7 @@
         </p:spPr>
         <p:txBody>
           <a:bodyPr xmlns:a="http://schemas.openxmlformats.org/drawingml/2006/main" lIns="0" tIns="0" rIns="0" bIns="0" anchor="t">
-            <a:normAutofit fontScale="88746"/>
+            <a:normAutofit fontScale="82918"/>
           </a:bodyPr>
           <a:lstStyle xmlns:a="http://schemas.openxmlformats.org/drawingml/2006/main"/>
           <a:p xmlns:a="http://schemas.openxmlformats.org/drawingml/2006/main">
@@ -15692,7 +15692,7 @@
           <p:cNvPr id="26" name="paragraph-468.96000000000004">
             <a:extLst xmlns:a="http://schemas.openxmlformats.org/drawingml/2006/main">
               <a:ext uri="{FF2B5EF4-FFF2-40B4-BE49-F238E27FC236}">
-                <a16:creationId xmlns:a16="http://schemas.microsoft.com/office/drawing/2014/main" id="{9221F352-FE06-44BC-8E04-C8C806DAF8B2}"/>
+                <a16:creationId xmlns:a16="http://schemas.microsoft.com/office/drawing/2014/main" id="{349D73CB-F58A-4792-B24A-5A38A871D28A}"/>
               </a:ext>
             </a:extLst>
           </p:cNvPr>
@@ -15752,7 +15752,7 @@
     </p:spTree>
     <p:extLst>
       <p:ext uri="{BB962C8B-B14F-4D97-AF65-F5344CB8AC3E}">
-        <p14:creationId xmlns:p14="http://schemas.microsoft.com/office/powerpoint/2010/main" val="145151818"/>
+        <p14:creationId xmlns:p14="http://schemas.microsoft.com/office/powerpoint/2010/main" val="1157352806"/>
       </p:ext>
     </p:extLst>
   </p:cSld>
@@ -15783,7 +15783,7 @@
           <p:cNvPr id="56" name="running-label">
             <a:extLst xmlns:a="http://schemas.openxmlformats.org/drawingml/2006/main">
               <a:ext uri="{FF2B5EF4-FFF2-40B4-BE49-F238E27FC236}">
-                <a16:creationId xmlns:a16="http://schemas.microsoft.com/office/drawing/2014/main" id="{1B1C9283-6BCD-489C-8654-1D645FB3B903}"/>
+                <a16:creationId xmlns:a16="http://schemas.microsoft.com/office/drawing/2014/main" id="{F3A9F2B3-D052-4F39-AA55-99CD82D8CEA8}"/>
               </a:ext>
             </a:extLst>
           </p:cNvPr>
@@ -15845,7 +15845,7 @@
           <p:cNvPr id="2" name="page-number">
             <a:extLst xmlns:a="http://schemas.openxmlformats.org/drawingml/2006/main">
               <a:ext uri="{FF2B5EF4-FFF2-40B4-BE49-F238E27FC236}">
-                <a16:creationId xmlns:a16="http://schemas.microsoft.com/office/drawing/2014/main" id="{2F99303E-4C9B-4421-947A-0575EFDB04EF}"/>
+                <a16:creationId xmlns:a16="http://schemas.microsoft.com/office/drawing/2014/main" id="{D55A1168-A3F5-4A7F-9CA9-C44F43CC8752}"/>
               </a:ext>
             </a:extLst>
           </p:cNvPr>
@@ -15907,7 +15907,7 @@
           <p:cNvPr id="3" name="header-rule">
             <a:extLst xmlns:a="http://schemas.openxmlformats.org/drawingml/2006/main">
               <a:ext uri="{FF2B5EF4-FFF2-40B4-BE49-F238E27FC236}">
-                <a16:creationId xmlns:a16="http://schemas.microsoft.com/office/drawing/2014/main" id="{6BF54B5C-468B-4440-A0BC-65098914BF75}"/>
+                <a16:creationId xmlns:a16="http://schemas.microsoft.com/office/drawing/2014/main" id="{E62B331E-457F-41D2-A25E-F50D9992CB19}"/>
               </a:ext>
             </a:extLst>
           </p:cNvPr>
@@ -15938,7 +15938,7 @@
           <p:cNvPr id="4" name="slide-title">
             <a:extLst xmlns:a="http://schemas.openxmlformats.org/drawingml/2006/main">
               <a:ext uri="{FF2B5EF4-FFF2-40B4-BE49-F238E27FC236}">
-                <a16:creationId xmlns:a16="http://schemas.microsoft.com/office/drawing/2014/main" id="{58BE5946-7EC1-4C10-A264-EE74C5A37060}"/>
+                <a16:creationId xmlns:a16="http://schemas.microsoft.com/office/drawing/2014/main" id="{C2A42A77-CFD4-4B8D-83D6-DFF8880B102B}"/>
               </a:ext>
             </a:extLst>
           </p:cNvPr>
@@ -16000,7 +16000,7 @@
           <p:cNvPr id="5" name="table-cell-140-0-0">
             <a:extLst xmlns:a="http://schemas.openxmlformats.org/drawingml/2006/main">
               <a:ext uri="{FF2B5EF4-FFF2-40B4-BE49-F238E27FC236}">
-                <a16:creationId xmlns:a16="http://schemas.microsoft.com/office/drawing/2014/main" id="{EAF9A3E2-D567-46D7-BE61-F9FE4967A97F}"/>
+                <a16:creationId xmlns:a16="http://schemas.microsoft.com/office/drawing/2014/main" id="{5D8BD783-E581-49DC-8162-A32D6ACABD62}"/>
               </a:ext>
             </a:extLst>
           </p:cNvPr>
@@ -16033,7 +16033,7 @@
           <p:cNvPr id="6" name="table-text-140-0-0">
             <a:extLst xmlns:a="http://schemas.openxmlformats.org/drawingml/2006/main">
               <a:ext uri="{FF2B5EF4-FFF2-40B4-BE49-F238E27FC236}">
-                <a16:creationId xmlns:a16="http://schemas.microsoft.com/office/drawing/2014/main" id="{F7BD56D9-22E6-457B-95BC-34AA055A65F0}"/>
+                <a16:creationId xmlns:a16="http://schemas.microsoft.com/office/drawing/2014/main" id="{48595890-3051-4F81-9649-9E6E4E54AE3D}"/>
               </a:ext>
             </a:extLst>
           </p:cNvPr>
@@ -16095,7 +16095,7 @@
           <p:cNvPr id="7" name="table-cell-140-0-1">
             <a:extLst xmlns:a="http://schemas.openxmlformats.org/drawingml/2006/main">
               <a:ext uri="{FF2B5EF4-FFF2-40B4-BE49-F238E27FC236}">
-                <a16:creationId xmlns:a16="http://schemas.microsoft.com/office/drawing/2014/main" id="{42EF8D78-BB13-449E-8169-4744F0B5922F}"/>
+                <a16:creationId xmlns:a16="http://schemas.microsoft.com/office/drawing/2014/main" id="{D6BD31BC-2322-4D53-92F5-4F1BAD00C701}"/>
               </a:ext>
             </a:extLst>
           </p:cNvPr>
@@ -16128,7 +16128,7 @@
           <p:cNvPr id="8" name="table-text-140-0-1">
             <a:extLst xmlns:a="http://schemas.openxmlformats.org/drawingml/2006/main">
               <a:ext uri="{FF2B5EF4-FFF2-40B4-BE49-F238E27FC236}">
-                <a16:creationId xmlns:a16="http://schemas.microsoft.com/office/drawing/2014/main" id="{F2042EDC-D308-4315-89B1-82E6D19495B6}"/>
+                <a16:creationId xmlns:a16="http://schemas.microsoft.com/office/drawing/2014/main" id="{B73F4DBB-65A8-4B83-BB6B-C1C29FC193DB}"/>
               </a:ext>
             </a:extLst>
           </p:cNvPr>
@@ -16190,7 +16190,7 @@
           <p:cNvPr id="9" name="table-cell-140-0-2">
             <a:extLst xmlns:a="http://schemas.openxmlformats.org/drawingml/2006/main">
               <a:ext uri="{FF2B5EF4-FFF2-40B4-BE49-F238E27FC236}">
-                <a16:creationId xmlns:a16="http://schemas.microsoft.com/office/drawing/2014/main" id="{2E7812E7-836D-4B92-97D8-FF388757A98D}"/>
+                <a16:creationId xmlns:a16="http://schemas.microsoft.com/office/drawing/2014/main" id="{D63B34C8-7708-414C-8B8A-453696B052F9}"/>
               </a:ext>
             </a:extLst>
           </p:cNvPr>
@@ -16223,7 +16223,7 @@
           <p:cNvPr id="10" name="table-text-140-0-2">
             <a:extLst xmlns:a="http://schemas.openxmlformats.org/drawingml/2006/main">
               <a:ext uri="{FF2B5EF4-FFF2-40B4-BE49-F238E27FC236}">
-                <a16:creationId xmlns:a16="http://schemas.microsoft.com/office/drawing/2014/main" id="{C9EBFB8B-3733-4C29-8165-6C18670D2577}"/>
+                <a16:creationId xmlns:a16="http://schemas.microsoft.com/office/drawing/2014/main" id="{659D793D-1DE6-4D69-95FB-832D7F34B913}"/>
               </a:ext>
             </a:extLst>
           </p:cNvPr>
@@ -16285,7 +16285,7 @@
           <p:cNvPr id="11" name="table-cell-140-1-0">
             <a:extLst xmlns:a="http://schemas.openxmlformats.org/drawingml/2006/main">
               <a:ext uri="{FF2B5EF4-FFF2-40B4-BE49-F238E27FC236}">
-                <a16:creationId xmlns:a16="http://schemas.microsoft.com/office/drawing/2014/main" id="{0CE5EAF5-F8F2-4327-86F6-7D7564A38AB9}"/>
+                <a16:creationId xmlns:a16="http://schemas.microsoft.com/office/drawing/2014/main" id="{79B83C43-8750-46E6-9110-66A3B3987359}"/>
               </a:ext>
             </a:extLst>
           </p:cNvPr>
@@ -16318,7 +16318,7 @@
           <p:cNvPr id="12" name="table-text-140-1-0">
             <a:extLst xmlns:a="http://schemas.openxmlformats.org/drawingml/2006/main">
               <a:ext uri="{FF2B5EF4-FFF2-40B4-BE49-F238E27FC236}">
-                <a16:creationId xmlns:a16="http://schemas.microsoft.com/office/drawing/2014/main" id="{EEC6CADE-407E-4CC6-8BD2-5E2D1F99D783}"/>
+                <a16:creationId xmlns:a16="http://schemas.microsoft.com/office/drawing/2014/main" id="{2425E776-325B-42ED-9EC2-FCFDD40C14BA}"/>
               </a:ext>
             </a:extLst>
           </p:cNvPr>
@@ -16380,7 +16380,7 @@
           <p:cNvPr id="13" name="table-cell-140-1-1">
             <a:extLst xmlns:a="http://schemas.openxmlformats.org/drawingml/2006/main">
               <a:ext uri="{FF2B5EF4-FFF2-40B4-BE49-F238E27FC236}">
-                <a16:creationId xmlns:a16="http://schemas.microsoft.com/office/drawing/2014/main" id="{D79D9C29-0367-49CD-A2C4-9B138F00FBD4}"/>
+                <a16:creationId xmlns:a16="http://schemas.microsoft.com/office/drawing/2014/main" id="{8AEE6792-C6CB-40CA-A497-18B0693A871A}"/>
               </a:ext>
             </a:extLst>
           </p:cNvPr>
@@ -16413,7 +16413,7 @@
           <p:cNvPr id="14" name="table-text-140-1-1">
             <a:extLst xmlns:a="http://schemas.openxmlformats.org/drawingml/2006/main">
               <a:ext uri="{FF2B5EF4-FFF2-40B4-BE49-F238E27FC236}">
-                <a16:creationId xmlns:a16="http://schemas.microsoft.com/office/drawing/2014/main" id="{14D401EF-44E6-4409-A45D-88197BBF5397}"/>
+                <a16:creationId xmlns:a16="http://schemas.microsoft.com/office/drawing/2014/main" id="{1D490552-F719-4860-ABBD-1CC8A05381ED}"/>
               </a:ext>
             </a:extLst>
           </p:cNvPr>
@@ -16475,7 +16475,7 @@
           <p:cNvPr id="15" name="table-cell-140-1-2">
             <a:extLst xmlns:a="http://schemas.openxmlformats.org/drawingml/2006/main">
               <a:ext uri="{FF2B5EF4-FFF2-40B4-BE49-F238E27FC236}">
-                <a16:creationId xmlns:a16="http://schemas.microsoft.com/office/drawing/2014/main" id="{374409C0-1FD3-49BF-A1C6-D735B29B11A1}"/>
+                <a16:creationId xmlns:a16="http://schemas.microsoft.com/office/drawing/2014/main" id="{4D2E1664-63C0-400F-B643-EA5C38C0EAE1}"/>
               </a:ext>
             </a:extLst>
           </p:cNvPr>
@@ -16508,7 +16508,7 @@
           <p:cNvPr id="16" name="table-text-140-1-2">
             <a:extLst xmlns:a="http://schemas.openxmlformats.org/drawingml/2006/main">
               <a:ext uri="{FF2B5EF4-FFF2-40B4-BE49-F238E27FC236}">
-                <a16:creationId xmlns:a16="http://schemas.microsoft.com/office/drawing/2014/main" id="{EA9AD904-7051-46F7-AF81-DD81EE7257A6}"/>
+                <a16:creationId xmlns:a16="http://schemas.microsoft.com/office/drawing/2014/main" id="{D2DE08AC-E01E-46E4-BE23-2BF8BAEE874C}"/>
               </a:ext>
             </a:extLst>
           </p:cNvPr>
@@ -16570,7 +16570,7 @@
           <p:cNvPr id="17" name="table-cell-140-2-0">
             <a:extLst xmlns:a="http://schemas.openxmlformats.org/drawingml/2006/main">
               <a:ext uri="{FF2B5EF4-FFF2-40B4-BE49-F238E27FC236}">
-                <a16:creationId xmlns:a16="http://schemas.microsoft.com/office/drawing/2014/main" id="{63A03D0E-EB9D-4094-A8D8-8EB0DB343A83}"/>
+                <a16:creationId xmlns:a16="http://schemas.microsoft.com/office/drawing/2014/main" id="{47ACC0DF-DD11-4A38-80E2-BD6EDB7DB564}"/>
               </a:ext>
             </a:extLst>
           </p:cNvPr>
@@ -16603,7 +16603,7 @@
           <p:cNvPr id="18" name="table-text-140-2-0">
             <a:extLst xmlns:a="http://schemas.openxmlformats.org/drawingml/2006/main">
               <a:ext uri="{FF2B5EF4-FFF2-40B4-BE49-F238E27FC236}">
-                <a16:creationId xmlns:a16="http://schemas.microsoft.com/office/drawing/2014/main" id="{D2EDC48D-F12D-4094-8D10-E03CD7FF1ED5}"/>
+                <a16:creationId xmlns:a16="http://schemas.microsoft.com/office/drawing/2014/main" id="{CD93825E-863A-448F-91A2-609638DA7DE5}"/>
               </a:ext>
             </a:extLst>
           </p:cNvPr>
@@ -16665,7 +16665,7 @@
           <p:cNvPr id="19" name="table-cell-140-2-1">
             <a:extLst xmlns:a="http://schemas.openxmlformats.org/drawingml/2006/main">
               <a:ext uri="{FF2B5EF4-FFF2-40B4-BE49-F238E27FC236}">
-                <a16:creationId xmlns:a16="http://schemas.microsoft.com/office/drawing/2014/main" id="{D9E3F5DC-ADA6-422A-B509-467A263EA608}"/>
+                <a16:creationId xmlns:a16="http://schemas.microsoft.com/office/drawing/2014/main" id="{36D5CA8B-0735-4CDC-81CB-78926BCDC744}"/>
               </a:ext>
             </a:extLst>
           </p:cNvPr>
@@ -16698,7 +16698,7 @@
           <p:cNvPr id="20" name="table-text-140-2-1">
             <a:extLst xmlns:a="http://schemas.openxmlformats.org/drawingml/2006/main">
               <a:ext uri="{FF2B5EF4-FFF2-40B4-BE49-F238E27FC236}">
-                <a16:creationId xmlns:a16="http://schemas.microsoft.com/office/drawing/2014/main" id="{9357FE2E-DE5E-4817-B211-06450C41ABE0}"/>
+                <a16:creationId xmlns:a16="http://schemas.microsoft.com/office/drawing/2014/main" id="{B75780F2-58BE-4D33-8199-844CAB5488D8}"/>
               </a:ext>
             </a:extLst>
           </p:cNvPr>
@@ -16723,7 +16723,7 @@
         </p:spPr>
         <p:txBody>
           <a:bodyPr xmlns:a="http://schemas.openxmlformats.org/drawingml/2006/main" lIns="0" tIns="0" rIns="0" bIns="0" anchor="t">
-            <a:normAutofit fontScale="90161"/>
+            <a:normAutofit fontScale="87339"/>
           </a:bodyPr>
           <a:lstStyle xmlns:a="http://schemas.openxmlformats.org/drawingml/2006/main"/>
           <a:p xmlns:a="http://schemas.openxmlformats.org/drawingml/2006/main">
@@ -16760,7 +16760,7 @@
           <p:cNvPr id="21" name="table-cell-140-2-2">
             <a:extLst xmlns:a="http://schemas.openxmlformats.org/drawingml/2006/main">
               <a:ext uri="{FF2B5EF4-FFF2-40B4-BE49-F238E27FC236}">
-                <a16:creationId xmlns:a16="http://schemas.microsoft.com/office/drawing/2014/main" id="{31E414E3-23F9-474E-9B10-42F137D1CEF2}"/>
+                <a16:creationId xmlns:a16="http://schemas.microsoft.com/office/drawing/2014/main" id="{4742097C-0C53-4BCD-A547-22B8A8F332EA}"/>
               </a:ext>
             </a:extLst>
           </p:cNvPr>
@@ -16793,7 +16793,7 @@
           <p:cNvPr id="22" name="table-text-140-2-2">
             <a:extLst xmlns:a="http://schemas.openxmlformats.org/drawingml/2006/main">
               <a:ext uri="{FF2B5EF4-FFF2-40B4-BE49-F238E27FC236}">
-                <a16:creationId xmlns:a16="http://schemas.microsoft.com/office/drawing/2014/main" id="{3A878CA5-CFFC-4074-A5A5-37C442A4053F}"/>
+                <a16:creationId xmlns:a16="http://schemas.microsoft.com/office/drawing/2014/main" id="{10E8D9B2-8840-4600-A3DF-7D633F0E8CC8}"/>
               </a:ext>
             </a:extLst>
           </p:cNvPr>
@@ -16855,7 +16855,7 @@
           <p:cNvPr id="23" name="table-cell-140-3-0">
             <a:extLst xmlns:a="http://schemas.openxmlformats.org/drawingml/2006/main">
               <a:ext uri="{FF2B5EF4-FFF2-40B4-BE49-F238E27FC236}">
-                <a16:creationId xmlns:a16="http://schemas.microsoft.com/office/drawing/2014/main" id="{909B67F5-7B67-4C99-9CB8-244B8808A6FE}"/>
+                <a16:creationId xmlns:a16="http://schemas.microsoft.com/office/drawing/2014/main" id="{88648A45-0A0F-432A-A65F-B5B796835E6B}"/>
               </a:ext>
             </a:extLst>
           </p:cNvPr>
@@ -16888,7 +16888,7 @@
           <p:cNvPr id="24" name="table-text-140-3-0">
             <a:extLst xmlns:a="http://schemas.openxmlformats.org/drawingml/2006/main">
               <a:ext uri="{FF2B5EF4-FFF2-40B4-BE49-F238E27FC236}">
-                <a16:creationId xmlns:a16="http://schemas.microsoft.com/office/drawing/2014/main" id="{10BA6B9A-464B-4623-BB8A-E22FFA3EAE7C}"/>
+                <a16:creationId xmlns:a16="http://schemas.microsoft.com/office/drawing/2014/main" id="{798B711B-C28D-4257-99A7-517A0DB6336D}"/>
               </a:ext>
             </a:extLst>
           </p:cNvPr>
@@ -16950,7 +16950,7 @@
           <p:cNvPr id="25" name="table-cell-140-3-1">
             <a:extLst xmlns:a="http://schemas.openxmlformats.org/drawingml/2006/main">
               <a:ext uri="{FF2B5EF4-FFF2-40B4-BE49-F238E27FC236}">
-                <a16:creationId xmlns:a16="http://schemas.microsoft.com/office/drawing/2014/main" id="{BD09F33E-628F-4701-8C31-1DC1E109E7D9}"/>
+                <a16:creationId xmlns:a16="http://schemas.microsoft.com/office/drawing/2014/main" id="{ACA4A93E-751B-417F-BC41-94488BBB4A56}"/>
               </a:ext>
             </a:extLst>
           </p:cNvPr>
@@ -16983,7 +16983,7 @@
           <p:cNvPr id="26" name="table-text-140-3-1">
             <a:extLst xmlns:a="http://schemas.openxmlformats.org/drawingml/2006/main">
               <a:ext uri="{FF2B5EF4-FFF2-40B4-BE49-F238E27FC236}">
-                <a16:creationId xmlns:a16="http://schemas.microsoft.com/office/drawing/2014/main" id="{A9823B3F-CE96-4A23-806A-CF95C0E40B52}"/>
+                <a16:creationId xmlns:a16="http://schemas.microsoft.com/office/drawing/2014/main" id="{965AD074-EE5A-4424-B393-19BD6A71DFAC}"/>
               </a:ext>
             </a:extLst>
           </p:cNvPr>
@@ -17045,7 +17045,7 @@
           <p:cNvPr id="27" name="table-cell-140-3-2">
             <a:extLst xmlns:a="http://schemas.openxmlformats.org/drawingml/2006/main">
               <a:ext uri="{FF2B5EF4-FFF2-40B4-BE49-F238E27FC236}">
-                <a16:creationId xmlns:a16="http://schemas.microsoft.com/office/drawing/2014/main" id="{A8AA99DD-9BED-4D0C-AE59-DC246940935C}"/>
+                <a16:creationId xmlns:a16="http://schemas.microsoft.com/office/drawing/2014/main" id="{377B0228-6DC6-4C37-870B-AAE6659E0EB0}"/>
               </a:ext>
             </a:extLst>
           </p:cNvPr>
@@ -17078,7 +17078,7 @@
           <p:cNvPr id="28" name="table-text-140-3-2">
             <a:extLst xmlns:a="http://schemas.openxmlformats.org/drawingml/2006/main">
               <a:ext uri="{FF2B5EF4-FFF2-40B4-BE49-F238E27FC236}">
-                <a16:creationId xmlns:a16="http://schemas.microsoft.com/office/drawing/2014/main" id="{9C60A644-796A-40E5-A474-C6ACAA918815}"/>
+                <a16:creationId xmlns:a16="http://schemas.microsoft.com/office/drawing/2014/main" id="{B95D1636-290D-435D-A621-AF9ED3F56D3D}"/>
               </a:ext>
             </a:extLst>
           </p:cNvPr>
@@ -17140,7 +17140,7 @@
           <p:cNvPr id="29" name="table-cell-140-4-0">
             <a:extLst xmlns:a="http://schemas.openxmlformats.org/drawingml/2006/main">
               <a:ext uri="{FF2B5EF4-FFF2-40B4-BE49-F238E27FC236}">
-                <a16:creationId xmlns:a16="http://schemas.microsoft.com/office/drawing/2014/main" id="{C811C980-0072-41E7-940A-FC2EB2BCF21C}"/>
+                <a16:creationId xmlns:a16="http://schemas.microsoft.com/office/drawing/2014/main" id="{786BCB6D-4E68-4D12-B5F7-62963150D1F0}"/>
               </a:ext>
             </a:extLst>
           </p:cNvPr>
@@ -17173,7 +17173,7 @@
           <p:cNvPr id="30" name="table-text-140-4-0">
             <a:extLst xmlns:a="http://schemas.openxmlformats.org/drawingml/2006/main">
               <a:ext uri="{FF2B5EF4-FFF2-40B4-BE49-F238E27FC236}">
-                <a16:creationId xmlns:a16="http://schemas.microsoft.com/office/drawing/2014/main" id="{F904CFF2-7A62-47D7-95A6-3615EDDDA8C5}"/>
+                <a16:creationId xmlns:a16="http://schemas.microsoft.com/office/drawing/2014/main" id="{68E9620D-A948-4F21-9CC3-793B655EEA54}"/>
               </a:ext>
             </a:extLst>
           </p:cNvPr>
@@ -17235,7 +17235,7 @@
           <p:cNvPr id="31" name="table-cell-140-4-1">
             <a:extLst xmlns:a="http://schemas.openxmlformats.org/drawingml/2006/main">
               <a:ext uri="{FF2B5EF4-FFF2-40B4-BE49-F238E27FC236}">
-                <a16:creationId xmlns:a16="http://schemas.microsoft.com/office/drawing/2014/main" id="{6070638C-92F0-48AE-8D43-D4C21FAACB01}"/>
+                <a16:creationId xmlns:a16="http://schemas.microsoft.com/office/drawing/2014/main" id="{DAB69CAD-073E-4885-8DEF-59862A304327}"/>
               </a:ext>
             </a:extLst>
           </p:cNvPr>
@@ -17268,7 +17268,7 @@
           <p:cNvPr id="32" name="table-text-140-4-1">
             <a:extLst xmlns:a="http://schemas.openxmlformats.org/drawingml/2006/main">
               <a:ext uri="{FF2B5EF4-FFF2-40B4-BE49-F238E27FC236}">
-                <a16:creationId xmlns:a16="http://schemas.microsoft.com/office/drawing/2014/main" id="{6D2BE476-4665-4172-B674-FA10E98C5782}"/>
+                <a16:creationId xmlns:a16="http://schemas.microsoft.com/office/drawing/2014/main" id="{66EED192-42E1-484B-AFFE-1A1806446C72}"/>
               </a:ext>
             </a:extLst>
           </p:cNvPr>
@@ -17330,7 +17330,7 @@
           <p:cNvPr id="33" name="table-cell-140-4-2">
             <a:extLst xmlns:a="http://schemas.openxmlformats.org/drawingml/2006/main">
               <a:ext uri="{FF2B5EF4-FFF2-40B4-BE49-F238E27FC236}">
-                <a16:creationId xmlns:a16="http://schemas.microsoft.com/office/drawing/2014/main" id="{C539DF56-8D47-419A-BC43-AA2E76A8ABC0}"/>
+                <a16:creationId xmlns:a16="http://schemas.microsoft.com/office/drawing/2014/main" id="{E5D42395-D20C-44B4-BE50-2F59A01C8A87}"/>
               </a:ext>
             </a:extLst>
           </p:cNvPr>
@@ -17363,7 +17363,7 @@
           <p:cNvPr id="34" name="table-text-140-4-2">
             <a:extLst xmlns:a="http://schemas.openxmlformats.org/drawingml/2006/main">
               <a:ext uri="{FF2B5EF4-FFF2-40B4-BE49-F238E27FC236}">
-                <a16:creationId xmlns:a16="http://schemas.microsoft.com/office/drawing/2014/main" id="{151E67DA-B862-411E-B035-1423E39EA42E}"/>
+                <a16:creationId xmlns:a16="http://schemas.microsoft.com/office/drawing/2014/main" id="{9CA7D697-BD2A-447F-B972-E5879300B11D}"/>
               </a:ext>
             </a:extLst>
           </p:cNvPr>
@@ -17425,7 +17425,7 @@
           <p:cNvPr id="35" name="table-cell-140-5-0">
             <a:extLst xmlns:a="http://schemas.openxmlformats.org/drawingml/2006/main">
               <a:ext uri="{FF2B5EF4-FFF2-40B4-BE49-F238E27FC236}">
-                <a16:creationId xmlns:a16="http://schemas.microsoft.com/office/drawing/2014/main" id="{1AB2D071-3055-4E68-B580-E9D3E3899C4C}"/>
+                <a16:creationId xmlns:a16="http://schemas.microsoft.com/office/drawing/2014/main" id="{EDEDD70C-DF89-49DD-A11D-B91D933E489C}"/>
               </a:ext>
             </a:extLst>
           </p:cNvPr>
@@ -17458,7 +17458,7 @@
           <p:cNvPr id="36" name="table-text-140-5-0">
             <a:extLst xmlns:a="http://schemas.openxmlformats.org/drawingml/2006/main">
               <a:ext uri="{FF2B5EF4-FFF2-40B4-BE49-F238E27FC236}">
-                <a16:creationId xmlns:a16="http://schemas.microsoft.com/office/drawing/2014/main" id="{95E7ED51-3AA6-4919-B3E1-0C5EFD364406}"/>
+                <a16:creationId xmlns:a16="http://schemas.microsoft.com/office/drawing/2014/main" id="{7A2469D9-A05B-4EDE-AB4E-A412A373093C}"/>
               </a:ext>
             </a:extLst>
           </p:cNvPr>
@@ -17520,7 +17520,7 @@
           <p:cNvPr id="37" name="table-cell-140-5-1">
             <a:extLst xmlns:a="http://schemas.openxmlformats.org/drawingml/2006/main">
               <a:ext uri="{FF2B5EF4-FFF2-40B4-BE49-F238E27FC236}">
-                <a16:creationId xmlns:a16="http://schemas.microsoft.com/office/drawing/2014/main" id="{DA8EFD95-F782-4C6B-8302-ED42058A7430}"/>
+                <a16:creationId xmlns:a16="http://schemas.microsoft.com/office/drawing/2014/main" id="{16944217-171C-480D-8240-B41A0EAE9EEF}"/>
               </a:ext>
             </a:extLst>
           </p:cNvPr>
@@ -17553,7 +17553,7 @@
           <p:cNvPr id="38" name="table-text-140-5-1">
             <a:extLst xmlns:a="http://schemas.openxmlformats.org/drawingml/2006/main">
               <a:ext uri="{FF2B5EF4-FFF2-40B4-BE49-F238E27FC236}">
-                <a16:creationId xmlns:a16="http://schemas.microsoft.com/office/drawing/2014/main" id="{D2B63981-F101-4795-9D41-418E9B3BC540}"/>
+                <a16:creationId xmlns:a16="http://schemas.microsoft.com/office/drawing/2014/main" id="{25EB479D-631F-4D83-8763-6B825816BDAD}"/>
               </a:ext>
             </a:extLst>
           </p:cNvPr>
@@ -17615,7 +17615,7 @@
           <p:cNvPr id="39" name="table-cell-140-5-2">
             <a:extLst xmlns:a="http://schemas.openxmlformats.org/drawingml/2006/main">
               <a:ext uri="{FF2B5EF4-FFF2-40B4-BE49-F238E27FC236}">
-                <a16:creationId xmlns:a16="http://schemas.microsoft.com/office/drawing/2014/main" id="{C55D13F8-ECE6-42BD-B814-24D60845FA26}"/>
+                <a16:creationId xmlns:a16="http://schemas.microsoft.com/office/drawing/2014/main" id="{44E2FBAA-7C22-447A-A87B-A46A4807D5B9}"/>
               </a:ext>
             </a:extLst>
           </p:cNvPr>
@@ -17648,7 +17648,7 @@
           <p:cNvPr id="40" name="table-text-140-5-2">
             <a:extLst xmlns:a="http://schemas.openxmlformats.org/drawingml/2006/main">
               <a:ext uri="{FF2B5EF4-FFF2-40B4-BE49-F238E27FC236}">
-                <a16:creationId xmlns:a16="http://schemas.microsoft.com/office/drawing/2014/main" id="{82909429-DBF0-4387-9314-B0AAED491EAB}"/>
+                <a16:creationId xmlns:a16="http://schemas.microsoft.com/office/drawing/2014/main" id="{D5999B08-DDA7-4533-80CF-EBD2A75CAF03}"/>
               </a:ext>
             </a:extLst>
           </p:cNvPr>
@@ -17710,7 +17710,7 @@
           <p:cNvPr id="41" name="table-cell-140-6-0">
             <a:extLst xmlns:a="http://schemas.openxmlformats.org/drawingml/2006/main">
               <a:ext uri="{FF2B5EF4-FFF2-40B4-BE49-F238E27FC236}">
-                <a16:creationId xmlns:a16="http://schemas.microsoft.com/office/drawing/2014/main" id="{04228BD3-3CE5-4150-B51E-90827E12FFDF}"/>
+                <a16:creationId xmlns:a16="http://schemas.microsoft.com/office/drawing/2014/main" id="{783E040C-B83B-4A9D-B4C6-5425C3D9D1A3}"/>
               </a:ext>
             </a:extLst>
           </p:cNvPr>
@@ -17743,7 +17743,7 @@
           <p:cNvPr id="42" name="table-text-140-6-0">
             <a:extLst xmlns:a="http://schemas.openxmlformats.org/drawingml/2006/main">
               <a:ext uri="{FF2B5EF4-FFF2-40B4-BE49-F238E27FC236}">
-                <a16:creationId xmlns:a16="http://schemas.microsoft.com/office/drawing/2014/main" id="{2FF64F56-6E83-4B77-A1D5-5ADBABD26342}"/>
+                <a16:creationId xmlns:a16="http://schemas.microsoft.com/office/drawing/2014/main" id="{32B3D486-D210-401F-9B66-3F0170AF69F0}"/>
               </a:ext>
             </a:extLst>
           </p:cNvPr>
@@ -17805,7 +17805,7 @@
           <p:cNvPr id="43" name="table-cell-140-6-1">
             <a:extLst xmlns:a="http://schemas.openxmlformats.org/drawingml/2006/main">
               <a:ext uri="{FF2B5EF4-FFF2-40B4-BE49-F238E27FC236}">
-                <a16:creationId xmlns:a16="http://schemas.microsoft.com/office/drawing/2014/main" id="{16781A6B-4489-404C-A4CF-FBC0C3DD958F}"/>
+                <a16:creationId xmlns:a16="http://schemas.microsoft.com/office/drawing/2014/main" id="{991A218C-FE48-4EF2-B198-AC34AA4AE0D9}"/>
               </a:ext>
             </a:extLst>
           </p:cNvPr>
@@ -17838,7 +17838,7 @@
           <p:cNvPr id="44" name="table-text-140-6-1">
             <a:extLst xmlns:a="http://schemas.openxmlformats.org/drawingml/2006/main">
               <a:ext uri="{FF2B5EF4-FFF2-40B4-BE49-F238E27FC236}">
-                <a16:creationId xmlns:a16="http://schemas.microsoft.com/office/drawing/2014/main" id="{3D4C7907-F988-478D-927D-B19657C8A72E}"/>
+                <a16:creationId xmlns:a16="http://schemas.microsoft.com/office/drawing/2014/main" id="{A0845998-65D5-4D86-B331-CD392C5A11A2}"/>
               </a:ext>
             </a:extLst>
           </p:cNvPr>
@@ -17900,7 +17900,7 @@
           <p:cNvPr id="45" name="table-cell-140-6-2">
             <a:extLst xmlns:a="http://schemas.openxmlformats.org/drawingml/2006/main">
               <a:ext uri="{FF2B5EF4-FFF2-40B4-BE49-F238E27FC236}">
-                <a16:creationId xmlns:a16="http://schemas.microsoft.com/office/drawing/2014/main" id="{2853DD45-0BE9-4657-9E8F-743D4A8CBE1C}"/>
+                <a16:creationId xmlns:a16="http://schemas.microsoft.com/office/drawing/2014/main" id="{1ADD4F38-EE7D-4EBA-A3A2-ABE527057590}"/>
               </a:ext>
             </a:extLst>
           </p:cNvPr>
@@ -17933,7 +17933,7 @@
           <p:cNvPr id="46" name="table-text-140-6-2">
             <a:extLst xmlns:a="http://schemas.openxmlformats.org/drawingml/2006/main">
               <a:ext uri="{FF2B5EF4-FFF2-40B4-BE49-F238E27FC236}">
-                <a16:creationId xmlns:a16="http://schemas.microsoft.com/office/drawing/2014/main" id="{FB6CBC5C-DA7B-4CBE-A8ED-CCF85009E1EF}"/>
+                <a16:creationId xmlns:a16="http://schemas.microsoft.com/office/drawing/2014/main" id="{545236FC-278C-4FC5-8E79-EAA9980BA0DC}"/>
               </a:ext>
             </a:extLst>
           </p:cNvPr>
@@ -17958,7 +17958,7 @@
         </p:spPr>
         <p:txBody>
           <a:bodyPr xmlns:a="http://schemas.openxmlformats.org/drawingml/2006/main" lIns="0" tIns="0" rIns="0" bIns="0" anchor="t">
-            <a:normAutofit fontScale="100000"/>
+            <a:normAutofit fontScale="98161"/>
           </a:bodyPr>
           <a:lstStyle xmlns:a="http://schemas.openxmlformats.org/drawingml/2006/main"/>
           <a:p xmlns:a="http://schemas.openxmlformats.org/drawingml/2006/main">
@@ -17995,7 +17995,7 @@
           <p:cNvPr id="47" name="table-cell-140-7-0">
             <a:extLst xmlns:a="http://schemas.openxmlformats.org/drawingml/2006/main">
               <a:ext uri="{FF2B5EF4-FFF2-40B4-BE49-F238E27FC236}">
-                <a16:creationId xmlns:a16="http://schemas.microsoft.com/office/drawing/2014/main" id="{74B085E2-FBA0-421A-B28B-E8BC2F23F10F}"/>
+                <a16:creationId xmlns:a16="http://schemas.microsoft.com/office/drawing/2014/main" id="{F950F856-6C27-4D91-9A06-8DBD0BFED425}"/>
               </a:ext>
             </a:extLst>
           </p:cNvPr>
@@ -18028,7 +18028,7 @@
           <p:cNvPr id="48" name="table-text-140-7-0">
             <a:extLst xmlns:a="http://schemas.openxmlformats.org/drawingml/2006/main">
               <a:ext uri="{FF2B5EF4-FFF2-40B4-BE49-F238E27FC236}">
-                <a16:creationId xmlns:a16="http://schemas.microsoft.com/office/drawing/2014/main" id="{9C07789E-F6A9-4C17-97CD-671CD72C41BF}"/>
+                <a16:creationId xmlns:a16="http://schemas.microsoft.com/office/drawing/2014/main" id="{67D48CAC-E294-4A01-88BA-20C43F05E206}"/>
               </a:ext>
             </a:extLst>
           </p:cNvPr>
@@ -18090,7 +18090,7 @@
           <p:cNvPr id="49" name="table-cell-140-7-1">
             <a:extLst xmlns:a="http://schemas.openxmlformats.org/drawingml/2006/main">
               <a:ext uri="{FF2B5EF4-FFF2-40B4-BE49-F238E27FC236}">
-                <a16:creationId xmlns:a16="http://schemas.microsoft.com/office/drawing/2014/main" id="{45AD2E71-9666-4036-827D-00261EFBAE6B}"/>
+                <a16:creationId xmlns:a16="http://schemas.microsoft.com/office/drawing/2014/main" id="{ADD355C7-5E0F-46F9-B7E0-90541672E10F}"/>
               </a:ext>
             </a:extLst>
           </p:cNvPr>
@@ -18123,7 +18123,7 @@
           <p:cNvPr id="50" name="table-text-140-7-1">
             <a:extLst xmlns:a="http://schemas.openxmlformats.org/drawingml/2006/main">
               <a:ext uri="{FF2B5EF4-FFF2-40B4-BE49-F238E27FC236}">
-                <a16:creationId xmlns:a16="http://schemas.microsoft.com/office/drawing/2014/main" id="{58A6A92A-5AD6-4550-91ED-9F963D0B7335}"/>
+                <a16:creationId xmlns:a16="http://schemas.microsoft.com/office/drawing/2014/main" id="{0EC7E3A2-0C78-4873-BA47-4AA7D1876A04}"/>
               </a:ext>
             </a:extLst>
           </p:cNvPr>
@@ -18185,7 +18185,7 @@
           <p:cNvPr id="51" name="table-cell-140-7-2">
             <a:extLst xmlns:a="http://schemas.openxmlformats.org/drawingml/2006/main">
               <a:ext uri="{FF2B5EF4-FFF2-40B4-BE49-F238E27FC236}">
-                <a16:creationId xmlns:a16="http://schemas.microsoft.com/office/drawing/2014/main" id="{66DD2BDD-0E59-4970-829A-6E6A02E5BAB8}"/>
+                <a16:creationId xmlns:a16="http://schemas.microsoft.com/office/drawing/2014/main" id="{5AF86B01-E396-4A33-8341-1CBBC72C27F7}"/>
               </a:ext>
             </a:extLst>
           </p:cNvPr>
@@ -18218,7 +18218,7 @@
           <p:cNvPr id="52" name="table-text-140-7-2">
             <a:extLst xmlns:a="http://schemas.openxmlformats.org/drawingml/2006/main">
               <a:ext uri="{FF2B5EF4-FFF2-40B4-BE49-F238E27FC236}">
-                <a16:creationId xmlns:a16="http://schemas.microsoft.com/office/drawing/2014/main" id="{B6DEE657-434B-43C7-869F-A2A8B6C9855E}"/>
+                <a16:creationId xmlns:a16="http://schemas.microsoft.com/office/drawing/2014/main" id="{94F61122-C719-40DA-A855-E9A71EAAFF36}"/>
               </a:ext>
             </a:extLst>
           </p:cNvPr>
@@ -18243,7 +18243,7 @@
         </p:spPr>
         <p:txBody>
           <a:bodyPr xmlns:a="http://schemas.openxmlformats.org/drawingml/2006/main" lIns="0" tIns="0" rIns="0" bIns="0" anchor="t">
-            <a:normAutofit fontScale="80489"/>
+            <a:normAutofit fontScale="77160"/>
           </a:bodyPr>
           <a:lstStyle xmlns:a="http://schemas.openxmlformats.org/drawingml/2006/main"/>
           <a:p xmlns:a="http://schemas.openxmlformats.org/drawingml/2006/main">
@@ -18280,7 +18280,7 @@
           <p:cNvPr id="53" name="subheading-599.7">
             <a:extLst xmlns:a="http://schemas.openxmlformats.org/drawingml/2006/main">
               <a:ext uri="{FF2B5EF4-FFF2-40B4-BE49-F238E27FC236}">
-                <a16:creationId xmlns:a16="http://schemas.microsoft.com/office/drawing/2014/main" id="{C1B186F3-8EAD-4DFD-8363-4B8132993F40}"/>
+                <a16:creationId xmlns:a16="http://schemas.microsoft.com/office/drawing/2014/main" id="{0B942795-212A-4DFF-A26B-BE93E1FA31F3}"/>
               </a:ext>
             </a:extLst>
           </p:cNvPr>
@@ -18342,7 +18342,7 @@
           <p:cNvPr id="54" name="bullets-653.7">
             <a:extLst xmlns:a="http://schemas.openxmlformats.org/drawingml/2006/main">
               <a:ext uri="{FF2B5EF4-FFF2-40B4-BE49-F238E27FC236}">
-                <a16:creationId xmlns:a16="http://schemas.microsoft.com/office/drawing/2014/main" id="{E2A5B197-CB38-4D28-AE03-D87E0547F9B6}"/>
+                <a16:creationId xmlns:a16="http://schemas.microsoft.com/office/drawing/2014/main" id="{D2E51869-0B88-46DF-8C92-288FDD7AD080}"/>
               </a:ext>
             </a:extLst>
           </p:cNvPr>
@@ -18527,7 +18527,7 @@
           <p:cNvPr id="55" name="bullets-853.3000000000001">
             <a:extLst xmlns:a="http://schemas.openxmlformats.org/drawingml/2006/main">
               <a:ext uri="{FF2B5EF4-FFF2-40B4-BE49-F238E27FC236}">
-                <a16:creationId xmlns:a16="http://schemas.microsoft.com/office/drawing/2014/main" id="{1395C8AB-2310-453B-B4FF-89303F80FC9F}"/>
+                <a16:creationId xmlns:a16="http://schemas.microsoft.com/office/drawing/2014/main" id="{3A4B2F4D-4B5E-48CB-B986-4C6C9CBF7EB5}"/>
               </a:ext>
             </a:extLst>
           </p:cNvPr>
@@ -18620,7 +18620,7 @@
     </p:spTree>
     <p:extLst>
       <p:ext uri="{BB962C8B-B14F-4D97-AF65-F5344CB8AC3E}">
-        <p14:creationId xmlns:p14="http://schemas.microsoft.com/office/powerpoint/2010/main" val="2005786689"/>
+        <p14:creationId xmlns:p14="http://schemas.microsoft.com/office/powerpoint/2010/main" val="1609619814"/>
       </p:ext>
     </p:extLst>
   </p:cSld>
@@ -18651,7 +18651,7 @@
           <p:cNvPr id="14" name="running-label">
             <a:extLst xmlns:a="http://schemas.openxmlformats.org/drawingml/2006/main">
               <a:ext uri="{FF2B5EF4-FFF2-40B4-BE49-F238E27FC236}">
-                <a16:creationId xmlns:a16="http://schemas.microsoft.com/office/drawing/2014/main" id="{C2A0E375-E5CD-41FD-864F-367804B6AC9A}"/>
+                <a16:creationId xmlns:a16="http://schemas.microsoft.com/office/drawing/2014/main" id="{FE9D6D1C-6421-4FE1-BB57-806FABF55425}"/>
               </a:ext>
             </a:extLst>
           </p:cNvPr>
@@ -18713,7 +18713,7 @@
           <p:cNvPr id="2" name="page-number">
             <a:extLst xmlns:a="http://schemas.openxmlformats.org/drawingml/2006/main">
               <a:ext uri="{FF2B5EF4-FFF2-40B4-BE49-F238E27FC236}">
-                <a16:creationId xmlns:a16="http://schemas.microsoft.com/office/drawing/2014/main" id="{586087C9-71BA-4E95-B863-233680082769}"/>
+                <a16:creationId xmlns:a16="http://schemas.microsoft.com/office/drawing/2014/main" id="{A296AF24-B3DA-463D-9B36-FE55CA980FB1}"/>
               </a:ext>
             </a:extLst>
           </p:cNvPr>
@@ -18775,7 +18775,7 @@
           <p:cNvPr id="3" name="header-rule">
             <a:extLst xmlns:a="http://schemas.openxmlformats.org/drawingml/2006/main">
               <a:ext uri="{FF2B5EF4-FFF2-40B4-BE49-F238E27FC236}">
-                <a16:creationId xmlns:a16="http://schemas.microsoft.com/office/drawing/2014/main" id="{9D5D5477-F3D9-4D56-93AE-F31E014CB1DE}"/>
+                <a16:creationId xmlns:a16="http://schemas.microsoft.com/office/drawing/2014/main" id="{F1902372-1401-42DF-83DE-6B58BFE9B57E}"/>
               </a:ext>
             </a:extLst>
           </p:cNvPr>
@@ -18806,7 +18806,7 @@
           <p:cNvPr id="4" name="slide-title">
             <a:extLst xmlns:a="http://schemas.openxmlformats.org/drawingml/2006/main">
               <a:ext uri="{FF2B5EF4-FFF2-40B4-BE49-F238E27FC236}">
-                <a16:creationId xmlns:a16="http://schemas.microsoft.com/office/drawing/2014/main" id="{FC2B13F6-9009-42AF-A9CE-2E1E75B771CE}"/>
+                <a16:creationId xmlns:a16="http://schemas.microsoft.com/office/drawing/2014/main" id="{FB219252-EBB8-45F0-8DEF-3143ABCD11F6}"/>
               </a:ext>
             </a:extLst>
           </p:cNvPr>
@@ -18868,7 +18868,7 @@
           <p:cNvPr id="5" name="subheading-140">
             <a:extLst xmlns:a="http://schemas.openxmlformats.org/drawingml/2006/main">
               <a:ext uri="{FF2B5EF4-FFF2-40B4-BE49-F238E27FC236}">
-                <a16:creationId xmlns:a16="http://schemas.microsoft.com/office/drawing/2014/main" id="{DEF14980-51BD-4AE2-9259-D03A07429689}"/>
+                <a16:creationId xmlns:a16="http://schemas.microsoft.com/office/drawing/2014/main" id="{613022D0-1ABA-482B-92B4-405C9DAAD22C}"/>
               </a:ext>
             </a:extLst>
           </p:cNvPr>
@@ -18930,7 +18930,7 @@
           <p:cNvPr id="6" name="paragraph-194">
             <a:extLst xmlns:a="http://schemas.openxmlformats.org/drawingml/2006/main">
               <a:ext uri="{FF2B5EF4-FFF2-40B4-BE49-F238E27FC236}">
-                <a16:creationId xmlns:a16="http://schemas.microsoft.com/office/drawing/2014/main" id="{DBBB4A54-5977-4CB3-8430-B1DEB17214B4}"/>
+                <a16:creationId xmlns:a16="http://schemas.microsoft.com/office/drawing/2014/main" id="{15979CF4-AF57-470A-AC37-A4BF7AED2B86}"/>
               </a:ext>
             </a:extLst>
           </p:cNvPr>
@@ -18992,7 +18992,7 @@
           <p:cNvPr id="7" name="paragraph-266.64">
             <a:extLst xmlns:a="http://schemas.openxmlformats.org/drawingml/2006/main">
               <a:ext uri="{FF2B5EF4-FFF2-40B4-BE49-F238E27FC236}">
-                <a16:creationId xmlns:a16="http://schemas.microsoft.com/office/drawing/2014/main" id="{989894A4-667A-4870-80A5-673063609836}"/>
+                <a16:creationId xmlns:a16="http://schemas.microsoft.com/office/drawing/2014/main" id="{84C6800F-B206-4198-89C9-7D6748064D42}"/>
               </a:ext>
             </a:extLst>
           </p:cNvPr>
@@ -19054,7 +19054,7 @@
           <p:cNvPr id="8" name="paragraph-314.96">
             <a:extLst xmlns:a="http://schemas.openxmlformats.org/drawingml/2006/main">
               <a:ext uri="{FF2B5EF4-FFF2-40B4-BE49-F238E27FC236}">
-                <a16:creationId xmlns:a16="http://schemas.microsoft.com/office/drawing/2014/main" id="{A7DD76F8-527C-4C6C-BE46-B4AC32AC4006}"/>
+                <a16:creationId xmlns:a16="http://schemas.microsoft.com/office/drawing/2014/main" id="{B6C8DF28-D811-404C-A5EB-CB986BF95A11}"/>
               </a:ext>
             </a:extLst>
           </p:cNvPr>
@@ -19116,7 +19116,7 @@
           <p:cNvPr id="9" name="paragraph-411.91999999999996">
             <a:extLst xmlns:a="http://schemas.openxmlformats.org/drawingml/2006/main">
               <a:ext uri="{FF2B5EF4-FFF2-40B4-BE49-F238E27FC236}">
-                <a16:creationId xmlns:a16="http://schemas.microsoft.com/office/drawing/2014/main" id="{C7599DB3-76B7-4316-9A60-4DBEE45E1C9C}"/>
+                <a16:creationId xmlns:a16="http://schemas.microsoft.com/office/drawing/2014/main" id="{8260732A-A1A3-4A75-B839-BDD037A89982}"/>
               </a:ext>
             </a:extLst>
           </p:cNvPr>
@@ -19178,7 +19178,7 @@
           <p:cNvPr id="10" name="subheading-484.55999999999995">
             <a:extLst xmlns:a="http://schemas.openxmlformats.org/drawingml/2006/main">
               <a:ext uri="{FF2B5EF4-FFF2-40B4-BE49-F238E27FC236}">
-                <a16:creationId xmlns:a16="http://schemas.microsoft.com/office/drawing/2014/main" id="{AE982AC3-A618-4BA6-9DEF-1CF638E613C9}"/>
+                <a16:creationId xmlns:a16="http://schemas.microsoft.com/office/drawing/2014/main" id="{33E8B60D-6825-4174-BA9F-3E8D282EB654}"/>
               </a:ext>
             </a:extLst>
           </p:cNvPr>
@@ -19240,7 +19240,7 @@
           <p:cNvPr id="11" name="paragraph-538.56">
             <a:extLst xmlns:a="http://schemas.openxmlformats.org/drawingml/2006/main">
               <a:ext uri="{FF2B5EF4-FFF2-40B4-BE49-F238E27FC236}">
-                <a16:creationId xmlns:a16="http://schemas.microsoft.com/office/drawing/2014/main" id="{B7B5D6BF-8693-45AB-BDEE-0BF4351C4FBC}"/>
+                <a16:creationId xmlns:a16="http://schemas.microsoft.com/office/drawing/2014/main" id="{C7FE5529-A7D6-4E03-B45D-7D47218361D6}"/>
               </a:ext>
             </a:extLst>
           </p:cNvPr>
@@ -19302,7 +19302,7 @@
           <p:cNvPr id="12" name="bullets-586.88">
             <a:extLst xmlns:a="http://schemas.openxmlformats.org/drawingml/2006/main">
               <a:ext uri="{FF2B5EF4-FFF2-40B4-BE49-F238E27FC236}">
-                <a16:creationId xmlns:a16="http://schemas.microsoft.com/office/drawing/2014/main" id="{6EE1C662-19D0-4DDB-91CB-98279AFF5546}"/>
+                <a16:creationId xmlns:a16="http://schemas.microsoft.com/office/drawing/2014/main" id="{CBF81919-AC86-491B-9C2E-86F7481F6101}"/>
               </a:ext>
             </a:extLst>
           </p:cNvPr>
@@ -19487,7 +19487,7 @@
           <p:cNvPr id="13" name="paragraph-835.12">
             <a:extLst xmlns:a="http://schemas.openxmlformats.org/drawingml/2006/main">
               <a:ext uri="{FF2B5EF4-FFF2-40B4-BE49-F238E27FC236}">
-                <a16:creationId xmlns:a16="http://schemas.microsoft.com/office/drawing/2014/main" id="{4649EA8C-D618-4327-ADE8-1B7B0DC2BA82}"/>
+                <a16:creationId xmlns:a16="http://schemas.microsoft.com/office/drawing/2014/main" id="{48AB01D8-764F-4846-B1FA-FB9DD58D92DA}"/>
               </a:ext>
             </a:extLst>
           </p:cNvPr>
@@ -19547,7 +19547,7 @@
     </p:spTree>
     <p:extLst>
       <p:ext uri="{BB962C8B-B14F-4D97-AF65-F5344CB8AC3E}">
-        <p14:creationId xmlns:p14="http://schemas.microsoft.com/office/powerpoint/2010/main" val="1785489961"/>
+        <p14:creationId xmlns:p14="http://schemas.microsoft.com/office/powerpoint/2010/main" val="1886035157"/>
       </p:ext>
     </p:extLst>
   </p:cSld>
@@ -19578,7 +19578,7 @@
           <p:cNvPr id="6" name="running-label">
             <a:extLst xmlns:a="http://schemas.openxmlformats.org/drawingml/2006/main">
               <a:ext uri="{FF2B5EF4-FFF2-40B4-BE49-F238E27FC236}">
-                <a16:creationId xmlns:a16="http://schemas.microsoft.com/office/drawing/2014/main" id="{21032DB8-9267-4F6C-A209-F9D0EA637910}"/>
+                <a16:creationId xmlns:a16="http://schemas.microsoft.com/office/drawing/2014/main" id="{24E658ED-D6EA-4C60-BCFC-CC9444379A6D}"/>
               </a:ext>
             </a:extLst>
           </p:cNvPr>
@@ -19640,7 +19640,7 @@
           <p:cNvPr id="2" name="page-number">
             <a:extLst xmlns:a="http://schemas.openxmlformats.org/drawingml/2006/main">
               <a:ext uri="{FF2B5EF4-FFF2-40B4-BE49-F238E27FC236}">
-                <a16:creationId xmlns:a16="http://schemas.microsoft.com/office/drawing/2014/main" id="{718AFF4A-2967-4F16-8BE1-4EA7A4571038}"/>
+                <a16:creationId xmlns:a16="http://schemas.microsoft.com/office/drawing/2014/main" id="{164EBB45-7B68-442A-BE62-AB593DAACFA9}"/>
               </a:ext>
             </a:extLst>
           </p:cNvPr>
@@ -19702,7 +19702,7 @@
           <p:cNvPr id="3" name="header-rule">
             <a:extLst xmlns:a="http://schemas.openxmlformats.org/drawingml/2006/main">
               <a:ext uri="{FF2B5EF4-FFF2-40B4-BE49-F238E27FC236}">
-                <a16:creationId xmlns:a16="http://schemas.microsoft.com/office/drawing/2014/main" id="{513A1FD8-536D-4704-8876-C64520B34626}"/>
+                <a16:creationId xmlns:a16="http://schemas.microsoft.com/office/drawing/2014/main" id="{152CAC36-E3C2-4575-B65A-DE71005BABBE}"/>
               </a:ext>
             </a:extLst>
           </p:cNvPr>
@@ -19733,7 +19733,7 @@
           <p:cNvPr id="4" name="slide-title">
             <a:extLst xmlns:a="http://schemas.openxmlformats.org/drawingml/2006/main">
               <a:ext uri="{FF2B5EF4-FFF2-40B4-BE49-F238E27FC236}">
-                <a16:creationId xmlns:a16="http://schemas.microsoft.com/office/drawing/2014/main" id="{8FB64288-1C33-4186-A27B-1315E4958526}"/>
+                <a16:creationId xmlns:a16="http://schemas.microsoft.com/office/drawing/2014/main" id="{4030EFB7-F41D-4CE8-A67E-8FBEDF8111C6}"/>
               </a:ext>
             </a:extLst>
           </p:cNvPr>
@@ -19795,7 +19795,7 @@
           <p:cNvPr id="5" name="bullets-140">
             <a:extLst xmlns:a="http://schemas.openxmlformats.org/drawingml/2006/main">
               <a:ext uri="{FF2B5EF4-FFF2-40B4-BE49-F238E27FC236}">
-                <a16:creationId xmlns:a16="http://schemas.microsoft.com/office/drawing/2014/main" id="{40D649E4-A296-41F7-89BA-5A2495FF82D6}"/>
+                <a16:creationId xmlns:a16="http://schemas.microsoft.com/office/drawing/2014/main" id="{22C174B8-DC03-4418-BDC9-9579DBC67DA7}"/>
               </a:ext>
             </a:extLst>
           </p:cNvPr>
@@ -19978,7 +19978,7 @@
     </p:spTree>
     <p:extLst>
       <p:ext uri="{BB962C8B-B14F-4D97-AF65-F5344CB8AC3E}">
-        <p14:creationId xmlns:p14="http://schemas.microsoft.com/office/powerpoint/2010/main" val="1507643527"/>
+        <p14:creationId xmlns:p14="http://schemas.microsoft.com/office/powerpoint/2010/main" val="1171390164"/>
       </p:ext>
     </p:extLst>
   </p:cSld>
@@ -20009,7 +20009,7 @@
           <p:cNvPr id="13" name="running-label">
             <a:extLst xmlns:a="http://schemas.openxmlformats.org/drawingml/2006/main">
               <a:ext uri="{FF2B5EF4-FFF2-40B4-BE49-F238E27FC236}">
-                <a16:creationId xmlns:a16="http://schemas.microsoft.com/office/drawing/2014/main" id="{FC080EF1-F850-41B3-83BC-E10FEE8F24AA}"/>
+                <a16:creationId xmlns:a16="http://schemas.microsoft.com/office/drawing/2014/main" id="{39B7D093-B820-4DF5-9A1C-3868839B954A}"/>
               </a:ext>
             </a:extLst>
           </p:cNvPr>
@@ -20071,7 +20071,7 @@
           <p:cNvPr id="2" name="page-number">
             <a:extLst xmlns:a="http://schemas.openxmlformats.org/drawingml/2006/main">
               <a:ext uri="{FF2B5EF4-FFF2-40B4-BE49-F238E27FC236}">
-                <a16:creationId xmlns:a16="http://schemas.microsoft.com/office/drawing/2014/main" id="{7730D0A1-290C-4669-BDA3-AC4372938865}"/>
+                <a16:creationId xmlns:a16="http://schemas.microsoft.com/office/drawing/2014/main" id="{6F6482F1-B05B-46D7-977E-9F15DFAB8A10}"/>
               </a:ext>
             </a:extLst>
           </p:cNvPr>
@@ -20133,7 +20133,7 @@
           <p:cNvPr id="3" name="header-rule">
             <a:extLst xmlns:a="http://schemas.openxmlformats.org/drawingml/2006/main">
               <a:ext uri="{FF2B5EF4-FFF2-40B4-BE49-F238E27FC236}">
-                <a16:creationId xmlns:a16="http://schemas.microsoft.com/office/drawing/2014/main" id="{99109EA6-C074-4AE8-BA46-2B06B91BCAAD}"/>
+                <a16:creationId xmlns:a16="http://schemas.microsoft.com/office/drawing/2014/main" id="{1E72C566-5E3C-4F11-830E-C38703C86EF7}"/>
               </a:ext>
             </a:extLst>
           </p:cNvPr>
@@ -20164,7 +20164,7 @@
           <p:cNvPr id="4" name="slide-title">
             <a:extLst xmlns:a="http://schemas.openxmlformats.org/drawingml/2006/main">
               <a:ext uri="{FF2B5EF4-FFF2-40B4-BE49-F238E27FC236}">
-                <a16:creationId xmlns:a16="http://schemas.microsoft.com/office/drawing/2014/main" id="{CC517E27-1987-4734-B869-A64942A0F60E}"/>
+                <a16:creationId xmlns:a16="http://schemas.microsoft.com/office/drawing/2014/main" id="{0545AC73-9FD6-4AE3-800E-CE5DC3288124}"/>
               </a:ext>
             </a:extLst>
           </p:cNvPr>
@@ -20226,7 +20226,7 @@
           <p:cNvPr id="5" name="subheading-140">
             <a:extLst xmlns:a="http://schemas.openxmlformats.org/drawingml/2006/main">
               <a:ext uri="{FF2B5EF4-FFF2-40B4-BE49-F238E27FC236}">
-                <a16:creationId xmlns:a16="http://schemas.microsoft.com/office/drawing/2014/main" id="{1AB7E47C-135C-499D-894C-A20B42951782}"/>
+                <a16:creationId xmlns:a16="http://schemas.microsoft.com/office/drawing/2014/main" id="{EADFF4B1-FA73-476F-B686-42E6D3DE0F05}"/>
               </a:ext>
             </a:extLst>
           </p:cNvPr>
@@ -20288,7 +20288,7 @@
           <p:cNvPr id="6" name="paragraph-194">
             <a:extLst xmlns:a="http://schemas.openxmlformats.org/drawingml/2006/main">
               <a:ext uri="{FF2B5EF4-FFF2-40B4-BE49-F238E27FC236}">
-                <a16:creationId xmlns:a16="http://schemas.microsoft.com/office/drawing/2014/main" id="{0FA4B29D-E9EE-49C9-B963-9D609AAC4982}"/>
+                <a16:creationId xmlns:a16="http://schemas.microsoft.com/office/drawing/2014/main" id="{2F5D1CC3-5EEF-40E7-9711-0388727129F7}"/>
               </a:ext>
             </a:extLst>
           </p:cNvPr>
@@ -20350,7 +20350,7 @@
           <p:cNvPr id="7" name="paragraph-315.28">
             <a:extLst xmlns:a="http://schemas.openxmlformats.org/drawingml/2006/main">
               <a:ext uri="{FF2B5EF4-FFF2-40B4-BE49-F238E27FC236}">
-                <a16:creationId xmlns:a16="http://schemas.microsoft.com/office/drawing/2014/main" id="{8E3E9DA2-D590-44A0-8162-19B2102EFAD8}"/>
+                <a16:creationId xmlns:a16="http://schemas.microsoft.com/office/drawing/2014/main" id="{82409EB8-8BCB-4C02-A65D-D74973D71FC7}"/>
               </a:ext>
             </a:extLst>
           </p:cNvPr>
@@ -20416,7 +20416,7 @@
           <p:nvPr/>
         </p:nvPicPr>
         <p:blipFill>
-          <a:blip xmlns:r="http://schemas.openxmlformats.org/officeDocument/2006/relationships" xmlns:a="http://schemas.openxmlformats.org/drawingml/2006/main" r:embed="Rb274803b21ca477c"/>
+          <a:blip xmlns:r="http://schemas.openxmlformats.org/officeDocument/2006/relationships" xmlns:a="http://schemas.openxmlformats.org/drawingml/2006/main" r:embed="Re7917538b19c4a68"/>
           <a:stretch xmlns:a="http://schemas.openxmlformats.org/drawingml/2006/main"/>
         </p:blipFill>
         <p:spPr>
@@ -20436,7 +20436,7 @@
           <p:cNvPr id="9" name="image-caption-412.24">
             <a:extLst xmlns:a="http://schemas.openxmlformats.org/drawingml/2006/main">
               <a:ext uri="{FF2B5EF4-FFF2-40B4-BE49-F238E27FC236}">
-                <a16:creationId xmlns:a16="http://schemas.microsoft.com/office/drawing/2014/main" id="{7D635752-79E7-4874-B8AD-15016430917B}"/>
+                <a16:creationId xmlns:a16="http://schemas.microsoft.com/office/drawing/2014/main" id="{12BB1B89-DB48-4AA4-B237-C0E9086E6AA9}"/>
               </a:ext>
             </a:extLst>
           </p:cNvPr>
@@ -20498,7 +20498,7 @@
           <p:cNvPr id="10" name="subheading-796.24">
             <a:extLst xmlns:a="http://schemas.openxmlformats.org/drawingml/2006/main">
               <a:ext uri="{FF2B5EF4-FFF2-40B4-BE49-F238E27FC236}">
-                <a16:creationId xmlns:a16="http://schemas.microsoft.com/office/drawing/2014/main" id="{6D028675-47A6-432A-9223-BAAE9EEEAB17}"/>
+                <a16:creationId xmlns:a16="http://schemas.microsoft.com/office/drawing/2014/main" id="{A3D1F5CF-DA50-40FD-AF55-5F51AB596522}"/>
               </a:ext>
             </a:extLst>
           </p:cNvPr>
@@ -20560,7 +20560,7 @@
           <p:cNvPr id="11" name="paragraph-850.24">
             <a:extLst xmlns:a="http://schemas.openxmlformats.org/drawingml/2006/main">
               <a:ext uri="{FF2B5EF4-FFF2-40B4-BE49-F238E27FC236}">
-                <a16:creationId xmlns:a16="http://schemas.microsoft.com/office/drawing/2014/main" id="{1C38E800-122B-4F88-B406-B9A690CBCD1F}"/>
+                <a16:creationId xmlns:a16="http://schemas.microsoft.com/office/drawing/2014/main" id="{EF16C275-3179-4ED8-9430-2EF3DD88F261}"/>
               </a:ext>
             </a:extLst>
           </p:cNvPr>
@@ -20622,7 +20622,7 @@
           <p:cNvPr id="12" name="paragraph-947.2">
             <a:extLst xmlns:a="http://schemas.openxmlformats.org/drawingml/2006/main">
               <a:ext uri="{FF2B5EF4-FFF2-40B4-BE49-F238E27FC236}">
-                <a16:creationId xmlns:a16="http://schemas.microsoft.com/office/drawing/2014/main" id="{D173229D-6671-4A6C-AAF5-7F2B290DEDB3}"/>
+                <a16:creationId xmlns:a16="http://schemas.microsoft.com/office/drawing/2014/main" id="{951C5494-162A-475C-840E-B2D125DC3BAA}"/>
               </a:ext>
             </a:extLst>
           </p:cNvPr>
@@ -20682,7 +20682,7 @@
     </p:spTree>
     <p:extLst>
       <p:ext uri="{BB962C8B-B14F-4D97-AF65-F5344CB8AC3E}">
-        <p14:creationId xmlns:p14="http://schemas.microsoft.com/office/powerpoint/2010/main" val="1191695592"/>
+        <p14:creationId xmlns:p14="http://schemas.microsoft.com/office/powerpoint/2010/main" val="346398018"/>
       </p:ext>
     </p:extLst>
   </p:cSld>
@@ -20713,7 +20713,7 @@
           <p:cNvPr id="13" name="running-label">
             <a:extLst xmlns:a="http://schemas.openxmlformats.org/drawingml/2006/main">
               <a:ext uri="{FF2B5EF4-FFF2-40B4-BE49-F238E27FC236}">
-                <a16:creationId xmlns:a16="http://schemas.microsoft.com/office/drawing/2014/main" id="{DC7C895E-32B6-40A6-820D-83109FD9DEE6}"/>
+                <a16:creationId xmlns:a16="http://schemas.microsoft.com/office/drawing/2014/main" id="{9F17BF1D-B4E4-4FA4-AF93-A04ACEC3932A}"/>
               </a:ext>
             </a:extLst>
           </p:cNvPr>
@@ -20775,7 +20775,7 @@
           <p:cNvPr id="2" name="page-number">
             <a:extLst xmlns:a="http://schemas.openxmlformats.org/drawingml/2006/main">
               <a:ext uri="{FF2B5EF4-FFF2-40B4-BE49-F238E27FC236}">
-                <a16:creationId xmlns:a16="http://schemas.microsoft.com/office/drawing/2014/main" id="{E6ADD981-7E75-480E-9779-CA4C998C4504}"/>
+                <a16:creationId xmlns:a16="http://schemas.microsoft.com/office/drawing/2014/main" id="{837B50CE-F045-49B3-9013-F1A71CF81624}"/>
               </a:ext>
             </a:extLst>
           </p:cNvPr>
@@ -20837,7 +20837,7 @@
           <p:cNvPr id="3" name="header-rule">
             <a:extLst xmlns:a="http://schemas.openxmlformats.org/drawingml/2006/main">
               <a:ext uri="{FF2B5EF4-FFF2-40B4-BE49-F238E27FC236}">
-                <a16:creationId xmlns:a16="http://schemas.microsoft.com/office/drawing/2014/main" id="{50518D29-4AA5-495E-83F4-DB824B455A74}"/>
+                <a16:creationId xmlns:a16="http://schemas.microsoft.com/office/drawing/2014/main" id="{751894BC-DAFB-41CE-AB84-0F18E2458748}"/>
               </a:ext>
             </a:extLst>
           </p:cNvPr>
@@ -20868,7 +20868,7 @@
           <p:cNvPr id="4" name="slide-title">
             <a:extLst xmlns:a="http://schemas.openxmlformats.org/drawingml/2006/main">
               <a:ext uri="{FF2B5EF4-FFF2-40B4-BE49-F238E27FC236}">
-                <a16:creationId xmlns:a16="http://schemas.microsoft.com/office/drawing/2014/main" id="{D603E2FB-AD90-46FF-A6E6-B5AAFAEBD7C9}"/>
+                <a16:creationId xmlns:a16="http://schemas.microsoft.com/office/drawing/2014/main" id="{89BE02A8-0B7B-4CE7-913E-17AC9EC0D8D9}"/>
               </a:ext>
             </a:extLst>
           </p:cNvPr>
@@ -20930,7 +20930,7 @@
           <p:cNvPr id="5" name="subheading-140">
             <a:extLst xmlns:a="http://schemas.openxmlformats.org/drawingml/2006/main">
               <a:ext uri="{FF2B5EF4-FFF2-40B4-BE49-F238E27FC236}">
-                <a16:creationId xmlns:a16="http://schemas.microsoft.com/office/drawing/2014/main" id="{C6DBF29A-BBC7-4E7B-AF67-0A334B86F761}"/>
+                <a16:creationId xmlns:a16="http://schemas.microsoft.com/office/drawing/2014/main" id="{99A77AD9-CEEA-4248-A031-FB1AF432968C}"/>
               </a:ext>
             </a:extLst>
           </p:cNvPr>
@@ -20992,7 +20992,7 @@
           <p:cNvPr id="6" name="paragraph-194">
             <a:extLst xmlns:a="http://schemas.openxmlformats.org/drawingml/2006/main">
               <a:ext uri="{FF2B5EF4-FFF2-40B4-BE49-F238E27FC236}">
-                <a16:creationId xmlns:a16="http://schemas.microsoft.com/office/drawing/2014/main" id="{C9E6CA87-AB9B-4462-91A7-8B8355A7523F}"/>
+                <a16:creationId xmlns:a16="http://schemas.microsoft.com/office/drawing/2014/main" id="{D82FD75A-5E73-4322-AF8F-7EF3999F339E}"/>
               </a:ext>
             </a:extLst>
           </p:cNvPr>
@@ -21058,7 +21058,7 @@
           <p:nvPr/>
         </p:nvPicPr>
         <p:blipFill>
-          <a:blip xmlns:r="http://schemas.openxmlformats.org/officeDocument/2006/relationships" xmlns:a="http://schemas.openxmlformats.org/drawingml/2006/main" r:embed="R337ff5bdcf434c75"/>
+          <a:blip xmlns:r="http://schemas.openxmlformats.org/officeDocument/2006/relationships" xmlns:a="http://schemas.openxmlformats.org/drawingml/2006/main" r:embed="Re118bf4ec7b548e6"/>
           <a:stretch xmlns:a="http://schemas.openxmlformats.org/drawingml/2006/main"/>
         </p:blipFill>
         <p:spPr>
@@ -21078,7 +21078,7 @@
           <p:cNvPr id="8" name="image-caption-315.28">
             <a:extLst xmlns:a="http://schemas.openxmlformats.org/drawingml/2006/main">
               <a:ext uri="{FF2B5EF4-FFF2-40B4-BE49-F238E27FC236}">
-                <a16:creationId xmlns:a16="http://schemas.microsoft.com/office/drawing/2014/main" id="{32F3AB75-730B-4A5D-A1B8-557E07996B22}"/>
+                <a16:creationId xmlns:a16="http://schemas.microsoft.com/office/drawing/2014/main" id="{17B8C0B2-AC00-426D-86D9-6ADD12D37C31}"/>
               </a:ext>
             </a:extLst>
           </p:cNvPr>
@@ -21140,7 +21140,7 @@
           <p:cNvPr id="9" name="subheading-699.28">
             <a:extLst xmlns:a="http://schemas.openxmlformats.org/drawingml/2006/main">
               <a:ext uri="{FF2B5EF4-FFF2-40B4-BE49-F238E27FC236}">
-                <a16:creationId xmlns:a16="http://schemas.microsoft.com/office/drawing/2014/main" id="{8A9519B3-214F-4FE3-B2D7-7F78D85F6A83}"/>
+                <a16:creationId xmlns:a16="http://schemas.microsoft.com/office/drawing/2014/main" id="{8906387B-C996-4819-84B4-E9CDCAE8053B}"/>
               </a:ext>
             </a:extLst>
           </p:cNvPr>
@@ -21202,7 +21202,7 @@
           <p:cNvPr id="10" name="paragraph-753.28">
             <a:extLst xmlns:a="http://schemas.openxmlformats.org/drawingml/2006/main">
               <a:ext uri="{FF2B5EF4-FFF2-40B4-BE49-F238E27FC236}">
-                <a16:creationId xmlns:a16="http://schemas.microsoft.com/office/drawing/2014/main" id="{38FAA248-7AC4-47EC-96F8-B46B0ACF6BB9}"/>
+                <a16:creationId xmlns:a16="http://schemas.microsoft.com/office/drawing/2014/main" id="{10F499E1-DCB5-4789-B7FA-DB7C65312B2F}"/>
               </a:ext>
             </a:extLst>
           </p:cNvPr>
@@ -21264,7 +21264,7 @@
           <p:cNvPr id="11" name="paragraph-874.56">
             <a:extLst xmlns:a="http://schemas.openxmlformats.org/drawingml/2006/main">
               <a:ext uri="{FF2B5EF4-FFF2-40B4-BE49-F238E27FC236}">
-                <a16:creationId xmlns:a16="http://schemas.microsoft.com/office/drawing/2014/main" id="{385D4343-6254-4708-90EE-AAAEE2010049}"/>
+                <a16:creationId xmlns:a16="http://schemas.microsoft.com/office/drawing/2014/main" id="{E050A665-673B-4A80-BB48-70C7230D4095}"/>
               </a:ext>
             </a:extLst>
           </p:cNvPr>
@@ -21326,7 +21326,7 @@
           <p:cNvPr id="12" name="subheading-947.1999999999999">
             <a:extLst xmlns:a="http://schemas.openxmlformats.org/drawingml/2006/main">
               <a:ext uri="{FF2B5EF4-FFF2-40B4-BE49-F238E27FC236}">
-                <a16:creationId xmlns:a16="http://schemas.microsoft.com/office/drawing/2014/main" id="{6392D9FC-9C50-4997-BC35-00061CFDB233}"/>
+                <a16:creationId xmlns:a16="http://schemas.microsoft.com/office/drawing/2014/main" id="{33A4CF49-1566-432E-A245-48F17E1D6D09}"/>
               </a:ext>
             </a:extLst>
           </p:cNvPr>
@@ -21386,7 +21386,7 @@
     </p:spTree>
     <p:extLst>
       <p:ext uri="{BB962C8B-B14F-4D97-AF65-F5344CB8AC3E}">
-        <p14:creationId xmlns:p14="http://schemas.microsoft.com/office/powerpoint/2010/main" val="858363227"/>
+        <p14:creationId xmlns:p14="http://schemas.microsoft.com/office/powerpoint/2010/main" val="970439632"/>
       </p:ext>
     </p:extLst>
   </p:cSld>
@@ -21417,7 +21417,7 @@
           <p:cNvPr id="10" name="running-label">
             <a:extLst xmlns:a="http://schemas.openxmlformats.org/drawingml/2006/main">
               <a:ext uri="{FF2B5EF4-FFF2-40B4-BE49-F238E27FC236}">
-                <a16:creationId xmlns:a16="http://schemas.microsoft.com/office/drawing/2014/main" id="{DD9C2566-6127-49DE-9B8F-69AC3F4CA294}"/>
+                <a16:creationId xmlns:a16="http://schemas.microsoft.com/office/drawing/2014/main" id="{0736910B-EC06-482B-A2E6-37B779B7A96D}"/>
               </a:ext>
             </a:extLst>
           </p:cNvPr>
@@ -21479,7 +21479,7 @@
           <p:cNvPr id="2" name="page-number">
             <a:extLst xmlns:a="http://schemas.openxmlformats.org/drawingml/2006/main">
               <a:ext uri="{FF2B5EF4-FFF2-40B4-BE49-F238E27FC236}">
-                <a16:creationId xmlns:a16="http://schemas.microsoft.com/office/drawing/2014/main" id="{7668919E-AE95-4F1C-9FF1-71C2CE1E1C55}"/>
+                <a16:creationId xmlns:a16="http://schemas.microsoft.com/office/drawing/2014/main" id="{5C938536-FCB4-46B7-8FA0-B392B807F640}"/>
               </a:ext>
             </a:extLst>
           </p:cNvPr>
@@ -21541,7 +21541,7 @@
           <p:cNvPr id="3" name="header-rule">
             <a:extLst xmlns:a="http://schemas.openxmlformats.org/drawingml/2006/main">
               <a:ext uri="{FF2B5EF4-FFF2-40B4-BE49-F238E27FC236}">
-                <a16:creationId xmlns:a16="http://schemas.microsoft.com/office/drawing/2014/main" id="{207081DE-E30B-4BDC-ADA8-2A7F84E92355}"/>
+                <a16:creationId xmlns:a16="http://schemas.microsoft.com/office/drawing/2014/main" id="{C66C9058-719D-4986-ABE5-96F2F12FF9B6}"/>
               </a:ext>
             </a:extLst>
           </p:cNvPr>
@@ -21572,7 +21572,7 @@
           <p:cNvPr id="4" name="slide-title">
             <a:extLst xmlns:a="http://schemas.openxmlformats.org/drawingml/2006/main">
               <a:ext uri="{FF2B5EF4-FFF2-40B4-BE49-F238E27FC236}">
-                <a16:creationId xmlns:a16="http://schemas.microsoft.com/office/drawing/2014/main" id="{30DE78DD-93BD-4CCA-848C-FCDECC80A391}"/>
+                <a16:creationId xmlns:a16="http://schemas.microsoft.com/office/drawing/2014/main" id="{817A837E-A017-4718-A971-FE7AE7CD73CC}"/>
               </a:ext>
             </a:extLst>
           </p:cNvPr>
@@ -21634,7 +21634,7 @@
           <p:cNvPr id="5" name="paragraph-140">
             <a:extLst xmlns:a="http://schemas.openxmlformats.org/drawingml/2006/main">
               <a:ext uri="{FF2B5EF4-FFF2-40B4-BE49-F238E27FC236}">
-                <a16:creationId xmlns:a16="http://schemas.microsoft.com/office/drawing/2014/main" id="{90AD0490-D331-4D18-8B9E-749C89DC72B2}"/>
+                <a16:creationId xmlns:a16="http://schemas.microsoft.com/office/drawing/2014/main" id="{9258CD56-DB9C-4437-872A-FE65A00EA3C7}"/>
               </a:ext>
             </a:extLst>
           </p:cNvPr>
@@ -21696,7 +21696,7 @@
           <p:cNvPr id="6" name="paragraph-309.92">
             <a:extLst xmlns:a="http://schemas.openxmlformats.org/drawingml/2006/main">
               <a:ext uri="{FF2B5EF4-FFF2-40B4-BE49-F238E27FC236}">
-                <a16:creationId xmlns:a16="http://schemas.microsoft.com/office/drawing/2014/main" id="{6EDBFB50-AA12-4D60-955F-E667CE79B39D}"/>
+                <a16:creationId xmlns:a16="http://schemas.microsoft.com/office/drawing/2014/main" id="{6AE55665-B13C-4102-9D03-710F04B21DCF}"/>
               </a:ext>
             </a:extLst>
           </p:cNvPr>
@@ -21758,7 +21758,7 @@
           <p:cNvPr id="7" name="subheading-431.20000000000005">
             <a:extLst xmlns:a="http://schemas.openxmlformats.org/drawingml/2006/main">
               <a:ext uri="{FF2B5EF4-FFF2-40B4-BE49-F238E27FC236}">
-                <a16:creationId xmlns:a16="http://schemas.microsoft.com/office/drawing/2014/main" id="{40F545A7-105F-4A41-80BA-C31A7E75826E}"/>
+                <a16:creationId xmlns:a16="http://schemas.microsoft.com/office/drawing/2014/main" id="{203B3207-D5FC-46CA-80BD-64579C4DB5B7}"/>
               </a:ext>
             </a:extLst>
           </p:cNvPr>
@@ -21820,7 +21820,7 @@
           <p:cNvPr id="8" name="paragraph-485.20000000000005">
             <a:extLst xmlns:a="http://schemas.openxmlformats.org/drawingml/2006/main">
               <a:ext uri="{FF2B5EF4-FFF2-40B4-BE49-F238E27FC236}">
-                <a16:creationId xmlns:a16="http://schemas.microsoft.com/office/drawing/2014/main" id="{63B37BB0-E0BE-42CA-A989-1CC1E55EE80C}"/>
+                <a16:creationId xmlns:a16="http://schemas.microsoft.com/office/drawing/2014/main" id="{C94A53D9-AE0A-44C6-B462-A291D6A643C8}"/>
               </a:ext>
             </a:extLst>
           </p:cNvPr>
@@ -21882,7 +21882,7 @@
           <p:cNvPr id="9" name="paragraph-606.48">
             <a:extLst xmlns:a="http://schemas.openxmlformats.org/drawingml/2006/main">
               <a:ext uri="{FF2B5EF4-FFF2-40B4-BE49-F238E27FC236}">
-                <a16:creationId xmlns:a16="http://schemas.microsoft.com/office/drawing/2014/main" id="{61F58765-DDF5-4535-A125-80555109289D}"/>
+                <a16:creationId xmlns:a16="http://schemas.microsoft.com/office/drawing/2014/main" id="{14404021-6DB6-471F-9FE5-773B34D642F1}"/>
               </a:ext>
             </a:extLst>
           </p:cNvPr>
@@ -21942,7 +21942,7 @@
     </p:spTree>
     <p:extLst>
       <p:ext uri="{BB962C8B-B14F-4D97-AF65-F5344CB8AC3E}">
-        <p14:creationId xmlns:p14="http://schemas.microsoft.com/office/powerpoint/2010/main" val="992397981"/>
+        <p14:creationId xmlns:p14="http://schemas.microsoft.com/office/powerpoint/2010/main" val="985103151"/>
       </p:ext>
     </p:extLst>
   </p:cSld>

</xml_diff>